<commit_message>
Rewrite report prose in the team's voice and replace the superseded manuscript
Report: chapters rewritten in plain first-person-plural prose with the same
numbers (checked against the previous build), template metadata cleaned,
verification claims made precise (the distortion metrics have no second
implementation yet).

Manuscript: v0.3 written fresh on the seven-log real-data study, replacing the
v0.2 draft whose results came from simulated logs. Its tables are printed by
scripts/review3/make_paper_tables.py from realdata/results.

Deck: wording kept in step (draft v0.3, limits box).

Co-Authored-By: Claude Sonnet 5.5 <noreply@anthropic.com>
</commit_message>
<xml_diff>
--- a/docs/review-3/Team1_Review3_OCEL.pptx
+++ b/docs/review-3/Team1_Review3_OCEL.pptx
@@ -10758,7 +10758,7 @@
                 <a:latin typeface="Times New Roman" panose="02020603050405020304" pitchFamily="18" charset="0"/>
                 <a:cs typeface="Times New Roman" panose="02020603050405020304" pitchFamily="18" charset="0"/>
               </a:rPr>
-              <a:t>independent human labelling of the real-data findings; the converters are checked by us, not by a second team.</a:t>
+              <a:t>independent human labelling of the real-data findings; a second implementation of the distortion metrics; the converters are checked by us, not by a second team.</a:t>
             </a:r>
           </a:p>
         </p:txBody>
@@ -11799,7 +11799,7 @@
                           <a:latin typeface="Times New Roman" panose="02020603050405020304" pitchFamily="18" charset="0"/>
                           <a:cs typeface="Times New Roman" panose="02020603050405020304" pitchFamily="18" charset="0"/>
                         </a:rPr>
-                        <a:t>Manuscript in preparation (draft v0.2); not submitted; venue not yet chosen</a:t>
+                        <a:t>Manuscript in preparation (draft v0.3); not submitted; venue not yet chosen</a:t>
                       </a:r>
                     </a:p>
                   </a:txBody>

</xml_diff>

<commit_message>
Add publication package and manuscript v0.4; add distortion self-check
- Manuscript v0.4: reframe narrowing around plausible case notions
  (widest notion per log; notions covering at least half the events),
  add threshold sensitivity, explain how the seven logs were chosen,
  and make the tone more formal.
- make_paper_tables.py prints the narrowing and sensitivity counts so
  every number in the paper regenerates from realdata/results.
- docs/publication: Word/PDF manuscripts (v0.3, v0.4), cover letter
  and a submission guide; build_manuscript_docx.py builds the Word file.
- realdata/src/check_distortion.py: plain-Python re-implementation of
  the distortion metrics, run by make study on slices of three logs.
- Review 3 report and deck updated to mention the new self-check;
  CITATION.cff retitled to the flattening study.

Co-Authored-By: Claude Opus 5.5 <noreply@anthropic.com>
</commit_message>
<xml_diff>
--- a/docs/review-3/Team1_Review3_OCEL.pptx
+++ b/docs/review-3/Team1_Review3_OCEL.pptx
@@ -8715,7 +8715,7 @@
                 <a:latin typeface="Times New Roman" panose="02020603050405020304" pitchFamily="18" charset="0"/>
                 <a:cs typeface="Times New Roman" panose="02020603050405020304" pitchFamily="18" charset="0"/>
               </a:rPr>
-              <a:t>Full run: make study (5 min 11 s on our laptop)</a:t>
+              <a:t>Full run: make study (5 min 21 s on our laptop)</a:t>
             </a:r>
           </a:p>
         </p:txBody>
@@ -9515,7 +9515,7 @@
         </p:nvGraphicFramePr>
         <p:xfrm>
           <a:off x="457200" y="1371600"/>
-          <a:ext cx="11274552" cy="4032504"/>
+          <a:ext cx="11274552" cy="4059936"/>
         </p:xfrm>
         <a:graphic>
           <a:graphicData uri="http://schemas.openxmlformats.org/drawingml/2006/table">
@@ -9693,7 +9693,7 @@
                   </a:tcPr>
                 </a:tc>
               </a:tr>
-              <a:tr h="603504">
+              <a:tr h="521208">
                 <a:tc>
                   <a:txBody>
                     <a:bodyPr/>
@@ -9860,7 +9860,7 @@
                   </a:tcPr>
                 </a:tc>
               </a:tr>
-              <a:tr h="603504">
+              <a:tr h="521208">
                 <a:tc>
                   <a:txBody>
                     <a:bodyPr/>
@@ -10027,7 +10027,7 @@
                   </a:tcPr>
                 </a:tc>
               </a:tr>
-              <a:tr h="603504">
+              <a:tr h="521208">
                 <a:tc>
                   <a:txBody>
                     <a:bodyPr/>
@@ -10194,7 +10194,7 @@
                   </a:tcPr>
                 </a:tc>
               </a:tr>
-              <a:tr h="603504">
+              <a:tr h="521208">
                 <a:tc>
                   <a:txBody>
                     <a:bodyPr/>
@@ -10361,7 +10361,174 @@
                   </a:tcPr>
                 </a:tc>
               </a:tr>
-              <a:tr h="603504">
+              <a:tr h="521208">
+                <a:tc>
+                  <a:txBody>
+                    <a:bodyPr/>
+                    <a:lstStyle/>
+                    <a:p>
+                      <a:pPr marL="0" indent="0" algn="l">
+                        <a:lnSpc>
+                          <a:spcPct val="100000"/>
+                        </a:lnSpc>
+                        <a:spcBef>
+                          <a:spcPts val="0"/>
+                        </a:spcBef>
+                        <a:spcAft>
+                          <a:spcPts val="0"/>
+                        </a:spcAft>
+                        <a:buNone/>
+                      </a:pPr>
+                      <a:r>
+                        <a:rPr lang="en-IN" sz="1300" dirty="0">
+                          <a:solidFill>
+                            <a:srgbClr val="1F2328"/>
+                          </a:solidFill>
+                          <a:latin typeface="Times New Roman" panose="02020603050405020304" pitchFamily="18" charset="0"/>
+                          <a:cs typeface="Times New Roman" panose="02020603050405020304" pitchFamily="18" charset="0"/>
+                        </a:rPr>
+                        <a:t>Distortion self-check</a:t>
+                      </a:r>
+                    </a:p>
+                  </a:txBody>
+                  <a:tcPr marL="73152" marR="73152" marT="45720" marB="45720" anchor="ctr">
+                    <a:lnL w="9525">
+                      <a:solidFill>
+                        <a:srgbClr val="C9D3E0"/>
+                      </a:solidFill>
+                    </a:lnL>
+                    <a:lnR w="9525">
+                      <a:solidFill>
+                        <a:srgbClr val="C9D3E0"/>
+                      </a:solidFill>
+                    </a:lnR>
+                    <a:lnT w="9525">
+                      <a:solidFill>
+                        <a:srgbClr val="C9D3E0"/>
+                      </a:solidFill>
+                    </a:lnT>
+                    <a:lnB w="9525">
+                      <a:solidFill>
+                        <a:srgbClr val="C9D3E0"/>
+                      </a:solidFill>
+                    </a:lnB>
+                    <a:solidFill>
+                      <a:srgbClr val="EEF3FA"/>
+                    </a:solidFill>
+                  </a:tcPr>
+                </a:tc>
+                <a:tc>
+                  <a:txBody>
+                    <a:bodyPr/>
+                    <a:lstStyle/>
+                    <a:p>
+                      <a:pPr marL="0" indent="0" algn="l">
+                        <a:lnSpc>
+                          <a:spcPct val="100000"/>
+                        </a:lnSpc>
+                        <a:spcBef>
+                          <a:spcPts val="0"/>
+                        </a:spcBef>
+                        <a:spcAft>
+                          <a:spcPts val="0"/>
+                        </a:spcAft>
+                        <a:buNone/>
+                      </a:pPr>
+                      <a:r>
+                        <a:rPr lang="en-IN" sz="1300" dirty="0">
+                          <a:solidFill>
+                            <a:srgbClr val="1F2328"/>
+                          </a:solidFill>
+                          <a:latin typeface="Times New Roman" panose="02020603050405020304" pitchFamily="18" charset="0"/>
+                          <a:cs typeface="Times New Roman" panose="02020603050405020304" pitchFamily="18" charset="0"/>
+                        </a:rPr>
+                        <a:t>Pandas metrics equal a plain-Python version</a:t>
+                      </a:r>
+                    </a:p>
+                  </a:txBody>
+                  <a:tcPr marL="73152" marR="73152" marT="45720" marB="45720" anchor="ctr">
+                    <a:lnL w="9525">
+                      <a:solidFill>
+                        <a:srgbClr val="C9D3E0"/>
+                      </a:solidFill>
+                    </a:lnL>
+                    <a:lnR w="9525">
+                      <a:solidFill>
+                        <a:srgbClr val="C9D3E0"/>
+                      </a:solidFill>
+                    </a:lnR>
+                    <a:lnT w="9525">
+                      <a:solidFill>
+                        <a:srgbClr val="C9D3E0"/>
+                      </a:solidFill>
+                    </a:lnT>
+                    <a:lnB w="9525">
+                      <a:solidFill>
+                        <a:srgbClr val="C9D3E0"/>
+                      </a:solidFill>
+                    </a:lnB>
+                    <a:solidFill>
+                      <a:srgbClr val="EEF3FA"/>
+                    </a:solidFill>
+                  </a:tcPr>
+                </a:tc>
+                <a:tc>
+                  <a:txBody>
+                    <a:bodyPr/>
+                    <a:lstStyle/>
+                    <a:p>
+                      <a:pPr marL="0" indent="0" algn="l">
+                        <a:lnSpc>
+                          <a:spcPct val="100000"/>
+                        </a:lnSpc>
+                        <a:spcBef>
+                          <a:spcPts val="0"/>
+                        </a:spcBef>
+                        <a:spcAft>
+                          <a:spcPts val="0"/>
+                        </a:spcAft>
+                        <a:buNone/>
+                      </a:pPr>
+                      <a:r>
+                        <a:rPr lang="en-IN" sz="1300" dirty="0">
+                          <a:solidFill>
+                            <a:srgbClr val="1F2328"/>
+                          </a:solidFill>
+                          <a:latin typeface="Times New Roman" panose="02020603050405020304" pitchFamily="18" charset="0"/>
+                          <a:cs typeface="Times New Roman" panose="02020603050405020304" pitchFamily="18" charset="0"/>
+                        </a:rPr>
+                        <a:t>60 case notions identical on 3 real slices</a:t>
+                      </a:r>
+                    </a:p>
+                  </a:txBody>
+                  <a:tcPr marL="73152" marR="73152" marT="45720" marB="45720" anchor="ctr">
+                    <a:lnL w="9525">
+                      <a:solidFill>
+                        <a:srgbClr val="C9D3E0"/>
+                      </a:solidFill>
+                    </a:lnL>
+                    <a:lnR w="9525">
+                      <a:solidFill>
+                        <a:srgbClr val="C9D3E0"/>
+                      </a:solidFill>
+                    </a:lnR>
+                    <a:lnT w="9525">
+                      <a:solidFill>
+                        <a:srgbClr val="C9D3E0"/>
+                      </a:solidFill>
+                    </a:lnT>
+                    <a:lnB w="9525">
+                      <a:solidFill>
+                        <a:srgbClr val="C9D3E0"/>
+                      </a:solidFill>
+                    </a:lnB>
+                    <a:solidFill>
+                      <a:srgbClr val="EEF3FA"/>
+                    </a:solidFill>
+                  </a:tcPr>
+                </a:tc>
+              </a:tr>
+              <a:tr h="521208">
                 <a:tc>
                   <a:txBody>
                     <a:bodyPr/>
@@ -10413,7 +10580,7 @@
                       </a:solidFill>
                     </a:lnB>
                     <a:solidFill>
-                      <a:srgbClr val="EEF3FA"/>
+                      <a:srgbClr val="FFFFFF"/>
                     </a:solidFill>
                   </a:tcPr>
                 </a:tc>
@@ -10468,7 +10635,7 @@
                       </a:solidFill>
                     </a:lnB>
                     <a:solidFill>
-                      <a:srgbClr val="EEF3FA"/>
+                      <a:srgbClr val="FFFFFF"/>
                     </a:solidFill>
                   </a:tcPr>
                 </a:tc>
@@ -10523,12 +10690,12 @@
                       </a:solidFill>
                     </a:lnB>
                     <a:solidFill>
-                      <a:srgbClr val="EEF3FA"/>
+                      <a:srgbClr val="FFFFFF"/>
                     </a:solidFill>
                   </a:tcPr>
                 </a:tc>
               </a:tr>
-              <a:tr h="603504">
+              <a:tr h="521208">
                 <a:tc>
                   <a:txBody>
                     <a:bodyPr/>
@@ -10580,7 +10747,7 @@
                       </a:solidFill>
                     </a:lnB>
                     <a:solidFill>
-                      <a:srgbClr val="FFFFFF"/>
+                      <a:srgbClr val="EEF3FA"/>
                     </a:solidFill>
                   </a:tcPr>
                 </a:tc>
@@ -10635,7 +10802,7 @@
                       </a:solidFill>
                     </a:lnB>
                     <a:solidFill>
-                      <a:srgbClr val="FFFFFF"/>
+                      <a:srgbClr val="EEF3FA"/>
                     </a:solidFill>
                   </a:tcPr>
                 </a:tc>
@@ -10690,7 +10857,7 @@
                       </a:solidFill>
                     </a:lnB>
                     <a:solidFill>
-                      <a:srgbClr val="FFFFFF"/>
+                      <a:srgbClr val="EEF3FA"/>
                     </a:solidFill>
                   </a:tcPr>
                 </a:tc>
@@ -10758,7 +10925,7 @@
                 <a:latin typeface="Times New Roman" panose="02020603050405020304" pitchFamily="18" charset="0"/>
                 <a:cs typeface="Times New Roman" panose="02020603050405020304" pitchFamily="18" charset="0"/>
               </a:rPr>
-              <a:t>independent human labelling of the real-data findings; a second implementation of the distortion metrics; the converters are checked by us, not by a second team.</a:t>
+              <a:t>independent human labelling; the distortion check covers slices, not full logs; the activity rankings have no second implementation; the converters are checked by us only.</a:t>
             </a:r>
           </a:p>
         </p:txBody>

</xml_diff>

<commit_message>
Update Review 3 report and deck; raise discovery recursion limit
- Report: process-discovery section, bootstrap intervals, plausible case
  notions, full-log verification, JIIS submission status; formal register
  throughout; VIT template fixes (abstract page number, CROP abbreviation)
- Deck: new process-discovery slide, updated outcome, testing and references;
  template path configurable (DECK_TEMPLATE)
- Figures: fitness-versus-coverage chart; timeline shows the submission
- discovery.py: raise the recursion limit (pm4py's tree folding uses deepcopy)
  and give each case notion an hour; discovery numbers in the report and deck
  are from the earlier run until AoE2 and Angular are re-mined
- JIIS: numbered citation style, reference fixes, compiled PDF and cover letter

Co-Authored-By: Claude Opus 5.5 <noreply@anthropic.com>
</commit_message>
<xml_diff>
--- a/docs/review-3/Team1_Review3_OCEL.pptx
+++ b/docs/review-3/Team1_Review3_OCEL.pptx
@@ -27,6 +27,7 @@
     <p:sldId id="272" r:id="rId117"/>
     <p:sldId id="273" r:id="rId118"/>
     <p:sldId id="274" r:id="rId119"/>
+    <p:sldId id="275" r:id="rId120"/>
   </p:sldIdLst>
   <p:sldSz cx="12192000" cy="6858000"/>
   <p:notesSz cx="6858000" cy="9144000"/>
@@ -942,7 +943,7 @@
           <a:p>
             <a:r>
               <a:rPr lang="en-IN" dirty="0"/>
-              <a:t>We tested the project the way we would test someone else's. Downloads are checked against the published size and MD5 where the publisher gives one, and every file gets a SHA-256 on record. Re-running reproduces every result file byte for byte. Our fast code is compared with a slow, plain Python version, and our rule code with independent SQL, and the OULAD counts with a separate read of the raw files. And here is the part we are actually proud of: those checks found three real bugs of our own. Duplicate Gerrit comments, an abandon message we missed, and a tie-breaking problem in event order. We fixed all three and re-ran everything. What we have not done is get a second person to label the findings independently. That is on the limits list.</a:t>
+              <a:t>Discovery is what most people actually use process mining for, so we mined a model from every flat view. Look at the chart. Up is fitness, how well the model replays its own log. Right is how much of the real process the model even contains. Every single dot sits near the top, fitness 0.955 or better, including the ones on the far left that show a tiny slice of the process. So the standard quality check says everything is fine, exactly when the view is most partial. And where cases mix up events from different objects, the miner wraps them in loops, and precision drops to 0.04. A model like that will accept almost anything.</a:t>
             </a:r>
           </a:p>
         </p:txBody>
@@ -1001,7 +1002,7 @@
           <a:p>
             <a:r>
               <a:rPr lang="en-IN" dirty="0"/>
-              <a:t>So, what do we conclude? That the pipeline works, that it is checked, and that on real data the story is narrowing more than duplication. And one limit we repeat on purpose: the capstone model is a design. We could not test it on portal data. Next steps, in order of importance: get someone independent to label our findings, add the harder comparisons like discovery quality and prediction, add a few more real logs, and, if the university allows it, plug in the real audit log. Thank you. We are happy to take questions.</a:t>
+              <a:t>We tested the project the way we would test someone else's. Downloads are checked against the published size and MD5 where the publisher gives one, and every file gets a SHA-256 on record. Re-running reproduces every result file byte for byte. Our fast code is compared with a slow, plain Python version, and that comparison now runs on all seven full logs, every object type, identical. Our rule code is checked against independent SQL, and the OULAD counts against a separate read of the raw files. And here is the part we are actually proud of: those checks found three real bugs of our own. Duplicate Gerrit comments, an abandon message we missed, and a tie-breaking problem in event order. We fixed all three and re-ran everything. What we have not done is get a second person to label the findings independently. That is on the limits list.</a:t>
             </a:r>
           </a:p>
         </p:txBody>
@@ -1060,7 +1061,7 @@
           <a:p>
             <a:r>
               <a:rPr lang="en-IN" dirty="0"/>
-              <a:t>This slide is short because the honest answer is short. No patent, no conference paper, no journal acceptance. What we do have is a manuscript draft, version zero point two, and a working, checked code base. We would rather tell you that now than have you find it in Q and A. Once there is a real submission receipt, that is the proof we will upload.</a:t>
+              <a:t>So, what do we conclude? That the pipeline works, that it is checked, and that on real data the story is narrowing more than duplication. And here's the part that surprised us most: the models you mine from those narrow views still look great on paper, so the usual check never raises a flag. One limit we repeat on purpose: the capstone model is a design. We could not test it on portal data. Next steps: get someone independent to label our findings, try prediction and other miners, and answer whatever the journal reviewers send back. Thank you. We are happy to take questions.</a:t>
             </a:r>
           </a:p>
         </p:txBody>
@@ -1119,7 +1120,7 @@
           <a:p>
             <a:r>
               <a:rPr lang="en-IN" dirty="0"/>
-              <a:t>References in IEEE style. Everything on this slide was checked against its publisher record or its arXiv entry before it went on the slide. The last line lists the datasets, all openly licensed. Thank you.</a:t>
+              <a:t>This slide is short because the honest answer is short. No patent and no conference paper. We did submit the journal paper, to the Journal of Intelligent Information Systems, and the submission acknowledgement is our proof. It is under review, not accepted, and we would rather say that clearly now than have it come up in Q and A. Alongside it, the whole code base is public and re-runs every number.</a:t>
             </a:r>
           </a:p>
         </p:txBody>
@@ -1178,7 +1179,66 @@
           <a:p>
             <a:r>
               <a:rPr lang="en-IN" dirty="0"/>
-              <a:t>Quick honesty first. This slide is meant to show our guide's approval mail, and we do not have that screenshot in the file yet, so it is marked as a placeholder, in yellow, on purpose. We would rather show an empty box than a made-up one. The right side lists the six things the mail has to confirm, including the Turnitin numbers, which we will fill in from the real report. One thing we can already say truthfully: the project outcome is ongoing. Our journal manuscript is still being written.</a:t>
+              <a:t>Quick honesty first. This slide is meant to show our guide's approval mail, and we do not have that screenshot in the file yet, so it is marked as a placeholder, in yellow, on purpose. We would rather show an empty box than a made-up one. The right side lists the six things the mail has to confirm, including the Turnitin numbers, which we will fill in from the real report. One thing we can already say truthfully: the project outcome is a journal paper, submitted to the Journal of Intelligent Information Systems and now under review.</a:t>
+            </a:r>
+          </a:p>
+        </p:txBody>
+      </p:sp>
+    </p:spTree>
+  </p:cSld>
+  <p:clrMapOvr>
+    <a:masterClrMapping/>
+  </p:clrMapOvr>
+</p:notes>
+</file>
+
+<file path=ppt/notesSlides/notesSlide20.xml><?xml version="1.0" encoding="utf-8"?>
+<p:notes xmlns:a="http://schemas.openxmlformats.org/drawingml/2006/main" xmlns:r="http://schemas.openxmlformats.org/officeDocument/2006/relationships" xmlns:p="http://schemas.openxmlformats.org/presentationml/2006/main">
+  <p:cSld>
+    <p:spTree>
+      <p:nvGrpSpPr>
+        <p:cNvPr id="1" name=""/>
+        <p:cNvGrpSpPr/>
+        <p:nvPr/>
+      </p:nvGrpSpPr>
+      <p:grpSpPr>
+        <a:xfrm>
+          <a:off x="0" y="0"/>
+          <a:ext cx="0" cy="0"/>
+          <a:chOff x="0" y="0"/>
+          <a:chExt cx="0" cy="0"/>
+        </a:xfrm>
+      </p:grpSpPr>
+      <p:sp>
+        <p:nvSpPr>
+          <p:cNvPr id="2" name="Slide Image Placeholder 1"/>
+          <p:cNvSpPr>
+            <a:spLocks noGrp="1" noRot="1" noChangeAspect="1"/>
+          </p:cNvSpPr>
+          <p:nvPr>
+            <p:ph type="sldImg"/>
+          </p:nvPr>
+        </p:nvSpPr>
+        <p:spPr/>
+      </p:sp>
+      <p:sp>
+        <p:nvSpPr>
+          <p:cNvPr id="3" name="Notes Placeholder 2"/>
+          <p:cNvSpPr>
+            <a:spLocks noGrp="1"/>
+          </p:cNvSpPr>
+          <p:nvPr>
+            <p:ph type="body" idx="1"/>
+          </p:nvPr>
+        </p:nvSpPr>
+        <p:spPr/>
+        <p:txBody>
+          <a:bodyPr/>
+          <a:lstStyle/>
+          <a:p>
+            <a:r>
+              <a:rPr lang="en-IN" dirty="0"/>
+              <a:t>References in IEEE style. Everything on this slide was checked against its publisher record or its arXiv entry before it went on the slide. The last line lists the datasets, all openly licensed. Thank you.</a:t>
             </a:r>
           </a:p>
         </p:txBody>
@@ -1296,7 +1356,7 @@
           <a:p>
             <a:r>
               <a:rPr lang="en-IN" dirty="0"/>
-              <a:t>Here is the whole project in one breath. Process mining likes one case per event. Real workflows do not work like that. We built a pipeline around OCEL 2.0, which lets one event point at many objects, and we pointed it at seven real public logs: Gerrit code review, the Open University student data, Angular commits, the German Bundestag, Enron e-mails, Ethereum, and Age of Empires. Our honest finding is a little less dramatic than we expected. Flattening rarely duplicates events, except in fan-out logs. The bigger effect is narrowing, you only see a slice. And one more thing worth saying out loud: none of these numbers come from synthetic data.</a:t>
+              <a:t>Here is the whole project in one breath. Process mining likes one case per event. Real workflows do not work like that. We built a pipeline around OCEL 2.0, which lets one event point at many objects, and we pointed it at seven real public logs: Gerrit code review, the Open University student data, Angular commits, the German Bundestag, Enron e-mails, Ethereum, and Age of Empires. Our honest finding is a little less dramatic than we expected. Flattening rarely duplicates events, except in fan-out logs. The bigger effect is narrowing, you only see a slice. And the model you mine from that slice still looks perfectly healthy. And one more thing worth saying out loud: none of these numbers come from synthetic data.</a:t>
             </a:r>
           </a:p>
         </p:txBody>
@@ -1532,7 +1592,7 @@
           <a:p>
             <a:r>
               <a:rPr lang="en-IN" dirty="0"/>
-              <a:t>Five objectives, in the order we did them. One, model the capstone lifecycle. Two, build a pipeline you can re-run. Three, measure the distortion without us picking the rules, because rules we pick can flatter our own idea. Four, compare what an analyst would actually look at, rankings, edge counts, variants. Five, check everything twice. On the right: the goals this touches are Quality Education and Industry, Innovation and Infrastructure. We rate the technology at level four, validated in the lab, and we say level two to three for plugging it into the real portal. The outcome we are aiming at is a journal paper. It is in preparation. It is not submitted, and we are not going to pretend otherwise.</a:t>
+              <a:t>Five objectives, in the order we did them. One, model the capstone lifecycle. Two, build a pipeline you can re-run. Three, measure the distortion without us picking the rules, because rules we pick can flatter our own idea. Four, compare what an analyst would actually look at, rankings, edge counts, variants. Five, check everything twice. On the right: the goals this touches are Quality Education and Industry, Innovation and Infrastructure. We rate the technology at level four, validated in the lab, and we say level two to three for plugging it into the real portal. The outcome is a journal paper. We submitted it to the Journal of Intelligent Information Systems, a Springer journal indexed in Scopus, and it is under review. Under review is not accepted, and we are not going to pretend otherwise.</a:t>
             </a:r>
           </a:p>
         </p:txBody>
@@ -7404,7 +7464,7 @@
                           <a:latin typeface="Times New Roman" panose="02020603050405020304" pitchFamily="18" charset="0"/>
                           <a:cs typeface="Times New Roman" panose="02020603050405020304" pitchFamily="18" charset="0"/>
                         </a:rPr>
-                        <a:t>consequence.py</a:t>
+                        <a:t>consequence.py, discovery.py, bootstrap.py</a:t>
                       </a:r>
                     </a:p>
                   </a:txBody>
@@ -7459,7 +7519,7 @@
                           <a:latin typeface="Times New Roman" panose="02020603050405020304" pitchFamily="18" charset="0"/>
                           <a:cs typeface="Times New Roman" panose="02020603050405020304" pitchFamily="18" charset="0"/>
                         </a:rPr>
-                        <a:t>Flat vs object-centric rankings, edges, variants, entities</a:t>
+                        <a:t>Flat vs object-centric rankings, edges, variants, entities, mined models; bootstrap intervals</a:t>
                       </a:r>
                     </a:p>
                   </a:txBody>
@@ -7848,7 +7908,7 @@
                           <a:latin typeface="Times New Roman" panose="02020603050405020304" pitchFamily="18" charset="0"/>
                           <a:cs typeface="Times New Roman" panose="02020603050405020304" pitchFamily="18" charset="0"/>
                         </a:rPr>
-                        <a:t>sql_crosscheck.py, check_consequence.py</a:t>
+                        <a:t>sql_crosscheck.py, check_consequence.py, check_distortion.py</a:t>
                       </a:r>
                     </a:p>
                   </a:txBody>
@@ -7903,7 +7963,7 @@
                           <a:latin typeface="Times New Roman" panose="02020603050405020304" pitchFamily="18" charset="0"/>
                           <a:cs typeface="Times New Roman" panose="02020603050405020304" pitchFamily="18" charset="0"/>
                         </a:rPr>
-                        <a:t>Independent SQL and brute-force re-implementations</a:t>
+                        <a:t>Independent SQL, brute-force and full-log plain-Python re-implementations</a:t>
                       </a:r>
                     </a:p>
                   </a:txBody>
@@ -8070,7 +8130,7 @@
                           <a:latin typeface="Times New Roman" panose="02020603050405020304" pitchFamily="18" charset="0"/>
                           <a:cs typeface="Times New Roman" panose="02020603050405020304" pitchFamily="18" charset="0"/>
                         </a:rPr>
-                        <a:t>summarize_distortion.py, summarize_log_level.py, summarize_consequence.py</a:t>
+                        <a:t>summarize_*.py (distortion, log level, consequence, discovery)</a:t>
                       </a:r>
                     </a:p>
                   </a:txBody>
@@ -9500,1382 +9560,45 @@
                 <a:latin typeface="Times New Roman" panose="02020603050405020304" pitchFamily="18" charset="0"/>
                 <a:cs typeface="Times New Roman" panose="02020603050405020304" pitchFamily="18" charset="0"/>
               </a:rPr>
-              <a:t>Testing and Validation</a:t>
-            </a:r>
-          </a:p>
-        </p:txBody>
-      </p:sp>
-      <p:graphicFrame>
-        <p:nvGraphicFramePr>
-          <p:cNvPr id="3" name="Table 3"/>
-          <p:cNvGraphicFramePr>
-            <a:graphicFrameLocks noGrp="1"/>
-          </p:cNvGraphicFramePr>
+              <a:t>Experiments and Results: Process Discovery</a:t>
+            </a:r>
+          </a:p>
+        </p:txBody>
+      </p:sp>
+      <p:pic>
+        <p:nvPicPr>
+          <p:cNvPr id="3" name="Picture 3" descr="Replay fitness against the share of activities in the discovered model"/>
+          <p:cNvPicPr>
+            <a:picLocks noChangeAspect="1"/>
+          </p:cNvPicPr>
           <p:nvPr/>
-        </p:nvGraphicFramePr>
-        <p:xfrm>
-          <a:off x="457200" y="1371600"/>
-          <a:ext cx="11274552" cy="4059936"/>
-        </p:xfrm>
-        <a:graphic>
-          <a:graphicData uri="http://schemas.openxmlformats.org/drawingml/2006/table">
-            <a:tbl>
-              <a:tblPr firstRow="1" bandRow="1"/>
-              <a:tblGrid>
-                <a:gridCol w="3108960"/>
-                <a:gridCol w="5120640"/>
-                <a:gridCol w="3044952"/>
-              </a:tblGrid>
-              <a:tr h="411480">
-                <a:tc>
-                  <a:txBody>
-                    <a:bodyPr/>
-                    <a:lstStyle/>
-                    <a:p>
-                      <a:pPr marL="0" indent="0" algn="l">
-                        <a:lnSpc>
-                          <a:spcPct val="100000"/>
-                        </a:lnSpc>
-                        <a:spcBef>
-                          <a:spcPts val="0"/>
-                        </a:spcBef>
-                        <a:spcAft>
-                          <a:spcPts val="0"/>
-                        </a:spcAft>
-                        <a:buNone/>
-                      </a:pPr>
-                      <a:r>
-                        <a:rPr lang="en-IN" sz="1300" b="1" dirty="0">
-                          <a:solidFill>
-                            <a:srgbClr val="FFFFFF"/>
-                          </a:solidFill>
-                          <a:latin typeface="Times New Roman" panose="02020603050405020304" pitchFamily="18" charset="0"/>
-                          <a:cs typeface="Times New Roman" panose="02020603050405020304" pitchFamily="18" charset="0"/>
-                        </a:rPr>
-                        <a:t>Check</a:t>
-                      </a:r>
-                    </a:p>
-                  </a:txBody>
-                  <a:tcPr marL="73152" marR="73152" marT="45720" marB="45720" anchor="ctr">
-                    <a:lnL w="9525">
-                      <a:solidFill>
-                        <a:srgbClr val="C9D3E0"/>
-                      </a:solidFill>
-                    </a:lnL>
-                    <a:lnR w="9525">
-                      <a:solidFill>
-                        <a:srgbClr val="C9D3E0"/>
-                      </a:solidFill>
-                    </a:lnR>
-                    <a:lnT w="9525">
-                      <a:solidFill>
-                        <a:srgbClr val="C9D3E0"/>
-                      </a:solidFill>
-                    </a:lnT>
-                    <a:lnB w="9525">
-                      <a:solidFill>
-                        <a:srgbClr val="C9D3E0"/>
-                      </a:solidFill>
-                    </a:lnB>
-                    <a:solidFill>
-                      <a:srgbClr val="2A78D6"/>
-                    </a:solidFill>
-                  </a:tcPr>
-                </a:tc>
-                <a:tc>
-                  <a:txBody>
-                    <a:bodyPr/>
-                    <a:lstStyle/>
-                    <a:p>
-                      <a:pPr marL="0" indent="0" algn="l">
-                        <a:lnSpc>
-                          <a:spcPct val="100000"/>
-                        </a:lnSpc>
-                        <a:spcBef>
-                          <a:spcPts val="0"/>
-                        </a:spcBef>
-                        <a:spcAft>
-                          <a:spcPts val="0"/>
-                        </a:spcAft>
-                        <a:buNone/>
-                      </a:pPr>
-                      <a:r>
-                        <a:rPr lang="en-IN" sz="1300" b="1" dirty="0">
-                          <a:solidFill>
-                            <a:srgbClr val="FFFFFF"/>
-                          </a:solidFill>
-                          <a:latin typeface="Times New Roman" panose="02020603050405020304" pitchFamily="18" charset="0"/>
-                          <a:cs typeface="Times New Roman" panose="02020603050405020304" pitchFamily="18" charset="0"/>
-                        </a:rPr>
-                        <a:t>What it proves</a:t>
-                      </a:r>
-                    </a:p>
-                  </a:txBody>
-                  <a:tcPr marL="73152" marR="73152" marT="45720" marB="45720" anchor="ctr">
-                    <a:lnL w="9525">
-                      <a:solidFill>
-                        <a:srgbClr val="C9D3E0"/>
-                      </a:solidFill>
-                    </a:lnL>
-                    <a:lnR w="9525">
-                      <a:solidFill>
-                        <a:srgbClr val="C9D3E0"/>
-                      </a:solidFill>
-                    </a:lnR>
-                    <a:lnT w="9525">
-                      <a:solidFill>
-                        <a:srgbClr val="C9D3E0"/>
-                      </a:solidFill>
-                    </a:lnT>
-                    <a:lnB w="9525">
-                      <a:solidFill>
-                        <a:srgbClr val="C9D3E0"/>
-                      </a:solidFill>
-                    </a:lnB>
-                    <a:solidFill>
-                      <a:srgbClr val="2A78D6"/>
-                    </a:solidFill>
-                  </a:tcPr>
-                </a:tc>
-                <a:tc>
-                  <a:txBody>
-                    <a:bodyPr/>
-                    <a:lstStyle/>
-                    <a:p>
-                      <a:pPr marL="0" indent="0" algn="l">
-                        <a:lnSpc>
-                          <a:spcPct val="100000"/>
-                        </a:lnSpc>
-                        <a:spcBef>
-                          <a:spcPts val="0"/>
-                        </a:spcBef>
-                        <a:spcAft>
-                          <a:spcPts val="0"/>
-                        </a:spcAft>
-                        <a:buNone/>
-                      </a:pPr>
-                      <a:r>
-                        <a:rPr lang="en-IN" sz="1300" b="1" dirty="0">
-                          <a:solidFill>
-                            <a:srgbClr val="FFFFFF"/>
-                          </a:solidFill>
-                          <a:latin typeface="Times New Roman" panose="02020603050405020304" pitchFamily="18" charset="0"/>
-                          <a:cs typeface="Times New Roman" panose="02020603050405020304" pitchFamily="18" charset="0"/>
-                        </a:rPr>
-                        <a:t>Result</a:t>
-                      </a:r>
-                    </a:p>
-                  </a:txBody>
-                  <a:tcPr marL="73152" marR="73152" marT="45720" marB="45720" anchor="ctr">
-                    <a:lnL w="9525">
-                      <a:solidFill>
-                        <a:srgbClr val="C9D3E0"/>
-                      </a:solidFill>
-                    </a:lnL>
-                    <a:lnR w="9525">
-                      <a:solidFill>
-                        <a:srgbClr val="C9D3E0"/>
-                      </a:solidFill>
-                    </a:lnR>
-                    <a:lnT w="9525">
-                      <a:solidFill>
-                        <a:srgbClr val="C9D3E0"/>
-                      </a:solidFill>
-                    </a:lnT>
-                    <a:lnB w="9525">
-                      <a:solidFill>
-                        <a:srgbClr val="C9D3E0"/>
-                      </a:solidFill>
-                    </a:lnB>
-                    <a:solidFill>
-                      <a:srgbClr val="2A78D6"/>
-                    </a:solidFill>
-                  </a:tcPr>
-                </a:tc>
-              </a:tr>
-              <a:tr h="521208">
-                <a:tc>
-                  <a:txBody>
-                    <a:bodyPr/>
-                    <a:lstStyle/>
-                    <a:p>
-                      <a:pPr marL="0" indent="0" algn="l">
-                        <a:lnSpc>
-                          <a:spcPct val="100000"/>
-                        </a:lnSpc>
-                        <a:spcBef>
-                          <a:spcPts val="0"/>
-                        </a:spcBef>
-                        <a:spcAft>
-                          <a:spcPts val="0"/>
-                        </a:spcAft>
-                        <a:buNone/>
-                      </a:pPr>
-                      <a:r>
-                        <a:rPr lang="en-IN" sz="1300" dirty="0">
-                          <a:solidFill>
-                            <a:srgbClr val="1F2328"/>
-                          </a:solidFill>
-                          <a:latin typeface="Times New Roman" panose="02020603050405020304" pitchFamily="18" charset="0"/>
-                          <a:cs typeface="Times New Roman" panose="02020603050405020304" pitchFamily="18" charset="0"/>
-                        </a:rPr>
-                        <a:t>Download integrity</a:t>
-                      </a:r>
-                    </a:p>
-                  </a:txBody>
-                  <a:tcPr marL="73152" marR="73152" marT="45720" marB="45720" anchor="ctr">
-                    <a:lnL w="9525">
-                      <a:solidFill>
-                        <a:srgbClr val="C9D3E0"/>
-                      </a:solidFill>
-                    </a:lnL>
-                    <a:lnR w="9525">
-                      <a:solidFill>
-                        <a:srgbClr val="C9D3E0"/>
-                      </a:solidFill>
-                    </a:lnR>
-                    <a:lnT w="9525">
-                      <a:solidFill>
-                        <a:srgbClr val="C9D3E0"/>
-                      </a:solidFill>
-                    </a:lnT>
-                    <a:lnB w="9525">
-                      <a:solidFill>
-                        <a:srgbClr val="C9D3E0"/>
-                      </a:solidFill>
-                    </a:lnB>
-                    <a:solidFill>
-                      <a:srgbClr val="EEF3FA"/>
-                    </a:solidFill>
-                  </a:tcPr>
-                </a:tc>
-                <a:tc>
-                  <a:txBody>
-                    <a:bodyPr/>
-                    <a:lstStyle/>
-                    <a:p>
-                      <a:pPr marL="0" indent="0" algn="l">
-                        <a:lnSpc>
-                          <a:spcPct val="100000"/>
-                        </a:lnSpc>
-                        <a:spcBef>
-                          <a:spcPts val="0"/>
-                        </a:spcBef>
-                        <a:spcAft>
-                          <a:spcPts val="0"/>
-                        </a:spcAft>
-                        <a:buNone/>
-                      </a:pPr>
-                      <a:r>
-                        <a:rPr lang="en-IN" sz="1300" dirty="0">
-                          <a:solidFill>
-                            <a:srgbClr val="1F2328"/>
-                          </a:solidFill>
-                          <a:latin typeface="Times New Roman" panose="02020603050405020304" pitchFamily="18" charset="0"/>
-                          <a:cs typeface="Times New Roman" panose="02020603050405020304" pitchFamily="18" charset="0"/>
-                        </a:rPr>
-                        <a:t>Zenodo files match the published size and MD5</a:t>
-                      </a:r>
-                    </a:p>
-                  </a:txBody>
-                  <a:tcPr marL="73152" marR="73152" marT="45720" marB="45720" anchor="ctr">
-                    <a:lnL w="9525">
-                      <a:solidFill>
-                        <a:srgbClr val="C9D3E0"/>
-                      </a:solidFill>
-                    </a:lnL>
-                    <a:lnR w="9525">
-                      <a:solidFill>
-                        <a:srgbClr val="C9D3E0"/>
-                      </a:solidFill>
-                    </a:lnR>
-                    <a:lnT w="9525">
-                      <a:solidFill>
-                        <a:srgbClr val="C9D3E0"/>
-                      </a:solidFill>
-                    </a:lnT>
-                    <a:lnB w="9525">
-                      <a:solidFill>
-                        <a:srgbClr val="C9D3E0"/>
-                      </a:solidFill>
-                    </a:lnB>
-                    <a:solidFill>
-                      <a:srgbClr val="EEF3FA"/>
-                    </a:solidFill>
-                  </a:tcPr>
-                </a:tc>
-                <a:tc>
-                  <a:txBody>
-                    <a:bodyPr/>
-                    <a:lstStyle/>
-                    <a:p>
-                      <a:pPr marL="0" indent="0" algn="l">
-                        <a:lnSpc>
-                          <a:spcPct val="100000"/>
-                        </a:lnSpc>
-                        <a:spcBef>
-                          <a:spcPts val="0"/>
-                        </a:spcBef>
-                        <a:spcAft>
-                          <a:spcPts val="0"/>
-                        </a:spcAft>
-                        <a:buNone/>
-                      </a:pPr>
-                      <a:r>
-                        <a:rPr lang="en-IN" sz="1300" dirty="0">
-                          <a:solidFill>
-                            <a:srgbClr val="1F2328"/>
-                          </a:solidFill>
-                          <a:latin typeface="Times New Roman" panose="02020603050405020304" pitchFamily="18" charset="0"/>
-                          <a:cs typeface="Times New Roman" panose="02020603050405020304" pitchFamily="18" charset="0"/>
-                        </a:rPr>
-                        <a:t>Zenodo: size + MD5 checked; every file: SHA-256 recorded</a:t>
-                      </a:r>
-                    </a:p>
-                  </a:txBody>
-                  <a:tcPr marL="73152" marR="73152" marT="45720" marB="45720" anchor="ctr">
-                    <a:lnL w="9525">
-                      <a:solidFill>
-                        <a:srgbClr val="C9D3E0"/>
-                      </a:solidFill>
-                    </a:lnL>
-                    <a:lnR w="9525">
-                      <a:solidFill>
-                        <a:srgbClr val="C9D3E0"/>
-                      </a:solidFill>
-                    </a:lnR>
-                    <a:lnT w="9525">
-                      <a:solidFill>
-                        <a:srgbClr val="C9D3E0"/>
-                      </a:solidFill>
-                    </a:lnT>
-                    <a:lnB w="9525">
-                      <a:solidFill>
-                        <a:srgbClr val="C9D3E0"/>
-                      </a:solidFill>
-                    </a:lnB>
-                    <a:solidFill>
-                      <a:srgbClr val="EEF3FA"/>
-                    </a:solidFill>
-                  </a:tcPr>
-                </a:tc>
-              </a:tr>
-              <a:tr h="521208">
-                <a:tc>
-                  <a:txBody>
-                    <a:bodyPr/>
-                    <a:lstStyle/>
-                    <a:p>
-                      <a:pPr marL="0" indent="0" algn="l">
-                        <a:lnSpc>
-                          <a:spcPct val="100000"/>
-                        </a:lnSpc>
-                        <a:spcBef>
-                          <a:spcPts val="0"/>
-                        </a:spcBef>
-                        <a:spcAft>
-                          <a:spcPts val="0"/>
-                        </a:spcAft>
-                        <a:buNone/>
-                      </a:pPr>
-                      <a:r>
-                        <a:rPr lang="en-IN" sz="1300" dirty="0">
-                          <a:solidFill>
-                            <a:srgbClr val="1F2328"/>
-                          </a:solidFill>
-                          <a:latin typeface="Times New Roman" panose="02020603050405020304" pitchFamily="18" charset="0"/>
-                          <a:cs typeface="Times New Roman" panose="02020603050405020304" pitchFamily="18" charset="0"/>
-                        </a:rPr>
-                        <a:t>Reproducibility</a:t>
-                      </a:r>
-                    </a:p>
-                  </a:txBody>
-                  <a:tcPr marL="73152" marR="73152" marT="45720" marB="45720" anchor="ctr">
-                    <a:lnL w="9525">
-                      <a:solidFill>
-                        <a:srgbClr val="C9D3E0"/>
-                      </a:solidFill>
-                    </a:lnL>
-                    <a:lnR w="9525">
-                      <a:solidFill>
-                        <a:srgbClr val="C9D3E0"/>
-                      </a:solidFill>
-                    </a:lnR>
-                    <a:lnT w="9525">
-                      <a:solidFill>
-                        <a:srgbClr val="C9D3E0"/>
-                      </a:solidFill>
-                    </a:lnT>
-                    <a:lnB w="9525">
-                      <a:solidFill>
-                        <a:srgbClr val="C9D3E0"/>
-                      </a:solidFill>
-                    </a:lnB>
-                    <a:solidFill>
-                      <a:srgbClr val="FFFFFF"/>
-                    </a:solidFill>
-                  </a:tcPr>
-                </a:tc>
-                <a:tc>
-                  <a:txBody>
-                    <a:bodyPr/>
-                    <a:lstStyle/>
-                    <a:p>
-                      <a:pPr marL="0" indent="0" algn="l">
-                        <a:lnSpc>
-                          <a:spcPct val="100000"/>
-                        </a:lnSpc>
-                        <a:spcBef>
-                          <a:spcPts val="0"/>
-                        </a:spcBef>
-                        <a:spcAft>
-                          <a:spcPts val="0"/>
-                        </a:spcAft>
-                        <a:buNone/>
-                      </a:pPr>
-                      <a:r>
-                        <a:rPr lang="en-IN" sz="1300" dirty="0">
-                          <a:solidFill>
-                            <a:srgbClr val="1F2328"/>
-                          </a:solidFill>
-                          <a:latin typeface="Times New Roman" panose="02020603050405020304" pitchFamily="18" charset="0"/>
-                          <a:cs typeface="Times New Roman" panose="02020603050405020304" pitchFamily="18" charset="0"/>
-                        </a:rPr>
-                        <a:t>Re-running gives the same outputs</a:t>
-                      </a:r>
-                    </a:p>
-                  </a:txBody>
-                  <a:tcPr marL="73152" marR="73152" marT="45720" marB="45720" anchor="ctr">
-                    <a:lnL w="9525">
-                      <a:solidFill>
-                        <a:srgbClr val="C9D3E0"/>
-                      </a:solidFill>
-                    </a:lnL>
-                    <a:lnR w="9525">
-                      <a:solidFill>
-                        <a:srgbClr val="C9D3E0"/>
-                      </a:solidFill>
-                    </a:lnR>
-                    <a:lnT w="9525">
-                      <a:solidFill>
-                        <a:srgbClr val="C9D3E0"/>
-                      </a:solidFill>
-                    </a:lnT>
-                    <a:lnB w="9525">
-                      <a:solidFill>
-                        <a:srgbClr val="C9D3E0"/>
-                      </a:solidFill>
-                    </a:lnB>
-                    <a:solidFill>
-                      <a:srgbClr val="FFFFFF"/>
-                    </a:solidFill>
-                  </a:tcPr>
-                </a:tc>
-                <a:tc>
-                  <a:txBody>
-                    <a:bodyPr/>
-                    <a:lstStyle/>
-                    <a:p>
-                      <a:pPr marL="0" indent="0" algn="l">
-                        <a:lnSpc>
-                          <a:spcPct val="100000"/>
-                        </a:lnSpc>
-                        <a:spcBef>
-                          <a:spcPts val="0"/>
-                        </a:spcBef>
-                        <a:spcAft>
-                          <a:spcPts val="0"/>
-                        </a:spcAft>
-                        <a:buNone/>
-                      </a:pPr>
-                      <a:r>
-                        <a:rPr lang="en-IN" sz="1300" dirty="0">
-                          <a:solidFill>
-                            <a:srgbClr val="1F2328"/>
-                          </a:solidFill>
-                          <a:latin typeface="Times New Roman" panose="02020603050405020304" pitchFamily="18" charset="0"/>
-                          <a:cs typeface="Times New Roman" panose="02020603050405020304" pitchFamily="18" charset="0"/>
-                        </a:rPr>
-                        <a:t>All tracked results byte-identical</a:t>
-                      </a:r>
-                    </a:p>
-                  </a:txBody>
-                  <a:tcPr marL="73152" marR="73152" marT="45720" marB="45720" anchor="ctr">
-                    <a:lnL w="9525">
-                      <a:solidFill>
-                        <a:srgbClr val="C9D3E0"/>
-                      </a:solidFill>
-                    </a:lnL>
-                    <a:lnR w="9525">
-                      <a:solidFill>
-                        <a:srgbClr val="C9D3E0"/>
-                      </a:solidFill>
-                    </a:lnR>
-                    <a:lnT w="9525">
-                      <a:solidFill>
-                        <a:srgbClr val="C9D3E0"/>
-                      </a:solidFill>
-                    </a:lnT>
-                    <a:lnB w="9525">
-                      <a:solidFill>
-                        <a:srgbClr val="C9D3E0"/>
-                      </a:solidFill>
-                    </a:lnB>
-                    <a:solidFill>
-                      <a:srgbClr val="FFFFFF"/>
-                    </a:solidFill>
-                  </a:tcPr>
-                </a:tc>
-              </a:tr>
-              <a:tr h="521208">
-                <a:tc>
-                  <a:txBody>
-                    <a:bodyPr/>
-                    <a:lstStyle/>
-                    <a:p>
-                      <a:pPr marL="0" indent="0" algn="l">
-                        <a:lnSpc>
-                          <a:spcPct val="100000"/>
-                        </a:lnSpc>
-                        <a:spcBef>
-                          <a:spcPts val="0"/>
-                        </a:spcBef>
-                        <a:spcAft>
-                          <a:spcPts val="0"/>
-                        </a:spcAft>
-                        <a:buNone/>
-                      </a:pPr>
-                      <a:r>
-                        <a:rPr lang="en-IN" sz="1300" dirty="0">
-                          <a:solidFill>
-                            <a:srgbClr val="1F2328"/>
-                          </a:solidFill>
-                          <a:latin typeface="Times New Roman" panose="02020603050405020304" pitchFamily="18" charset="0"/>
-                          <a:cs typeface="Times New Roman" panose="02020603050405020304" pitchFamily="18" charset="0"/>
-                        </a:rPr>
-                        <a:t>SQL cross-check</a:t>
-                      </a:r>
-                    </a:p>
-                  </a:txBody>
-                  <a:tcPr marL="73152" marR="73152" marT="45720" marB="45720" anchor="ctr">
-                    <a:lnL w="9525">
-                      <a:solidFill>
-                        <a:srgbClr val="C9D3E0"/>
-                      </a:solidFill>
-                    </a:lnL>
-                    <a:lnR w="9525">
-                      <a:solidFill>
-                        <a:srgbClr val="C9D3E0"/>
-                      </a:solidFill>
-                    </a:lnR>
-                    <a:lnT w="9525">
-                      <a:solidFill>
-                        <a:srgbClr val="C9D3E0"/>
-                      </a:solidFill>
-                    </a:lnT>
-                    <a:lnB w="9525">
-                      <a:solidFill>
-                        <a:srgbClr val="C9D3E0"/>
-                      </a:solidFill>
-                    </a:lnB>
-                    <a:solidFill>
-                      <a:srgbClr val="EEF3FA"/>
-                    </a:solidFill>
-                  </a:tcPr>
-                </a:tc>
-                <a:tc>
-                  <a:txBody>
-                    <a:bodyPr/>
-                    <a:lstStyle/>
-                    <a:p>
-                      <a:pPr marL="0" indent="0" algn="l">
-                        <a:lnSpc>
-                          <a:spcPct val="100000"/>
-                        </a:lnSpc>
-                        <a:spcBef>
-                          <a:spcPts val="0"/>
-                        </a:spcBef>
-                        <a:spcAft>
-                          <a:spcPts val="0"/>
-                        </a:spcAft>
-                        <a:buNone/>
-                      </a:pPr>
-                      <a:r>
-                        <a:rPr lang="en-IN" sz="1300" dirty="0">
-                          <a:solidFill>
-                            <a:srgbClr val="1F2328"/>
-                          </a:solidFill>
-                          <a:latin typeface="Times New Roman" panose="02020603050405020304" pitchFamily="18" charset="0"/>
-                          <a:cs typeface="Times New Roman" panose="02020603050405020304" pitchFamily="18" charset="0"/>
-                        </a:rPr>
-                        <a:t>Predicate code matches independent SQL</a:t>
-                      </a:r>
-                    </a:p>
-                  </a:txBody>
-                  <a:tcPr marL="73152" marR="73152" marT="45720" marB="45720" anchor="ctr">
-                    <a:lnL w="9525">
-                      <a:solidFill>
-                        <a:srgbClr val="C9D3E0"/>
-                      </a:solidFill>
-                    </a:lnL>
-                    <a:lnR w="9525">
-                      <a:solidFill>
-                        <a:srgbClr val="C9D3E0"/>
-                      </a:solidFill>
-                    </a:lnR>
-                    <a:lnT w="9525">
-                      <a:solidFill>
-                        <a:srgbClr val="C9D3E0"/>
-                      </a:solidFill>
-                    </a:lnT>
-                    <a:lnB w="9525">
-                      <a:solidFill>
-                        <a:srgbClr val="C9D3E0"/>
-                      </a:solidFill>
-                    </a:lnB>
-                    <a:solidFill>
-                      <a:srgbClr val="EEF3FA"/>
-                    </a:solidFill>
-                  </a:tcPr>
-                </a:tc>
-                <a:tc>
-                  <a:txBody>
-                    <a:bodyPr/>
-                    <a:lstStyle/>
-                    <a:p>
-                      <a:pPr marL="0" indent="0" algn="l">
-                        <a:lnSpc>
-                          <a:spcPct val="100000"/>
-                        </a:lnSpc>
-                        <a:spcBef>
-                          <a:spcPts val="0"/>
-                        </a:spcBef>
-                        <a:spcAft>
-                          <a:spcPts val="0"/>
-                        </a:spcAft>
-                        <a:buNone/>
-                      </a:pPr>
-                      <a:r>
-                        <a:rPr lang="en-IN" sz="1300" dirty="0">
-                          <a:solidFill>
-                            <a:srgbClr val="1F2328"/>
-                          </a:solidFill>
-                          <a:latin typeface="Times New Roman" panose="02020603050405020304" pitchFamily="18" charset="0"/>
-                          <a:cs typeface="Times New Roman" panose="02020603050405020304" pitchFamily="18" charset="0"/>
-                        </a:rPr>
-                        <a:t>4 of 4 CROP rules exact</a:t>
-                      </a:r>
-                    </a:p>
-                  </a:txBody>
-                  <a:tcPr marL="73152" marR="73152" marT="45720" marB="45720" anchor="ctr">
-                    <a:lnL w="9525">
-                      <a:solidFill>
-                        <a:srgbClr val="C9D3E0"/>
-                      </a:solidFill>
-                    </a:lnL>
-                    <a:lnR w="9525">
-                      <a:solidFill>
-                        <a:srgbClr val="C9D3E0"/>
-                      </a:solidFill>
-                    </a:lnR>
-                    <a:lnT w="9525">
-                      <a:solidFill>
-                        <a:srgbClr val="C9D3E0"/>
-                      </a:solidFill>
-                    </a:lnT>
-                    <a:lnB w="9525">
-                      <a:solidFill>
-                        <a:srgbClr val="C9D3E0"/>
-                      </a:solidFill>
-                    </a:lnB>
-                    <a:solidFill>
-                      <a:srgbClr val="EEF3FA"/>
-                    </a:solidFill>
-                  </a:tcPr>
-                </a:tc>
-              </a:tr>
-              <a:tr h="521208">
-                <a:tc>
-                  <a:txBody>
-                    <a:bodyPr/>
-                    <a:lstStyle/>
-                    <a:p>
-                      <a:pPr marL="0" indent="0" algn="l">
-                        <a:lnSpc>
-                          <a:spcPct val="100000"/>
-                        </a:lnSpc>
-                        <a:spcBef>
-                          <a:spcPts val="0"/>
-                        </a:spcBef>
-                        <a:spcAft>
-                          <a:spcPts val="0"/>
-                        </a:spcAft>
-                        <a:buNone/>
-                      </a:pPr>
-                      <a:r>
-                        <a:rPr lang="en-IN" sz="1300" dirty="0">
-                          <a:solidFill>
-                            <a:srgbClr val="1F2328"/>
-                          </a:solidFill>
-                          <a:latin typeface="Times New Roman" panose="02020603050405020304" pitchFamily="18" charset="0"/>
-                          <a:cs typeface="Times New Roman" panose="02020603050405020304" pitchFamily="18" charset="0"/>
-                        </a:rPr>
-                        <a:t>Brute-force self-check</a:t>
-                      </a:r>
-                    </a:p>
-                  </a:txBody>
-                  <a:tcPr marL="73152" marR="73152" marT="45720" marB="45720" anchor="ctr">
-                    <a:lnL w="9525">
-                      <a:solidFill>
-                        <a:srgbClr val="C9D3E0"/>
-                      </a:solidFill>
-                    </a:lnL>
-                    <a:lnR w="9525">
-                      <a:solidFill>
-                        <a:srgbClr val="C9D3E0"/>
-                      </a:solidFill>
-                    </a:lnR>
-                    <a:lnT w="9525">
-                      <a:solidFill>
-                        <a:srgbClr val="C9D3E0"/>
-                      </a:solidFill>
-                    </a:lnT>
-                    <a:lnB w="9525">
-                      <a:solidFill>
-                        <a:srgbClr val="C9D3E0"/>
-                      </a:solidFill>
-                    </a:lnB>
-                    <a:solidFill>
-                      <a:srgbClr val="FFFFFF"/>
-                    </a:solidFill>
-                  </a:tcPr>
-                </a:tc>
-                <a:tc>
-                  <a:txBody>
-                    <a:bodyPr/>
-                    <a:lstStyle/>
-                    <a:p>
-                      <a:pPr marL="0" indent="0" algn="l">
-                        <a:lnSpc>
-                          <a:spcPct val="100000"/>
-                        </a:lnSpc>
-                        <a:spcBef>
-                          <a:spcPts val="0"/>
-                        </a:spcBef>
-                        <a:spcAft>
-                          <a:spcPts val="0"/>
-                        </a:spcAft>
-                        <a:buNone/>
-                      </a:pPr>
-                      <a:r>
-                        <a:rPr lang="en-IN" sz="1300" dirty="0">
-                          <a:solidFill>
-                            <a:srgbClr val="1F2328"/>
-                          </a:solidFill>
-                          <a:latin typeface="Times New Roman" panose="02020603050405020304" pitchFamily="18" charset="0"/>
-                          <a:cs typeface="Times New Roman" panose="02020603050405020304" pitchFamily="18" charset="0"/>
-                        </a:rPr>
-                        <a:t>Fast code equals plain Python</a:t>
-                      </a:r>
-                    </a:p>
-                  </a:txBody>
-                  <a:tcPr marL="73152" marR="73152" marT="45720" marB="45720" anchor="ctr">
-                    <a:lnL w="9525">
-                      <a:solidFill>
-                        <a:srgbClr val="C9D3E0"/>
-                      </a:solidFill>
-                    </a:lnL>
-                    <a:lnR w="9525">
-                      <a:solidFill>
-                        <a:srgbClr val="C9D3E0"/>
-                      </a:solidFill>
-                    </a:lnR>
-                    <a:lnT w="9525">
-                      <a:solidFill>
-                        <a:srgbClr val="C9D3E0"/>
-                      </a:solidFill>
-                    </a:lnT>
-                    <a:lnB w="9525">
-                      <a:solidFill>
-                        <a:srgbClr val="C9D3E0"/>
-                      </a:solidFill>
-                    </a:lnB>
-                    <a:solidFill>
-                      <a:srgbClr val="FFFFFF"/>
-                    </a:solidFill>
-                  </a:tcPr>
-                </a:tc>
-                <a:tc>
-                  <a:txBody>
-                    <a:bodyPr/>
-                    <a:lstStyle/>
-                    <a:p>
-                      <a:pPr marL="0" indent="0" algn="l">
-                        <a:lnSpc>
-                          <a:spcPct val="100000"/>
-                        </a:lnSpc>
-                        <a:spcBef>
-                          <a:spcPts val="0"/>
-                        </a:spcBef>
-                        <a:spcAft>
-                          <a:spcPts val="0"/>
-                        </a:spcAft>
-                        <a:buNone/>
-                      </a:pPr>
-                      <a:r>
-                        <a:rPr lang="en-IN" sz="1300" dirty="0">
-                          <a:solidFill>
-                            <a:srgbClr val="1F2328"/>
-                          </a:solidFill>
-                          <a:latin typeface="Times New Roman" panose="02020603050405020304" pitchFamily="18" charset="0"/>
-                          <a:cs typeface="Times New Roman" panose="02020603050405020304" pitchFamily="18" charset="0"/>
-                        </a:rPr>
-                        <a:t>Event pairs identical on 4 case notions</a:t>
-                      </a:r>
-                    </a:p>
-                  </a:txBody>
-                  <a:tcPr marL="73152" marR="73152" marT="45720" marB="45720" anchor="ctr">
-                    <a:lnL w="9525">
-                      <a:solidFill>
-                        <a:srgbClr val="C9D3E0"/>
-                      </a:solidFill>
-                    </a:lnL>
-                    <a:lnR w="9525">
-                      <a:solidFill>
-                        <a:srgbClr val="C9D3E0"/>
-                      </a:solidFill>
-                    </a:lnR>
-                    <a:lnT w="9525">
-                      <a:solidFill>
-                        <a:srgbClr val="C9D3E0"/>
-                      </a:solidFill>
-                    </a:lnT>
-                    <a:lnB w="9525">
-                      <a:solidFill>
-                        <a:srgbClr val="C9D3E0"/>
-                      </a:solidFill>
-                    </a:lnB>
-                    <a:solidFill>
-                      <a:srgbClr val="FFFFFF"/>
-                    </a:solidFill>
-                  </a:tcPr>
-                </a:tc>
-              </a:tr>
-              <a:tr h="521208">
-                <a:tc>
-                  <a:txBody>
-                    <a:bodyPr/>
-                    <a:lstStyle/>
-                    <a:p>
-                      <a:pPr marL="0" indent="0" algn="l">
-                        <a:lnSpc>
-                          <a:spcPct val="100000"/>
-                        </a:lnSpc>
-                        <a:spcBef>
-                          <a:spcPts val="0"/>
-                        </a:spcBef>
-                        <a:spcAft>
-                          <a:spcPts val="0"/>
-                        </a:spcAft>
-                        <a:buNone/>
-                      </a:pPr>
-                      <a:r>
-                        <a:rPr lang="en-IN" sz="1300" dirty="0">
-                          <a:solidFill>
-                            <a:srgbClr val="1F2328"/>
-                          </a:solidFill>
-                          <a:latin typeface="Times New Roman" panose="02020603050405020304" pitchFamily="18" charset="0"/>
-                          <a:cs typeface="Times New Roman" panose="02020603050405020304" pitchFamily="18" charset="0"/>
-                        </a:rPr>
-                        <a:t>Distortion self-check</a:t>
-                      </a:r>
-                    </a:p>
-                  </a:txBody>
-                  <a:tcPr marL="73152" marR="73152" marT="45720" marB="45720" anchor="ctr">
-                    <a:lnL w="9525">
-                      <a:solidFill>
-                        <a:srgbClr val="C9D3E0"/>
-                      </a:solidFill>
-                    </a:lnL>
-                    <a:lnR w="9525">
-                      <a:solidFill>
-                        <a:srgbClr val="C9D3E0"/>
-                      </a:solidFill>
-                    </a:lnR>
-                    <a:lnT w="9525">
-                      <a:solidFill>
-                        <a:srgbClr val="C9D3E0"/>
-                      </a:solidFill>
-                    </a:lnT>
-                    <a:lnB w="9525">
-                      <a:solidFill>
-                        <a:srgbClr val="C9D3E0"/>
-                      </a:solidFill>
-                    </a:lnB>
-                    <a:solidFill>
-                      <a:srgbClr val="EEF3FA"/>
-                    </a:solidFill>
-                  </a:tcPr>
-                </a:tc>
-                <a:tc>
-                  <a:txBody>
-                    <a:bodyPr/>
-                    <a:lstStyle/>
-                    <a:p>
-                      <a:pPr marL="0" indent="0" algn="l">
-                        <a:lnSpc>
-                          <a:spcPct val="100000"/>
-                        </a:lnSpc>
-                        <a:spcBef>
-                          <a:spcPts val="0"/>
-                        </a:spcBef>
-                        <a:spcAft>
-                          <a:spcPts val="0"/>
-                        </a:spcAft>
-                        <a:buNone/>
-                      </a:pPr>
-                      <a:r>
-                        <a:rPr lang="en-IN" sz="1300" dirty="0">
-                          <a:solidFill>
-                            <a:srgbClr val="1F2328"/>
-                          </a:solidFill>
-                          <a:latin typeface="Times New Roman" panose="02020603050405020304" pitchFamily="18" charset="0"/>
-                          <a:cs typeface="Times New Roman" panose="02020603050405020304" pitchFamily="18" charset="0"/>
-                        </a:rPr>
-                        <a:t>Pandas metrics equal a plain-Python version</a:t>
-                      </a:r>
-                    </a:p>
-                  </a:txBody>
-                  <a:tcPr marL="73152" marR="73152" marT="45720" marB="45720" anchor="ctr">
-                    <a:lnL w="9525">
-                      <a:solidFill>
-                        <a:srgbClr val="C9D3E0"/>
-                      </a:solidFill>
-                    </a:lnL>
-                    <a:lnR w="9525">
-                      <a:solidFill>
-                        <a:srgbClr val="C9D3E0"/>
-                      </a:solidFill>
-                    </a:lnR>
-                    <a:lnT w="9525">
-                      <a:solidFill>
-                        <a:srgbClr val="C9D3E0"/>
-                      </a:solidFill>
-                    </a:lnT>
-                    <a:lnB w="9525">
-                      <a:solidFill>
-                        <a:srgbClr val="C9D3E0"/>
-                      </a:solidFill>
-                    </a:lnB>
-                    <a:solidFill>
-                      <a:srgbClr val="EEF3FA"/>
-                    </a:solidFill>
-                  </a:tcPr>
-                </a:tc>
-                <a:tc>
-                  <a:txBody>
-                    <a:bodyPr/>
-                    <a:lstStyle/>
-                    <a:p>
-                      <a:pPr marL="0" indent="0" algn="l">
-                        <a:lnSpc>
-                          <a:spcPct val="100000"/>
-                        </a:lnSpc>
-                        <a:spcBef>
-                          <a:spcPts val="0"/>
-                        </a:spcBef>
-                        <a:spcAft>
-                          <a:spcPts val="0"/>
-                        </a:spcAft>
-                        <a:buNone/>
-                      </a:pPr>
-                      <a:r>
-                        <a:rPr lang="en-IN" sz="1300" dirty="0">
-                          <a:solidFill>
-                            <a:srgbClr val="1F2328"/>
-                          </a:solidFill>
-                          <a:latin typeface="Times New Roman" panose="02020603050405020304" pitchFamily="18" charset="0"/>
-                          <a:cs typeface="Times New Roman" panose="02020603050405020304" pitchFamily="18" charset="0"/>
-                        </a:rPr>
-                        <a:t>60 case notions identical on 3 real slices</a:t>
-                      </a:r>
-                    </a:p>
-                  </a:txBody>
-                  <a:tcPr marL="73152" marR="73152" marT="45720" marB="45720" anchor="ctr">
-                    <a:lnL w="9525">
-                      <a:solidFill>
-                        <a:srgbClr val="C9D3E0"/>
-                      </a:solidFill>
-                    </a:lnL>
-                    <a:lnR w="9525">
-                      <a:solidFill>
-                        <a:srgbClr val="C9D3E0"/>
-                      </a:solidFill>
-                    </a:lnR>
-                    <a:lnT w="9525">
-                      <a:solidFill>
-                        <a:srgbClr val="C9D3E0"/>
-                      </a:solidFill>
-                    </a:lnT>
-                    <a:lnB w="9525">
-                      <a:solidFill>
-                        <a:srgbClr val="C9D3E0"/>
-                      </a:solidFill>
-                    </a:lnB>
-                    <a:solidFill>
-                      <a:srgbClr val="EEF3FA"/>
-                    </a:solidFill>
-                  </a:tcPr>
-                </a:tc>
-              </a:tr>
-              <a:tr h="521208">
-                <a:tc>
-                  <a:txBody>
-                    <a:bodyPr/>
-                    <a:lstStyle/>
-                    <a:p>
-                      <a:pPr marL="0" indent="0" algn="l">
-                        <a:lnSpc>
-                          <a:spcPct val="100000"/>
-                        </a:lnSpc>
-                        <a:spcBef>
-                          <a:spcPts val="0"/>
-                        </a:spcBef>
-                        <a:spcAft>
-                          <a:spcPts val="0"/>
-                        </a:spcAft>
-                        <a:buNone/>
-                      </a:pPr>
-                      <a:r>
-                        <a:rPr lang="en-IN" sz="1300" dirty="0">
-                          <a:solidFill>
-                            <a:srgbClr val="1F2328"/>
-                          </a:solidFill>
-                          <a:latin typeface="Times New Roman" panose="02020603050405020304" pitchFamily="18" charset="0"/>
-                          <a:cs typeface="Times New Roman" panose="02020603050405020304" pitchFamily="18" charset="0"/>
-                        </a:rPr>
-                        <a:t>Independent recomputation</a:t>
-                      </a:r>
-                    </a:p>
-                  </a:txBody>
-                  <a:tcPr marL="73152" marR="73152" marT="45720" marB="45720" anchor="ctr">
-                    <a:lnL w="9525">
-                      <a:solidFill>
-                        <a:srgbClr val="C9D3E0"/>
-                      </a:solidFill>
-                    </a:lnL>
-                    <a:lnR w="9525">
-                      <a:solidFill>
-                        <a:srgbClr val="C9D3E0"/>
-                      </a:solidFill>
-                    </a:lnR>
-                    <a:lnT w="9525">
-                      <a:solidFill>
-                        <a:srgbClr val="C9D3E0"/>
-                      </a:solidFill>
-                    </a:lnT>
-                    <a:lnB w="9525">
-                      <a:solidFill>
-                        <a:srgbClr val="C9D3E0"/>
-                      </a:solidFill>
-                    </a:lnB>
-                    <a:solidFill>
-                      <a:srgbClr val="FFFFFF"/>
-                    </a:solidFill>
-                  </a:tcPr>
-                </a:tc>
-                <a:tc>
-                  <a:txBody>
-                    <a:bodyPr/>
-                    <a:lstStyle/>
-                    <a:p>
-                      <a:pPr marL="0" indent="0" algn="l">
-                        <a:lnSpc>
-                          <a:spcPct val="100000"/>
-                        </a:lnSpc>
-                        <a:spcBef>
-                          <a:spcPts val="0"/>
-                        </a:spcBef>
-                        <a:spcAft>
-                          <a:spcPts val="0"/>
-                        </a:spcAft>
-                        <a:buNone/>
-                      </a:pPr>
-                      <a:r>
-                        <a:rPr lang="en-IN" sz="1300" dirty="0">
-                          <a:solidFill>
-                            <a:srgbClr val="1F2328"/>
-                          </a:solidFill>
-                          <a:latin typeface="Times New Roman" panose="02020603050405020304" pitchFamily="18" charset="0"/>
-                          <a:cs typeface="Times New Roman" panose="02020603050405020304" pitchFamily="18" charset="0"/>
-                        </a:rPr>
-                        <a:t>OULAD counts match raw CSVs</a:t>
-                      </a:r>
-                    </a:p>
-                  </a:txBody>
-                  <a:tcPr marL="73152" marR="73152" marT="45720" marB="45720" anchor="ctr">
-                    <a:lnL w="9525">
-                      <a:solidFill>
-                        <a:srgbClr val="C9D3E0"/>
-                      </a:solidFill>
-                    </a:lnL>
-                    <a:lnR w="9525">
-                      <a:solidFill>
-                        <a:srgbClr val="C9D3E0"/>
-                      </a:solidFill>
-                    </a:lnR>
-                    <a:lnT w="9525">
-                      <a:solidFill>
-                        <a:srgbClr val="C9D3E0"/>
-                      </a:solidFill>
-                    </a:lnT>
-                    <a:lnB w="9525">
-                      <a:solidFill>
-                        <a:srgbClr val="C9D3E0"/>
-                      </a:solidFill>
-                    </a:lnB>
-                    <a:solidFill>
-                      <a:srgbClr val="FFFFFF"/>
-                    </a:solidFill>
-                  </a:tcPr>
-                </a:tc>
-                <a:tc>
-                  <a:txBody>
-                    <a:bodyPr/>
-                    <a:lstStyle/>
-                    <a:p>
-                      <a:pPr marL="0" indent="0" algn="l">
-                        <a:lnSpc>
-                          <a:spcPct val="100000"/>
-                        </a:lnSpc>
-                        <a:spcBef>
-                          <a:spcPts val="0"/>
-                        </a:spcBef>
-                        <a:spcAft>
-                          <a:spcPts val="0"/>
-                        </a:spcAft>
-                        <a:buNone/>
-                      </a:pPr>
-                      <a:r>
-                        <a:rPr lang="en-IN" sz="1300" dirty="0">
-                          <a:solidFill>
-                            <a:srgbClr val="1F2328"/>
-                          </a:solidFill>
-                          <a:latin typeface="Times New Roman" panose="02020603050405020304" pitchFamily="18" charset="0"/>
-                          <a:cs typeface="Times New Roman" panose="02020603050405020304" pitchFamily="18" charset="0"/>
-                        </a:rPr>
-                        <a:t>15,348 / 415 / 29 exact</a:t>
-                      </a:r>
-                    </a:p>
-                  </a:txBody>
-                  <a:tcPr marL="73152" marR="73152" marT="45720" marB="45720" anchor="ctr">
-                    <a:lnL w="9525">
-                      <a:solidFill>
-                        <a:srgbClr val="C9D3E0"/>
-                      </a:solidFill>
-                    </a:lnL>
-                    <a:lnR w="9525">
-                      <a:solidFill>
-                        <a:srgbClr val="C9D3E0"/>
-                      </a:solidFill>
-                    </a:lnR>
-                    <a:lnT w="9525">
-                      <a:solidFill>
-                        <a:srgbClr val="C9D3E0"/>
-                      </a:solidFill>
-                    </a:lnT>
-                    <a:lnB w="9525">
-                      <a:solidFill>
-                        <a:srgbClr val="C9D3E0"/>
-                      </a:solidFill>
-                    </a:lnB>
-                    <a:solidFill>
-                      <a:srgbClr val="FFFFFF"/>
-                    </a:solidFill>
-                  </a:tcPr>
-                </a:tc>
-              </a:tr>
-              <a:tr h="521208">
-                <a:tc>
-                  <a:txBody>
-                    <a:bodyPr/>
-                    <a:lstStyle/>
-                    <a:p>
-                      <a:pPr marL="0" indent="0" algn="l">
-                        <a:lnSpc>
-                          <a:spcPct val="100000"/>
-                        </a:lnSpc>
-                        <a:spcBef>
-                          <a:spcPts val="0"/>
-                        </a:spcBef>
-                        <a:spcAft>
-                          <a:spcPts val="0"/>
-                        </a:spcAft>
-                        <a:buNone/>
-                      </a:pPr>
-                      <a:r>
-                        <a:rPr lang="en-IN" sz="1300" dirty="0">
-                          <a:solidFill>
-                            <a:srgbClr val="1F2328"/>
-                          </a:solidFill>
-                          <a:latin typeface="Times New Roman" panose="02020603050405020304" pitchFamily="18" charset="0"/>
-                          <a:cs typeface="Times New Roman" panose="02020603050405020304" pitchFamily="18" charset="0"/>
-                        </a:rPr>
-                        <a:t>Bugs our own checks found</a:t>
-                      </a:r>
-                    </a:p>
-                  </a:txBody>
-                  <a:tcPr marL="73152" marR="73152" marT="45720" marB="45720" anchor="ctr">
-                    <a:lnL w="9525">
-                      <a:solidFill>
-                        <a:srgbClr val="C9D3E0"/>
-                      </a:solidFill>
-                    </a:lnL>
-                    <a:lnR w="9525">
-                      <a:solidFill>
-                        <a:srgbClr val="C9D3E0"/>
-                      </a:solidFill>
-                    </a:lnR>
-                    <a:lnT w="9525">
-                      <a:solidFill>
-                        <a:srgbClr val="C9D3E0"/>
-                      </a:solidFill>
-                    </a:lnT>
-                    <a:lnB w="9525">
-                      <a:solidFill>
-                        <a:srgbClr val="C9D3E0"/>
-                      </a:solidFill>
-                    </a:lnB>
-                    <a:solidFill>
-                      <a:srgbClr val="EEF3FA"/>
-                    </a:solidFill>
-                  </a:tcPr>
-                </a:tc>
-                <a:tc>
-                  <a:txBody>
-                    <a:bodyPr/>
-                    <a:lstStyle/>
-                    <a:p>
-                      <a:pPr marL="0" indent="0" algn="l">
-                        <a:lnSpc>
-                          <a:spcPct val="100000"/>
-                        </a:lnSpc>
-                        <a:spcBef>
-                          <a:spcPts val="0"/>
-                        </a:spcBef>
-                        <a:spcAft>
-                          <a:spcPts val="0"/>
-                        </a:spcAft>
-                        <a:buNone/>
-                      </a:pPr>
-                      <a:r>
-                        <a:rPr lang="en-IN" sz="1300" dirty="0">
-                          <a:solidFill>
-                            <a:srgbClr val="1F2328"/>
-                          </a:solidFill>
-                          <a:latin typeface="Times New Roman" panose="02020603050405020304" pitchFamily="18" charset="0"/>
-                          <a:cs typeface="Times New Roman" panose="02020603050405020304" pitchFamily="18" charset="0"/>
-                        </a:rPr>
-                        <a:t>Verification is not a formality</a:t>
-                      </a:r>
-                    </a:p>
-                  </a:txBody>
-                  <a:tcPr marL="73152" marR="73152" marT="45720" marB="45720" anchor="ctr">
-                    <a:lnL w="9525">
-                      <a:solidFill>
-                        <a:srgbClr val="C9D3E0"/>
-                      </a:solidFill>
-                    </a:lnL>
-                    <a:lnR w="9525">
-                      <a:solidFill>
-                        <a:srgbClr val="C9D3E0"/>
-                      </a:solidFill>
-                    </a:lnR>
-                    <a:lnT w="9525">
-                      <a:solidFill>
-                        <a:srgbClr val="C9D3E0"/>
-                      </a:solidFill>
-                    </a:lnT>
-                    <a:lnB w="9525">
-                      <a:solidFill>
-                        <a:srgbClr val="C9D3E0"/>
-                      </a:solidFill>
-                    </a:lnB>
-                    <a:solidFill>
-                      <a:srgbClr val="EEF3FA"/>
-                    </a:solidFill>
-                  </a:tcPr>
-                </a:tc>
-                <a:tc>
-                  <a:txBody>
-                    <a:bodyPr/>
-                    <a:lstStyle/>
-                    <a:p>
-                      <a:pPr marL="0" indent="0" algn="l">
-                        <a:lnSpc>
-                          <a:spcPct val="100000"/>
-                        </a:lnSpc>
-                        <a:spcBef>
-                          <a:spcPts val="0"/>
-                        </a:spcBef>
-                        <a:spcAft>
-                          <a:spcPts val="0"/>
-                        </a:spcAft>
-                        <a:buNone/>
-                      </a:pPr>
-                      <a:r>
-                        <a:rPr lang="en-IN" sz="1300" dirty="0">
-                          <a:solidFill>
-                            <a:srgbClr val="1F2328"/>
-                          </a:solidFill>
-                          <a:latin typeface="Times New Roman" panose="02020603050405020304" pitchFamily="18" charset="0"/>
-                          <a:cs typeface="Times New Roman" panose="02020603050405020304" pitchFamily="18" charset="0"/>
-                        </a:rPr>
-                        <a:t>3 fixed: duplicate events, missed abandon form, tie-breaking</a:t>
-                      </a:r>
-                    </a:p>
-                  </a:txBody>
-                  <a:tcPr marL="73152" marR="73152" marT="45720" marB="45720" anchor="ctr">
-                    <a:lnL w="9525">
-                      <a:solidFill>
-                        <a:srgbClr val="C9D3E0"/>
-                      </a:solidFill>
-                    </a:lnL>
-                    <a:lnR w="9525">
-                      <a:solidFill>
-                        <a:srgbClr val="C9D3E0"/>
-                      </a:solidFill>
-                    </a:lnR>
-                    <a:lnT w="9525">
-                      <a:solidFill>
-                        <a:srgbClr val="C9D3E0"/>
-                      </a:solidFill>
-                    </a:lnT>
-                    <a:lnB w="9525">
-                      <a:solidFill>
-                        <a:srgbClr val="C9D3E0"/>
-                      </a:solidFill>
-                    </a:lnB>
-                    <a:solidFill>
-                      <a:srgbClr val="EEF3FA"/>
-                    </a:solidFill>
-                  </a:tcPr>
-                </a:tc>
-              </a:tr>
-            </a:tbl>
-          </a:graphicData>
-        </a:graphic>
-      </p:graphicFrame>
-      <p:sp>
-        <p:nvSpPr>
-          <p:cNvPr id="4" name="Limits 4"/>
+        </p:nvPicPr>
+        <p:blipFill>
+          <a:blip r:embed="rId2"/>
+          <a:stretch>
+            <a:fillRect/>
+          </a:stretch>
+        </p:blipFill>
+        <p:spPr>
+          <a:xfrm>
+            <a:off x="365760" y="1280160"/>
+            <a:ext cx="7223760" cy="4260166"/>
+          </a:xfrm>
+          <a:prstGeom prst="rect">
+            <a:avLst/>
+          </a:prstGeom>
+        </p:spPr>
+      </p:pic>
+      <p:sp>
+        <p:nvSpPr>
+          <p:cNvPr id="4" name="Takeaways 4"/>
           <p:cNvSpPr txBox="1"/>
           <p:nvPr/>
         </p:nvSpPr>
         <p:spPr>
           <a:xfrm>
-            <a:off x="457200" y="5486400"/>
-            <a:ext cx="11274552" cy="685800"/>
+            <a:off x="7772400" y="1371600"/>
+            <a:ext cx="3959352" cy="4754880"/>
           </a:xfrm>
           <a:prstGeom prst="roundRect">
             <a:avLst>
@@ -10890,7 +9613,7 @@
           </a:ln>
         </p:spPr>
         <p:txBody>
-          <a:bodyPr wrap="square" lIns="109728" tIns="76810" rIns="109728" bIns="76810" rtlCol="0" anchor="ctr">
+          <a:bodyPr wrap="square" lIns="109728" tIns="76810" rIns="109728" bIns="76810" rtlCol="0" anchor="t">
             <a:noAutofit/>
           </a:bodyPr>
           <a:lstStyle/>
@@ -10903,19 +9626,44 @@
                 <a:spcPts val="0"/>
               </a:spcBef>
               <a:spcAft>
-                <a:spcPts val="0"/>
+                <a:spcPts val="400"/>
               </a:spcAft>
               <a:buNone/>
             </a:pPr>
             <a:r>
-              <a:rPr lang="en-IN" sz="1500" b="1" dirty="0">
+              <a:rPr lang="en-IN" sz="1600" b="1" dirty="0">
                 <a:solidFill>
-                  <a:srgbClr val="EB6834"/>
+                  <a:srgbClr val="2A78D6"/>
                 </a:solidFill>
                 <a:latin typeface="Times New Roman" panose="02020603050405020304" pitchFamily="18" charset="0"/>
                 <a:cs typeface="Times New Roman" panose="02020603050405020304" pitchFamily="18" charset="0"/>
               </a:rPr>
-              <a:t>What we did not do: </a:t>
+              <a:t>What a miner gives you</a:t>
+            </a:r>
+          </a:p>
+          <a:p>
+            <a:pPr marL="285750" indent="-285750" algn="l">
+              <a:lnSpc>
+                <a:spcPct val="100000"/>
+              </a:lnSpc>
+              <a:spcBef>
+                <a:spcPts val="900"/>
+              </a:spcBef>
+              <a:spcAft>
+                <a:spcPts val="0"/>
+              </a:spcAft>
+              <a:buFont typeface="Arial" panose="020B0604020202020204" pitchFamily="34" charset="0"/>
+              <a:buChar char="•"/>
+            </a:pPr>
+            <a:r>
+              <a:rPr lang="en-IN" sz="1500" b="1" dirty="0">
+                <a:solidFill>
+                  <a:srgbClr val="1F2328"/>
+                </a:solidFill>
+                <a:latin typeface="Times New Roman" panose="02020603050405020304" pitchFamily="18" charset="0"/>
+                <a:cs typeface="Times New Roman" panose="02020603050405020304" pitchFamily="18" charset="0"/>
+              </a:rPr>
+              <a:t>35 of 38 </a:t>
             </a:r>
             <a:r>
               <a:rPr lang="en-IN" sz="1500" dirty="0">
@@ -10925,7 +9673,112 @@
                 <a:latin typeface="Times New Roman" panose="02020603050405020304" pitchFamily="18" charset="0"/>
                 <a:cs typeface="Times New Roman" panose="02020603050405020304" pitchFamily="18" charset="0"/>
               </a:rPr>
-              <a:t>independent human labelling; the distortion check covers slices, not full logs; the activity rankings have no second implementation; the converters are checked by us only.</a:t>
+              <a:t>case notions mined (Inductive Miner)</a:t>
+            </a:r>
+          </a:p>
+          <a:p>
+            <a:pPr marL="285750" indent="-285750" algn="l">
+              <a:lnSpc>
+                <a:spcPct val="100000"/>
+              </a:lnSpc>
+              <a:spcBef>
+                <a:spcPts val="900"/>
+              </a:spcBef>
+              <a:spcAft>
+                <a:spcPts val="0"/>
+              </a:spcAft>
+              <a:buFont typeface="Arial" panose="020B0604020202020204" pitchFamily="34" charset="0"/>
+              <a:buChar char="•"/>
+            </a:pPr>
+            <a:r>
+              <a:rPr lang="en-IN" sz="1500" b="1" dirty="0">
+                <a:solidFill>
+                  <a:srgbClr val="1F2328"/>
+                </a:solidFill>
+                <a:latin typeface="Times New Roman" panose="02020603050405020304" pitchFamily="18" charset="0"/>
+                <a:cs typeface="Times New Roman" panose="02020603050405020304" pitchFamily="18" charset="0"/>
+              </a:rPr>
+              <a:t>Fitness 0.955 to 1.000 </a:t>
+            </a:r>
+            <a:r>
+              <a:rPr lang="en-IN" sz="1500" dirty="0">
+                <a:solidFill>
+                  <a:srgbClr val="1F2328"/>
+                </a:solidFill>
+                <a:latin typeface="Times New Roman" panose="02020603050405020304" pitchFamily="18" charset="0"/>
+                <a:cs typeface="Times New Roman" panose="02020603050405020304" pitchFamily="18" charset="0"/>
+              </a:rPr>
+              <a:t>for every model, yet 20 show under half the activities</a:t>
+            </a:r>
+          </a:p>
+          <a:p>
+            <a:pPr marL="285750" indent="-285750" algn="l">
+              <a:lnSpc>
+                <a:spcPct val="100000"/>
+              </a:lnSpc>
+              <a:spcBef>
+                <a:spcPts val="900"/>
+              </a:spcBef>
+              <a:spcAft>
+                <a:spcPts val="0"/>
+              </a:spcAft>
+              <a:buFont typeface="Arial" panose="020B0604020202020204" pitchFamily="34" charset="0"/>
+              <a:buChar char="•"/>
+            </a:pPr>
+            <a:r>
+              <a:rPr lang="en-IN" sz="1500" b="1" dirty="0">
+                <a:solidFill>
+                  <a:srgbClr val="1F2328"/>
+                </a:solidFill>
+                <a:latin typeface="Times New Roman" panose="02020603050405020304" pitchFamily="18" charset="0"/>
+                <a:cs typeface="Times New Roman" panose="02020603050405020304" pitchFamily="18" charset="0"/>
+              </a:rPr>
+              <a:t>Divergence becomes loops: </a:t>
+            </a:r>
+            <a:r>
+              <a:rPr lang="en-IN" sz="1500" dirty="0">
+                <a:solidFill>
+                  <a:srgbClr val="1F2328"/>
+                </a:solidFill>
+                <a:latin typeface="Times New Roman" panose="02020603050405020304" pitchFamily="18" charset="0"/>
+                <a:cs typeface="Times New Roman" panose="02020603050405020304" pitchFamily="18" charset="0"/>
+              </a:rPr>
+              <a:t>loop share rises with divergence (rho 0.66)</a:t>
+            </a:r>
+          </a:p>
+          <a:p>
+            <a:pPr marL="285750" indent="-285750" algn="l">
+              <a:lnSpc>
+                <a:spcPct val="100000"/>
+              </a:lnSpc>
+              <a:spcBef>
+                <a:spcPts val="900"/>
+              </a:spcBef>
+              <a:spcAft>
+                <a:spcPts val="0"/>
+              </a:spcAft>
+              <a:buFont typeface="Arial" panose="020B0604020202020204" pitchFamily="34" charset="0"/>
+              <a:buChar char="•"/>
+            </a:pPr>
+            <a:r>
+              <a:rPr lang="en-IN" sz="1500" b="1" dirty="0">
+                <a:solidFill>
+                  <a:srgbClr val="1F2328"/>
+                </a:solidFill>
+                <a:latin typeface="Times New Roman" panose="02020603050405020304" pitchFamily="18" charset="0"/>
+                <a:cs typeface="Times New Roman" panose="02020603050405020304" pitchFamily="18" charset="0"/>
+              </a:rPr>
+              <a:t>Precision as low as 0.04 </a:t>
+            </a:r>
+            <a:r>
+              <a:rPr lang="en-IN" sz="1500" dirty="0">
+                <a:solidFill>
+                  <a:srgbClr val="1F2328"/>
+                </a:solidFill>
+                <a:latin typeface="Times New Roman" panose="02020603050405020304" pitchFamily="18" charset="0"/>
+                <a:cs typeface="Times New Roman" panose="02020603050405020304" pitchFamily="18" charset="0"/>
+              </a:rPr>
+              <a:t>in models that loop over almost everything</a:t>
             </a:r>
           </a:p>
         </p:txBody>
@@ -11058,6 +9911,1731 @@
                 <a:latin typeface="Times New Roman" panose="02020603050405020304" pitchFamily="18" charset="0"/>
                 <a:cs typeface="Times New Roman" panose="02020603050405020304" pitchFamily="18" charset="0"/>
               </a:rPr>
+              <a:t>Testing and Validation</a:t>
+            </a:r>
+          </a:p>
+        </p:txBody>
+      </p:sp>
+      <p:graphicFrame>
+        <p:nvGraphicFramePr>
+          <p:cNvPr id="3" name="Table 3"/>
+          <p:cNvGraphicFramePr>
+            <a:graphicFrameLocks noGrp="1"/>
+          </p:cNvGraphicFramePr>
+          <p:nvPr/>
+        </p:nvGraphicFramePr>
+        <p:xfrm>
+          <a:off x="457200" y="1371600"/>
+          <a:ext cx="11274552" cy="3822192"/>
+        </p:xfrm>
+        <a:graphic>
+          <a:graphicData uri="http://schemas.openxmlformats.org/drawingml/2006/table">
+            <a:tbl>
+              <a:tblPr firstRow="1" bandRow="1"/>
+              <a:tblGrid>
+                <a:gridCol w="3108960"/>
+                <a:gridCol w="5120640"/>
+                <a:gridCol w="3044952"/>
+              </a:tblGrid>
+              <a:tr h="384048">
+                <a:tc>
+                  <a:txBody>
+                    <a:bodyPr/>
+                    <a:lstStyle/>
+                    <a:p>
+                      <a:pPr marL="0" indent="0" algn="l">
+                        <a:lnSpc>
+                          <a:spcPct val="100000"/>
+                        </a:lnSpc>
+                        <a:spcBef>
+                          <a:spcPts val="0"/>
+                        </a:spcBef>
+                        <a:spcAft>
+                          <a:spcPts val="0"/>
+                        </a:spcAft>
+                        <a:buNone/>
+                      </a:pPr>
+                      <a:r>
+                        <a:rPr lang="en-IN" sz="1300" b="1" dirty="0">
+                          <a:solidFill>
+                            <a:srgbClr val="FFFFFF"/>
+                          </a:solidFill>
+                          <a:latin typeface="Times New Roman" panose="02020603050405020304" pitchFamily="18" charset="0"/>
+                          <a:cs typeface="Times New Roman" panose="02020603050405020304" pitchFamily="18" charset="0"/>
+                        </a:rPr>
+                        <a:t>Check</a:t>
+                      </a:r>
+                    </a:p>
+                  </a:txBody>
+                  <a:tcPr marL="73152" marR="73152" marT="45720" marB="45720" anchor="ctr">
+                    <a:lnL w="9525">
+                      <a:solidFill>
+                        <a:srgbClr val="C9D3E0"/>
+                      </a:solidFill>
+                    </a:lnL>
+                    <a:lnR w="9525">
+                      <a:solidFill>
+                        <a:srgbClr val="C9D3E0"/>
+                      </a:solidFill>
+                    </a:lnR>
+                    <a:lnT w="9525">
+                      <a:solidFill>
+                        <a:srgbClr val="C9D3E0"/>
+                      </a:solidFill>
+                    </a:lnT>
+                    <a:lnB w="9525">
+                      <a:solidFill>
+                        <a:srgbClr val="C9D3E0"/>
+                      </a:solidFill>
+                    </a:lnB>
+                    <a:solidFill>
+                      <a:srgbClr val="2A78D6"/>
+                    </a:solidFill>
+                  </a:tcPr>
+                </a:tc>
+                <a:tc>
+                  <a:txBody>
+                    <a:bodyPr/>
+                    <a:lstStyle/>
+                    <a:p>
+                      <a:pPr marL="0" indent="0" algn="l">
+                        <a:lnSpc>
+                          <a:spcPct val="100000"/>
+                        </a:lnSpc>
+                        <a:spcBef>
+                          <a:spcPts val="0"/>
+                        </a:spcBef>
+                        <a:spcAft>
+                          <a:spcPts val="0"/>
+                        </a:spcAft>
+                        <a:buNone/>
+                      </a:pPr>
+                      <a:r>
+                        <a:rPr lang="en-IN" sz="1300" b="1" dirty="0">
+                          <a:solidFill>
+                            <a:srgbClr val="FFFFFF"/>
+                          </a:solidFill>
+                          <a:latin typeface="Times New Roman" panose="02020603050405020304" pitchFamily="18" charset="0"/>
+                          <a:cs typeface="Times New Roman" panose="02020603050405020304" pitchFamily="18" charset="0"/>
+                        </a:rPr>
+                        <a:t>What it proves</a:t>
+                      </a:r>
+                    </a:p>
+                  </a:txBody>
+                  <a:tcPr marL="73152" marR="73152" marT="45720" marB="45720" anchor="ctr">
+                    <a:lnL w="9525">
+                      <a:solidFill>
+                        <a:srgbClr val="C9D3E0"/>
+                      </a:solidFill>
+                    </a:lnL>
+                    <a:lnR w="9525">
+                      <a:solidFill>
+                        <a:srgbClr val="C9D3E0"/>
+                      </a:solidFill>
+                    </a:lnR>
+                    <a:lnT w="9525">
+                      <a:solidFill>
+                        <a:srgbClr val="C9D3E0"/>
+                      </a:solidFill>
+                    </a:lnT>
+                    <a:lnB w="9525">
+                      <a:solidFill>
+                        <a:srgbClr val="C9D3E0"/>
+                      </a:solidFill>
+                    </a:lnB>
+                    <a:solidFill>
+                      <a:srgbClr val="2A78D6"/>
+                    </a:solidFill>
+                  </a:tcPr>
+                </a:tc>
+                <a:tc>
+                  <a:txBody>
+                    <a:bodyPr/>
+                    <a:lstStyle/>
+                    <a:p>
+                      <a:pPr marL="0" indent="0" algn="l">
+                        <a:lnSpc>
+                          <a:spcPct val="100000"/>
+                        </a:lnSpc>
+                        <a:spcBef>
+                          <a:spcPts val="0"/>
+                        </a:spcBef>
+                        <a:spcAft>
+                          <a:spcPts val="0"/>
+                        </a:spcAft>
+                        <a:buNone/>
+                      </a:pPr>
+                      <a:r>
+                        <a:rPr lang="en-IN" sz="1300" b="1" dirty="0">
+                          <a:solidFill>
+                            <a:srgbClr val="FFFFFF"/>
+                          </a:solidFill>
+                          <a:latin typeface="Times New Roman" panose="02020603050405020304" pitchFamily="18" charset="0"/>
+                          <a:cs typeface="Times New Roman" panose="02020603050405020304" pitchFamily="18" charset="0"/>
+                        </a:rPr>
+                        <a:t>Result</a:t>
+                      </a:r>
+                    </a:p>
+                  </a:txBody>
+                  <a:tcPr marL="73152" marR="73152" marT="45720" marB="45720" anchor="ctr">
+                    <a:lnL w="9525">
+                      <a:solidFill>
+                        <a:srgbClr val="C9D3E0"/>
+                      </a:solidFill>
+                    </a:lnL>
+                    <a:lnR w="9525">
+                      <a:solidFill>
+                        <a:srgbClr val="C9D3E0"/>
+                      </a:solidFill>
+                    </a:lnR>
+                    <a:lnT w="9525">
+                      <a:solidFill>
+                        <a:srgbClr val="C9D3E0"/>
+                      </a:solidFill>
+                    </a:lnT>
+                    <a:lnB w="9525">
+                      <a:solidFill>
+                        <a:srgbClr val="C9D3E0"/>
+                      </a:solidFill>
+                    </a:lnB>
+                    <a:solidFill>
+                      <a:srgbClr val="2A78D6"/>
+                    </a:solidFill>
+                  </a:tcPr>
+                </a:tc>
+              </a:tr>
+              <a:tr h="429768">
+                <a:tc>
+                  <a:txBody>
+                    <a:bodyPr/>
+                    <a:lstStyle/>
+                    <a:p>
+                      <a:pPr marL="0" indent="0" algn="l">
+                        <a:lnSpc>
+                          <a:spcPct val="100000"/>
+                        </a:lnSpc>
+                        <a:spcBef>
+                          <a:spcPts val="0"/>
+                        </a:spcBef>
+                        <a:spcAft>
+                          <a:spcPts val="0"/>
+                        </a:spcAft>
+                        <a:buNone/>
+                      </a:pPr>
+                      <a:r>
+                        <a:rPr lang="en-IN" sz="1300" dirty="0">
+                          <a:solidFill>
+                            <a:srgbClr val="1F2328"/>
+                          </a:solidFill>
+                          <a:latin typeface="Times New Roman" panose="02020603050405020304" pitchFamily="18" charset="0"/>
+                          <a:cs typeface="Times New Roman" panose="02020603050405020304" pitchFamily="18" charset="0"/>
+                        </a:rPr>
+                        <a:t>Download integrity</a:t>
+                      </a:r>
+                    </a:p>
+                  </a:txBody>
+                  <a:tcPr marL="73152" marR="73152" marT="45720" marB="45720" anchor="ctr">
+                    <a:lnL w="9525">
+                      <a:solidFill>
+                        <a:srgbClr val="C9D3E0"/>
+                      </a:solidFill>
+                    </a:lnL>
+                    <a:lnR w="9525">
+                      <a:solidFill>
+                        <a:srgbClr val="C9D3E0"/>
+                      </a:solidFill>
+                    </a:lnR>
+                    <a:lnT w="9525">
+                      <a:solidFill>
+                        <a:srgbClr val="C9D3E0"/>
+                      </a:solidFill>
+                    </a:lnT>
+                    <a:lnB w="9525">
+                      <a:solidFill>
+                        <a:srgbClr val="C9D3E0"/>
+                      </a:solidFill>
+                    </a:lnB>
+                    <a:solidFill>
+                      <a:srgbClr val="EEF3FA"/>
+                    </a:solidFill>
+                  </a:tcPr>
+                </a:tc>
+                <a:tc>
+                  <a:txBody>
+                    <a:bodyPr/>
+                    <a:lstStyle/>
+                    <a:p>
+                      <a:pPr marL="0" indent="0" algn="l">
+                        <a:lnSpc>
+                          <a:spcPct val="100000"/>
+                        </a:lnSpc>
+                        <a:spcBef>
+                          <a:spcPts val="0"/>
+                        </a:spcBef>
+                        <a:spcAft>
+                          <a:spcPts val="0"/>
+                        </a:spcAft>
+                        <a:buNone/>
+                      </a:pPr>
+                      <a:r>
+                        <a:rPr lang="en-IN" sz="1300" dirty="0">
+                          <a:solidFill>
+                            <a:srgbClr val="1F2328"/>
+                          </a:solidFill>
+                          <a:latin typeface="Times New Roman" panose="02020603050405020304" pitchFamily="18" charset="0"/>
+                          <a:cs typeface="Times New Roman" panose="02020603050405020304" pitchFamily="18" charset="0"/>
+                        </a:rPr>
+                        <a:t>Zenodo files match the published size and MD5</a:t>
+                      </a:r>
+                    </a:p>
+                  </a:txBody>
+                  <a:tcPr marL="73152" marR="73152" marT="45720" marB="45720" anchor="ctr">
+                    <a:lnL w="9525">
+                      <a:solidFill>
+                        <a:srgbClr val="C9D3E0"/>
+                      </a:solidFill>
+                    </a:lnL>
+                    <a:lnR w="9525">
+                      <a:solidFill>
+                        <a:srgbClr val="C9D3E0"/>
+                      </a:solidFill>
+                    </a:lnR>
+                    <a:lnT w="9525">
+                      <a:solidFill>
+                        <a:srgbClr val="C9D3E0"/>
+                      </a:solidFill>
+                    </a:lnT>
+                    <a:lnB w="9525">
+                      <a:solidFill>
+                        <a:srgbClr val="C9D3E0"/>
+                      </a:solidFill>
+                    </a:lnB>
+                    <a:solidFill>
+                      <a:srgbClr val="EEF3FA"/>
+                    </a:solidFill>
+                  </a:tcPr>
+                </a:tc>
+                <a:tc>
+                  <a:txBody>
+                    <a:bodyPr/>
+                    <a:lstStyle/>
+                    <a:p>
+                      <a:pPr marL="0" indent="0" algn="l">
+                        <a:lnSpc>
+                          <a:spcPct val="100000"/>
+                        </a:lnSpc>
+                        <a:spcBef>
+                          <a:spcPts val="0"/>
+                        </a:spcBef>
+                        <a:spcAft>
+                          <a:spcPts val="0"/>
+                        </a:spcAft>
+                        <a:buNone/>
+                      </a:pPr>
+                      <a:r>
+                        <a:rPr lang="en-IN" sz="1300" dirty="0">
+                          <a:solidFill>
+                            <a:srgbClr val="1F2328"/>
+                          </a:solidFill>
+                          <a:latin typeface="Times New Roman" panose="02020603050405020304" pitchFamily="18" charset="0"/>
+                          <a:cs typeface="Times New Roman" panose="02020603050405020304" pitchFamily="18" charset="0"/>
+                        </a:rPr>
+                        <a:t>Zenodo: size + MD5 checked; every file: SHA-256 recorded</a:t>
+                      </a:r>
+                    </a:p>
+                  </a:txBody>
+                  <a:tcPr marL="73152" marR="73152" marT="45720" marB="45720" anchor="ctr">
+                    <a:lnL w="9525">
+                      <a:solidFill>
+                        <a:srgbClr val="C9D3E0"/>
+                      </a:solidFill>
+                    </a:lnL>
+                    <a:lnR w="9525">
+                      <a:solidFill>
+                        <a:srgbClr val="C9D3E0"/>
+                      </a:solidFill>
+                    </a:lnR>
+                    <a:lnT w="9525">
+                      <a:solidFill>
+                        <a:srgbClr val="C9D3E0"/>
+                      </a:solidFill>
+                    </a:lnT>
+                    <a:lnB w="9525">
+                      <a:solidFill>
+                        <a:srgbClr val="C9D3E0"/>
+                      </a:solidFill>
+                    </a:lnB>
+                    <a:solidFill>
+                      <a:srgbClr val="EEF3FA"/>
+                    </a:solidFill>
+                  </a:tcPr>
+                </a:tc>
+              </a:tr>
+              <a:tr h="429768">
+                <a:tc>
+                  <a:txBody>
+                    <a:bodyPr/>
+                    <a:lstStyle/>
+                    <a:p>
+                      <a:pPr marL="0" indent="0" algn="l">
+                        <a:lnSpc>
+                          <a:spcPct val="100000"/>
+                        </a:lnSpc>
+                        <a:spcBef>
+                          <a:spcPts val="0"/>
+                        </a:spcBef>
+                        <a:spcAft>
+                          <a:spcPts val="0"/>
+                        </a:spcAft>
+                        <a:buNone/>
+                      </a:pPr>
+                      <a:r>
+                        <a:rPr lang="en-IN" sz="1300" dirty="0">
+                          <a:solidFill>
+                            <a:srgbClr val="1F2328"/>
+                          </a:solidFill>
+                          <a:latin typeface="Times New Roman" panose="02020603050405020304" pitchFamily="18" charset="0"/>
+                          <a:cs typeface="Times New Roman" panose="02020603050405020304" pitchFamily="18" charset="0"/>
+                        </a:rPr>
+                        <a:t>Reproducibility</a:t>
+                      </a:r>
+                    </a:p>
+                  </a:txBody>
+                  <a:tcPr marL="73152" marR="73152" marT="45720" marB="45720" anchor="ctr">
+                    <a:lnL w="9525">
+                      <a:solidFill>
+                        <a:srgbClr val="C9D3E0"/>
+                      </a:solidFill>
+                    </a:lnL>
+                    <a:lnR w="9525">
+                      <a:solidFill>
+                        <a:srgbClr val="C9D3E0"/>
+                      </a:solidFill>
+                    </a:lnR>
+                    <a:lnT w="9525">
+                      <a:solidFill>
+                        <a:srgbClr val="C9D3E0"/>
+                      </a:solidFill>
+                    </a:lnT>
+                    <a:lnB w="9525">
+                      <a:solidFill>
+                        <a:srgbClr val="C9D3E0"/>
+                      </a:solidFill>
+                    </a:lnB>
+                    <a:solidFill>
+                      <a:srgbClr val="FFFFFF"/>
+                    </a:solidFill>
+                  </a:tcPr>
+                </a:tc>
+                <a:tc>
+                  <a:txBody>
+                    <a:bodyPr/>
+                    <a:lstStyle/>
+                    <a:p>
+                      <a:pPr marL="0" indent="0" algn="l">
+                        <a:lnSpc>
+                          <a:spcPct val="100000"/>
+                        </a:lnSpc>
+                        <a:spcBef>
+                          <a:spcPts val="0"/>
+                        </a:spcBef>
+                        <a:spcAft>
+                          <a:spcPts val="0"/>
+                        </a:spcAft>
+                        <a:buNone/>
+                      </a:pPr>
+                      <a:r>
+                        <a:rPr lang="en-IN" sz="1300" dirty="0">
+                          <a:solidFill>
+                            <a:srgbClr val="1F2328"/>
+                          </a:solidFill>
+                          <a:latin typeface="Times New Roman" panose="02020603050405020304" pitchFamily="18" charset="0"/>
+                          <a:cs typeface="Times New Roman" panose="02020603050405020304" pitchFamily="18" charset="0"/>
+                        </a:rPr>
+                        <a:t>Re-running gives the same outputs</a:t>
+                      </a:r>
+                    </a:p>
+                  </a:txBody>
+                  <a:tcPr marL="73152" marR="73152" marT="45720" marB="45720" anchor="ctr">
+                    <a:lnL w="9525">
+                      <a:solidFill>
+                        <a:srgbClr val="C9D3E0"/>
+                      </a:solidFill>
+                    </a:lnL>
+                    <a:lnR w="9525">
+                      <a:solidFill>
+                        <a:srgbClr val="C9D3E0"/>
+                      </a:solidFill>
+                    </a:lnR>
+                    <a:lnT w="9525">
+                      <a:solidFill>
+                        <a:srgbClr val="C9D3E0"/>
+                      </a:solidFill>
+                    </a:lnT>
+                    <a:lnB w="9525">
+                      <a:solidFill>
+                        <a:srgbClr val="C9D3E0"/>
+                      </a:solidFill>
+                    </a:lnB>
+                    <a:solidFill>
+                      <a:srgbClr val="FFFFFF"/>
+                    </a:solidFill>
+                  </a:tcPr>
+                </a:tc>
+                <a:tc>
+                  <a:txBody>
+                    <a:bodyPr/>
+                    <a:lstStyle/>
+                    <a:p>
+                      <a:pPr marL="0" indent="0" algn="l">
+                        <a:lnSpc>
+                          <a:spcPct val="100000"/>
+                        </a:lnSpc>
+                        <a:spcBef>
+                          <a:spcPts val="0"/>
+                        </a:spcBef>
+                        <a:spcAft>
+                          <a:spcPts val="0"/>
+                        </a:spcAft>
+                        <a:buNone/>
+                      </a:pPr>
+                      <a:r>
+                        <a:rPr lang="en-IN" sz="1300" dirty="0">
+                          <a:solidFill>
+                            <a:srgbClr val="1F2328"/>
+                          </a:solidFill>
+                          <a:latin typeface="Times New Roman" panose="02020603050405020304" pitchFamily="18" charset="0"/>
+                          <a:cs typeface="Times New Roman" panose="02020603050405020304" pitchFamily="18" charset="0"/>
+                        </a:rPr>
+                        <a:t>All tracked results byte-identical</a:t>
+                      </a:r>
+                    </a:p>
+                  </a:txBody>
+                  <a:tcPr marL="73152" marR="73152" marT="45720" marB="45720" anchor="ctr">
+                    <a:lnL w="9525">
+                      <a:solidFill>
+                        <a:srgbClr val="C9D3E0"/>
+                      </a:solidFill>
+                    </a:lnL>
+                    <a:lnR w="9525">
+                      <a:solidFill>
+                        <a:srgbClr val="C9D3E0"/>
+                      </a:solidFill>
+                    </a:lnR>
+                    <a:lnT w="9525">
+                      <a:solidFill>
+                        <a:srgbClr val="C9D3E0"/>
+                      </a:solidFill>
+                    </a:lnT>
+                    <a:lnB w="9525">
+                      <a:solidFill>
+                        <a:srgbClr val="C9D3E0"/>
+                      </a:solidFill>
+                    </a:lnB>
+                    <a:solidFill>
+                      <a:srgbClr val="FFFFFF"/>
+                    </a:solidFill>
+                  </a:tcPr>
+                </a:tc>
+              </a:tr>
+              <a:tr h="429768">
+                <a:tc>
+                  <a:txBody>
+                    <a:bodyPr/>
+                    <a:lstStyle/>
+                    <a:p>
+                      <a:pPr marL="0" indent="0" algn="l">
+                        <a:lnSpc>
+                          <a:spcPct val="100000"/>
+                        </a:lnSpc>
+                        <a:spcBef>
+                          <a:spcPts val="0"/>
+                        </a:spcBef>
+                        <a:spcAft>
+                          <a:spcPts val="0"/>
+                        </a:spcAft>
+                        <a:buNone/>
+                      </a:pPr>
+                      <a:r>
+                        <a:rPr lang="en-IN" sz="1300" dirty="0">
+                          <a:solidFill>
+                            <a:srgbClr val="1F2328"/>
+                          </a:solidFill>
+                          <a:latin typeface="Times New Roman" panose="02020603050405020304" pitchFamily="18" charset="0"/>
+                          <a:cs typeface="Times New Roman" panose="02020603050405020304" pitchFamily="18" charset="0"/>
+                        </a:rPr>
+                        <a:t>SQL cross-check</a:t>
+                      </a:r>
+                    </a:p>
+                  </a:txBody>
+                  <a:tcPr marL="73152" marR="73152" marT="45720" marB="45720" anchor="ctr">
+                    <a:lnL w="9525">
+                      <a:solidFill>
+                        <a:srgbClr val="C9D3E0"/>
+                      </a:solidFill>
+                    </a:lnL>
+                    <a:lnR w="9525">
+                      <a:solidFill>
+                        <a:srgbClr val="C9D3E0"/>
+                      </a:solidFill>
+                    </a:lnR>
+                    <a:lnT w="9525">
+                      <a:solidFill>
+                        <a:srgbClr val="C9D3E0"/>
+                      </a:solidFill>
+                    </a:lnT>
+                    <a:lnB w="9525">
+                      <a:solidFill>
+                        <a:srgbClr val="C9D3E0"/>
+                      </a:solidFill>
+                    </a:lnB>
+                    <a:solidFill>
+                      <a:srgbClr val="EEF3FA"/>
+                    </a:solidFill>
+                  </a:tcPr>
+                </a:tc>
+                <a:tc>
+                  <a:txBody>
+                    <a:bodyPr/>
+                    <a:lstStyle/>
+                    <a:p>
+                      <a:pPr marL="0" indent="0" algn="l">
+                        <a:lnSpc>
+                          <a:spcPct val="100000"/>
+                        </a:lnSpc>
+                        <a:spcBef>
+                          <a:spcPts val="0"/>
+                        </a:spcBef>
+                        <a:spcAft>
+                          <a:spcPts val="0"/>
+                        </a:spcAft>
+                        <a:buNone/>
+                      </a:pPr>
+                      <a:r>
+                        <a:rPr lang="en-IN" sz="1300" dirty="0">
+                          <a:solidFill>
+                            <a:srgbClr val="1F2328"/>
+                          </a:solidFill>
+                          <a:latin typeface="Times New Roman" panose="02020603050405020304" pitchFamily="18" charset="0"/>
+                          <a:cs typeface="Times New Roman" panose="02020603050405020304" pitchFamily="18" charset="0"/>
+                        </a:rPr>
+                        <a:t>Predicate code matches independent SQL</a:t>
+                      </a:r>
+                    </a:p>
+                  </a:txBody>
+                  <a:tcPr marL="73152" marR="73152" marT="45720" marB="45720" anchor="ctr">
+                    <a:lnL w="9525">
+                      <a:solidFill>
+                        <a:srgbClr val="C9D3E0"/>
+                      </a:solidFill>
+                    </a:lnL>
+                    <a:lnR w="9525">
+                      <a:solidFill>
+                        <a:srgbClr val="C9D3E0"/>
+                      </a:solidFill>
+                    </a:lnR>
+                    <a:lnT w="9525">
+                      <a:solidFill>
+                        <a:srgbClr val="C9D3E0"/>
+                      </a:solidFill>
+                    </a:lnT>
+                    <a:lnB w="9525">
+                      <a:solidFill>
+                        <a:srgbClr val="C9D3E0"/>
+                      </a:solidFill>
+                    </a:lnB>
+                    <a:solidFill>
+                      <a:srgbClr val="EEF3FA"/>
+                    </a:solidFill>
+                  </a:tcPr>
+                </a:tc>
+                <a:tc>
+                  <a:txBody>
+                    <a:bodyPr/>
+                    <a:lstStyle/>
+                    <a:p>
+                      <a:pPr marL="0" indent="0" algn="l">
+                        <a:lnSpc>
+                          <a:spcPct val="100000"/>
+                        </a:lnSpc>
+                        <a:spcBef>
+                          <a:spcPts val="0"/>
+                        </a:spcBef>
+                        <a:spcAft>
+                          <a:spcPts val="0"/>
+                        </a:spcAft>
+                        <a:buNone/>
+                      </a:pPr>
+                      <a:r>
+                        <a:rPr lang="en-IN" sz="1300" dirty="0">
+                          <a:solidFill>
+                            <a:srgbClr val="1F2328"/>
+                          </a:solidFill>
+                          <a:latin typeface="Times New Roman" panose="02020603050405020304" pitchFamily="18" charset="0"/>
+                          <a:cs typeface="Times New Roman" panose="02020603050405020304" pitchFamily="18" charset="0"/>
+                        </a:rPr>
+                        <a:t>4 of 4 CROP rules exact</a:t>
+                      </a:r>
+                    </a:p>
+                  </a:txBody>
+                  <a:tcPr marL="73152" marR="73152" marT="45720" marB="45720" anchor="ctr">
+                    <a:lnL w="9525">
+                      <a:solidFill>
+                        <a:srgbClr val="C9D3E0"/>
+                      </a:solidFill>
+                    </a:lnL>
+                    <a:lnR w="9525">
+                      <a:solidFill>
+                        <a:srgbClr val="C9D3E0"/>
+                      </a:solidFill>
+                    </a:lnR>
+                    <a:lnT w="9525">
+                      <a:solidFill>
+                        <a:srgbClr val="C9D3E0"/>
+                      </a:solidFill>
+                    </a:lnT>
+                    <a:lnB w="9525">
+                      <a:solidFill>
+                        <a:srgbClr val="C9D3E0"/>
+                      </a:solidFill>
+                    </a:lnB>
+                    <a:solidFill>
+                      <a:srgbClr val="EEF3FA"/>
+                    </a:solidFill>
+                  </a:tcPr>
+                </a:tc>
+              </a:tr>
+              <a:tr h="429768">
+                <a:tc>
+                  <a:txBody>
+                    <a:bodyPr/>
+                    <a:lstStyle/>
+                    <a:p>
+                      <a:pPr marL="0" indent="0" algn="l">
+                        <a:lnSpc>
+                          <a:spcPct val="100000"/>
+                        </a:lnSpc>
+                        <a:spcBef>
+                          <a:spcPts val="0"/>
+                        </a:spcBef>
+                        <a:spcAft>
+                          <a:spcPts val="0"/>
+                        </a:spcAft>
+                        <a:buNone/>
+                      </a:pPr>
+                      <a:r>
+                        <a:rPr lang="en-IN" sz="1300" dirty="0">
+                          <a:solidFill>
+                            <a:srgbClr val="1F2328"/>
+                          </a:solidFill>
+                          <a:latin typeface="Times New Roman" panose="02020603050405020304" pitchFamily="18" charset="0"/>
+                          <a:cs typeface="Times New Roman" panose="02020603050405020304" pitchFamily="18" charset="0"/>
+                        </a:rPr>
+                        <a:t>Brute-force self-check</a:t>
+                      </a:r>
+                    </a:p>
+                  </a:txBody>
+                  <a:tcPr marL="73152" marR="73152" marT="45720" marB="45720" anchor="ctr">
+                    <a:lnL w="9525">
+                      <a:solidFill>
+                        <a:srgbClr val="C9D3E0"/>
+                      </a:solidFill>
+                    </a:lnL>
+                    <a:lnR w="9525">
+                      <a:solidFill>
+                        <a:srgbClr val="C9D3E0"/>
+                      </a:solidFill>
+                    </a:lnR>
+                    <a:lnT w="9525">
+                      <a:solidFill>
+                        <a:srgbClr val="C9D3E0"/>
+                      </a:solidFill>
+                    </a:lnT>
+                    <a:lnB w="9525">
+                      <a:solidFill>
+                        <a:srgbClr val="C9D3E0"/>
+                      </a:solidFill>
+                    </a:lnB>
+                    <a:solidFill>
+                      <a:srgbClr val="FFFFFF"/>
+                    </a:solidFill>
+                  </a:tcPr>
+                </a:tc>
+                <a:tc>
+                  <a:txBody>
+                    <a:bodyPr/>
+                    <a:lstStyle/>
+                    <a:p>
+                      <a:pPr marL="0" indent="0" algn="l">
+                        <a:lnSpc>
+                          <a:spcPct val="100000"/>
+                        </a:lnSpc>
+                        <a:spcBef>
+                          <a:spcPts val="0"/>
+                        </a:spcBef>
+                        <a:spcAft>
+                          <a:spcPts val="0"/>
+                        </a:spcAft>
+                        <a:buNone/>
+                      </a:pPr>
+                      <a:r>
+                        <a:rPr lang="en-IN" sz="1300" dirty="0">
+                          <a:solidFill>
+                            <a:srgbClr val="1F2328"/>
+                          </a:solidFill>
+                          <a:latin typeface="Times New Roman" panose="02020603050405020304" pitchFamily="18" charset="0"/>
+                          <a:cs typeface="Times New Roman" panose="02020603050405020304" pitchFamily="18" charset="0"/>
+                        </a:rPr>
+                        <a:t>Fast code equals plain Python</a:t>
+                      </a:r>
+                    </a:p>
+                  </a:txBody>
+                  <a:tcPr marL="73152" marR="73152" marT="45720" marB="45720" anchor="ctr">
+                    <a:lnL w="9525">
+                      <a:solidFill>
+                        <a:srgbClr val="C9D3E0"/>
+                      </a:solidFill>
+                    </a:lnL>
+                    <a:lnR w="9525">
+                      <a:solidFill>
+                        <a:srgbClr val="C9D3E0"/>
+                      </a:solidFill>
+                    </a:lnR>
+                    <a:lnT w="9525">
+                      <a:solidFill>
+                        <a:srgbClr val="C9D3E0"/>
+                      </a:solidFill>
+                    </a:lnT>
+                    <a:lnB w="9525">
+                      <a:solidFill>
+                        <a:srgbClr val="C9D3E0"/>
+                      </a:solidFill>
+                    </a:lnB>
+                    <a:solidFill>
+                      <a:srgbClr val="FFFFFF"/>
+                    </a:solidFill>
+                  </a:tcPr>
+                </a:tc>
+                <a:tc>
+                  <a:txBody>
+                    <a:bodyPr/>
+                    <a:lstStyle/>
+                    <a:p>
+                      <a:pPr marL="0" indent="0" algn="l">
+                        <a:lnSpc>
+                          <a:spcPct val="100000"/>
+                        </a:lnSpc>
+                        <a:spcBef>
+                          <a:spcPts val="0"/>
+                        </a:spcBef>
+                        <a:spcAft>
+                          <a:spcPts val="0"/>
+                        </a:spcAft>
+                        <a:buNone/>
+                      </a:pPr>
+                      <a:r>
+                        <a:rPr lang="en-IN" sz="1300" dirty="0">
+                          <a:solidFill>
+                            <a:srgbClr val="1F2328"/>
+                          </a:solidFill>
+                          <a:latin typeface="Times New Roman" panose="02020603050405020304" pitchFamily="18" charset="0"/>
+                          <a:cs typeface="Times New Roman" panose="02020603050405020304" pitchFamily="18" charset="0"/>
+                        </a:rPr>
+                        <a:t>Event pairs identical on 4 case notions</a:t>
+                      </a:r>
+                    </a:p>
+                  </a:txBody>
+                  <a:tcPr marL="73152" marR="73152" marT="45720" marB="45720" anchor="ctr">
+                    <a:lnL w="9525">
+                      <a:solidFill>
+                        <a:srgbClr val="C9D3E0"/>
+                      </a:solidFill>
+                    </a:lnL>
+                    <a:lnR w="9525">
+                      <a:solidFill>
+                        <a:srgbClr val="C9D3E0"/>
+                      </a:solidFill>
+                    </a:lnR>
+                    <a:lnT w="9525">
+                      <a:solidFill>
+                        <a:srgbClr val="C9D3E0"/>
+                      </a:solidFill>
+                    </a:lnT>
+                    <a:lnB w="9525">
+                      <a:solidFill>
+                        <a:srgbClr val="C9D3E0"/>
+                      </a:solidFill>
+                    </a:lnB>
+                    <a:solidFill>
+                      <a:srgbClr val="FFFFFF"/>
+                    </a:solidFill>
+                  </a:tcPr>
+                </a:tc>
+              </a:tr>
+              <a:tr h="429768">
+                <a:tc>
+                  <a:txBody>
+                    <a:bodyPr/>
+                    <a:lstStyle/>
+                    <a:p>
+                      <a:pPr marL="0" indent="0" algn="l">
+                        <a:lnSpc>
+                          <a:spcPct val="100000"/>
+                        </a:lnSpc>
+                        <a:spcBef>
+                          <a:spcPts val="0"/>
+                        </a:spcBef>
+                        <a:spcAft>
+                          <a:spcPts val="0"/>
+                        </a:spcAft>
+                        <a:buNone/>
+                      </a:pPr>
+                      <a:r>
+                        <a:rPr lang="en-IN" sz="1300" dirty="0">
+                          <a:solidFill>
+                            <a:srgbClr val="1F2328"/>
+                          </a:solidFill>
+                          <a:latin typeface="Times New Roman" panose="02020603050405020304" pitchFamily="18" charset="0"/>
+                          <a:cs typeface="Times New Roman" panose="02020603050405020304" pitchFamily="18" charset="0"/>
+                        </a:rPr>
+                        <a:t>Distortion self-check</a:t>
+                      </a:r>
+                    </a:p>
+                  </a:txBody>
+                  <a:tcPr marL="73152" marR="73152" marT="45720" marB="45720" anchor="ctr">
+                    <a:lnL w="9525">
+                      <a:solidFill>
+                        <a:srgbClr val="C9D3E0"/>
+                      </a:solidFill>
+                    </a:lnL>
+                    <a:lnR w="9525">
+                      <a:solidFill>
+                        <a:srgbClr val="C9D3E0"/>
+                      </a:solidFill>
+                    </a:lnR>
+                    <a:lnT w="9525">
+                      <a:solidFill>
+                        <a:srgbClr val="C9D3E0"/>
+                      </a:solidFill>
+                    </a:lnT>
+                    <a:lnB w="9525">
+                      <a:solidFill>
+                        <a:srgbClr val="C9D3E0"/>
+                      </a:solidFill>
+                    </a:lnB>
+                    <a:solidFill>
+                      <a:srgbClr val="EEF3FA"/>
+                    </a:solidFill>
+                  </a:tcPr>
+                </a:tc>
+                <a:tc>
+                  <a:txBody>
+                    <a:bodyPr/>
+                    <a:lstStyle/>
+                    <a:p>
+                      <a:pPr marL="0" indent="0" algn="l">
+                        <a:lnSpc>
+                          <a:spcPct val="100000"/>
+                        </a:lnSpc>
+                        <a:spcBef>
+                          <a:spcPts val="0"/>
+                        </a:spcBef>
+                        <a:spcAft>
+                          <a:spcPts val="0"/>
+                        </a:spcAft>
+                        <a:buNone/>
+                      </a:pPr>
+                      <a:r>
+                        <a:rPr lang="en-IN" sz="1300" dirty="0">
+                          <a:solidFill>
+                            <a:srgbClr val="1F2328"/>
+                          </a:solidFill>
+                          <a:latin typeface="Times New Roman" panose="02020603050405020304" pitchFamily="18" charset="0"/>
+                          <a:cs typeface="Times New Roman" panose="02020603050405020304" pitchFamily="18" charset="0"/>
+                        </a:rPr>
+                        <a:t>Pandas metrics equal a plain-Python version</a:t>
+                      </a:r>
+                    </a:p>
+                  </a:txBody>
+                  <a:tcPr marL="73152" marR="73152" marT="45720" marB="45720" anchor="ctr">
+                    <a:lnL w="9525">
+                      <a:solidFill>
+                        <a:srgbClr val="C9D3E0"/>
+                      </a:solidFill>
+                    </a:lnL>
+                    <a:lnR w="9525">
+                      <a:solidFill>
+                        <a:srgbClr val="C9D3E0"/>
+                      </a:solidFill>
+                    </a:lnR>
+                    <a:lnT w="9525">
+                      <a:solidFill>
+                        <a:srgbClr val="C9D3E0"/>
+                      </a:solidFill>
+                    </a:lnT>
+                    <a:lnB w="9525">
+                      <a:solidFill>
+                        <a:srgbClr val="C9D3E0"/>
+                      </a:solidFill>
+                    </a:lnB>
+                    <a:solidFill>
+                      <a:srgbClr val="EEF3FA"/>
+                    </a:solidFill>
+                  </a:tcPr>
+                </a:tc>
+                <a:tc>
+                  <a:txBody>
+                    <a:bodyPr/>
+                    <a:lstStyle/>
+                    <a:p>
+                      <a:pPr marL="0" indent="0" algn="l">
+                        <a:lnSpc>
+                          <a:spcPct val="100000"/>
+                        </a:lnSpc>
+                        <a:spcBef>
+                          <a:spcPts val="0"/>
+                        </a:spcBef>
+                        <a:spcAft>
+                          <a:spcPts val="0"/>
+                        </a:spcAft>
+                        <a:buNone/>
+                      </a:pPr>
+                      <a:r>
+                        <a:rPr lang="en-IN" sz="1300" dirty="0">
+                          <a:solidFill>
+                            <a:srgbClr val="1F2328"/>
+                          </a:solidFill>
+                          <a:latin typeface="Times New Roman" panose="02020603050405020304" pitchFamily="18" charset="0"/>
+                          <a:cs typeface="Times New Roman" panose="02020603050405020304" pitchFamily="18" charset="0"/>
+                        </a:rPr>
+                        <a:t>Identical on all 7 full logs: 87 notions, 294 type pairs</a:t>
+                      </a:r>
+                    </a:p>
+                  </a:txBody>
+                  <a:tcPr marL="73152" marR="73152" marT="45720" marB="45720" anchor="ctr">
+                    <a:lnL w="9525">
+                      <a:solidFill>
+                        <a:srgbClr val="C9D3E0"/>
+                      </a:solidFill>
+                    </a:lnL>
+                    <a:lnR w="9525">
+                      <a:solidFill>
+                        <a:srgbClr val="C9D3E0"/>
+                      </a:solidFill>
+                    </a:lnR>
+                    <a:lnT w="9525">
+                      <a:solidFill>
+                        <a:srgbClr val="C9D3E0"/>
+                      </a:solidFill>
+                    </a:lnT>
+                    <a:lnB w="9525">
+                      <a:solidFill>
+                        <a:srgbClr val="C9D3E0"/>
+                      </a:solidFill>
+                    </a:lnB>
+                    <a:solidFill>
+                      <a:srgbClr val="EEF3FA"/>
+                    </a:solidFill>
+                  </a:tcPr>
+                </a:tc>
+              </a:tr>
+              <a:tr h="429768">
+                <a:tc>
+                  <a:txBody>
+                    <a:bodyPr/>
+                    <a:lstStyle/>
+                    <a:p>
+                      <a:pPr marL="0" indent="0" algn="l">
+                        <a:lnSpc>
+                          <a:spcPct val="100000"/>
+                        </a:lnSpc>
+                        <a:spcBef>
+                          <a:spcPts val="0"/>
+                        </a:spcBef>
+                        <a:spcAft>
+                          <a:spcPts val="0"/>
+                        </a:spcAft>
+                        <a:buNone/>
+                      </a:pPr>
+                      <a:r>
+                        <a:rPr lang="en-IN" sz="1300" dirty="0">
+                          <a:solidFill>
+                            <a:srgbClr val="1F2328"/>
+                          </a:solidFill>
+                          <a:latin typeface="Times New Roman" panose="02020603050405020304" pitchFamily="18" charset="0"/>
+                          <a:cs typeface="Times New Roman" panose="02020603050405020304" pitchFamily="18" charset="0"/>
+                        </a:rPr>
+                        <a:t>Bootstrap reproduction</a:t>
+                      </a:r>
+                    </a:p>
+                  </a:txBody>
+                  <a:tcPr marL="73152" marR="73152" marT="45720" marB="45720" anchor="ctr">
+                    <a:lnL w="9525">
+                      <a:solidFill>
+                        <a:srgbClr val="C9D3E0"/>
+                      </a:solidFill>
+                    </a:lnL>
+                    <a:lnR w="9525">
+                      <a:solidFill>
+                        <a:srgbClr val="C9D3E0"/>
+                      </a:solidFill>
+                    </a:lnR>
+                    <a:lnT w="9525">
+                      <a:solidFill>
+                        <a:srgbClr val="C9D3E0"/>
+                      </a:solidFill>
+                    </a:lnT>
+                    <a:lnB w="9525">
+                      <a:solidFill>
+                        <a:srgbClr val="C9D3E0"/>
+                      </a:solidFill>
+                    </a:lnB>
+                    <a:solidFill>
+                      <a:srgbClr val="FFFFFF"/>
+                    </a:solidFill>
+                  </a:tcPr>
+                </a:tc>
+                <a:tc>
+                  <a:txBody>
+                    <a:bodyPr/>
+                    <a:lstStyle/>
+                    <a:p>
+                      <a:pPr marL="0" indent="0" algn="l">
+                        <a:lnSpc>
+                          <a:spcPct val="100000"/>
+                        </a:lnSpc>
+                        <a:spcBef>
+                          <a:spcPts val="0"/>
+                        </a:spcBef>
+                        <a:spcAft>
+                          <a:spcPts val="0"/>
+                        </a:spcAft>
+                        <a:buNone/>
+                      </a:pPr>
+                      <a:r>
+                        <a:rPr lang="en-IN" sz="1300" dirty="0">
+                          <a:solidFill>
+                            <a:srgbClr val="1F2328"/>
+                          </a:solidFill>
+                          <a:latin typeface="Times New Roman" panose="02020603050405020304" pitchFamily="18" charset="0"/>
+                          <a:cs typeface="Times New Roman" panose="02020603050405020304" pitchFamily="18" charset="0"/>
+                        </a:rPr>
+                        <a:t>Resampling code matches the analysis</a:t>
+                      </a:r>
+                    </a:p>
+                  </a:txBody>
+                  <a:tcPr marL="73152" marR="73152" marT="45720" marB="45720" anchor="ctr">
+                    <a:lnL w="9525">
+                      <a:solidFill>
+                        <a:srgbClr val="C9D3E0"/>
+                      </a:solidFill>
+                    </a:lnL>
+                    <a:lnR w="9525">
+                      <a:solidFill>
+                        <a:srgbClr val="C9D3E0"/>
+                      </a:solidFill>
+                    </a:lnR>
+                    <a:lnT w="9525">
+                      <a:solidFill>
+                        <a:srgbClr val="C9D3E0"/>
+                      </a:solidFill>
+                    </a:lnT>
+                    <a:lnB w="9525">
+                      <a:solidFill>
+                        <a:srgbClr val="C9D3E0"/>
+                      </a:solidFill>
+                    </a:lnB>
+                    <a:solidFill>
+                      <a:srgbClr val="FFFFFF"/>
+                    </a:solidFill>
+                  </a:tcPr>
+                </a:tc>
+                <a:tc>
+                  <a:txBody>
+                    <a:bodyPr/>
+                    <a:lstStyle/>
+                    <a:p>
+                      <a:pPr marL="0" indent="0" algn="l">
+                        <a:lnSpc>
+                          <a:spcPct val="100000"/>
+                        </a:lnSpc>
+                        <a:spcBef>
+                          <a:spcPts val="0"/>
+                        </a:spcBef>
+                        <a:spcAft>
+                          <a:spcPts val="0"/>
+                        </a:spcAft>
+                        <a:buNone/>
+                      </a:pPr>
+                      <a:r>
+                        <a:rPr lang="en-IN" sz="1300" dirty="0">
+                          <a:solidFill>
+                            <a:srgbClr val="1F2328"/>
+                          </a:solidFill>
+                          <a:latin typeface="Times New Roman" panose="02020603050405020304" pitchFamily="18" charset="0"/>
+                          <a:cs typeface="Times New Roman" panose="02020603050405020304" pitchFamily="18" charset="0"/>
+                        </a:rPr>
+                        <a:t>38 of 38 case notions exact</a:t>
+                      </a:r>
+                    </a:p>
+                  </a:txBody>
+                  <a:tcPr marL="73152" marR="73152" marT="45720" marB="45720" anchor="ctr">
+                    <a:lnL w="9525">
+                      <a:solidFill>
+                        <a:srgbClr val="C9D3E0"/>
+                      </a:solidFill>
+                    </a:lnL>
+                    <a:lnR w="9525">
+                      <a:solidFill>
+                        <a:srgbClr val="C9D3E0"/>
+                      </a:solidFill>
+                    </a:lnR>
+                    <a:lnT w="9525">
+                      <a:solidFill>
+                        <a:srgbClr val="C9D3E0"/>
+                      </a:solidFill>
+                    </a:lnT>
+                    <a:lnB w="9525">
+                      <a:solidFill>
+                        <a:srgbClr val="C9D3E0"/>
+                      </a:solidFill>
+                    </a:lnB>
+                    <a:solidFill>
+                      <a:srgbClr val="FFFFFF"/>
+                    </a:solidFill>
+                  </a:tcPr>
+                </a:tc>
+              </a:tr>
+              <a:tr h="429768">
+                <a:tc>
+                  <a:txBody>
+                    <a:bodyPr/>
+                    <a:lstStyle/>
+                    <a:p>
+                      <a:pPr marL="0" indent="0" algn="l">
+                        <a:lnSpc>
+                          <a:spcPct val="100000"/>
+                        </a:lnSpc>
+                        <a:spcBef>
+                          <a:spcPts val="0"/>
+                        </a:spcBef>
+                        <a:spcAft>
+                          <a:spcPts val="0"/>
+                        </a:spcAft>
+                        <a:buNone/>
+                      </a:pPr>
+                      <a:r>
+                        <a:rPr lang="en-IN" sz="1300" dirty="0">
+                          <a:solidFill>
+                            <a:srgbClr val="1F2328"/>
+                          </a:solidFill>
+                          <a:latin typeface="Times New Roman" panose="02020603050405020304" pitchFamily="18" charset="0"/>
+                          <a:cs typeface="Times New Roman" panose="02020603050405020304" pitchFamily="18" charset="0"/>
+                        </a:rPr>
+                        <a:t>Independent recomputation</a:t>
+                      </a:r>
+                    </a:p>
+                  </a:txBody>
+                  <a:tcPr marL="73152" marR="73152" marT="45720" marB="45720" anchor="ctr">
+                    <a:lnL w="9525">
+                      <a:solidFill>
+                        <a:srgbClr val="C9D3E0"/>
+                      </a:solidFill>
+                    </a:lnL>
+                    <a:lnR w="9525">
+                      <a:solidFill>
+                        <a:srgbClr val="C9D3E0"/>
+                      </a:solidFill>
+                    </a:lnR>
+                    <a:lnT w="9525">
+                      <a:solidFill>
+                        <a:srgbClr val="C9D3E0"/>
+                      </a:solidFill>
+                    </a:lnT>
+                    <a:lnB w="9525">
+                      <a:solidFill>
+                        <a:srgbClr val="C9D3E0"/>
+                      </a:solidFill>
+                    </a:lnB>
+                    <a:solidFill>
+                      <a:srgbClr val="EEF3FA"/>
+                    </a:solidFill>
+                  </a:tcPr>
+                </a:tc>
+                <a:tc>
+                  <a:txBody>
+                    <a:bodyPr/>
+                    <a:lstStyle/>
+                    <a:p>
+                      <a:pPr marL="0" indent="0" algn="l">
+                        <a:lnSpc>
+                          <a:spcPct val="100000"/>
+                        </a:lnSpc>
+                        <a:spcBef>
+                          <a:spcPts val="0"/>
+                        </a:spcBef>
+                        <a:spcAft>
+                          <a:spcPts val="0"/>
+                        </a:spcAft>
+                        <a:buNone/>
+                      </a:pPr>
+                      <a:r>
+                        <a:rPr lang="en-IN" sz="1300" dirty="0">
+                          <a:solidFill>
+                            <a:srgbClr val="1F2328"/>
+                          </a:solidFill>
+                          <a:latin typeface="Times New Roman" panose="02020603050405020304" pitchFamily="18" charset="0"/>
+                          <a:cs typeface="Times New Roman" panose="02020603050405020304" pitchFamily="18" charset="0"/>
+                        </a:rPr>
+                        <a:t>OULAD counts match raw CSVs</a:t>
+                      </a:r>
+                    </a:p>
+                  </a:txBody>
+                  <a:tcPr marL="73152" marR="73152" marT="45720" marB="45720" anchor="ctr">
+                    <a:lnL w="9525">
+                      <a:solidFill>
+                        <a:srgbClr val="C9D3E0"/>
+                      </a:solidFill>
+                    </a:lnL>
+                    <a:lnR w="9525">
+                      <a:solidFill>
+                        <a:srgbClr val="C9D3E0"/>
+                      </a:solidFill>
+                    </a:lnR>
+                    <a:lnT w="9525">
+                      <a:solidFill>
+                        <a:srgbClr val="C9D3E0"/>
+                      </a:solidFill>
+                    </a:lnT>
+                    <a:lnB w="9525">
+                      <a:solidFill>
+                        <a:srgbClr val="C9D3E0"/>
+                      </a:solidFill>
+                    </a:lnB>
+                    <a:solidFill>
+                      <a:srgbClr val="EEF3FA"/>
+                    </a:solidFill>
+                  </a:tcPr>
+                </a:tc>
+                <a:tc>
+                  <a:txBody>
+                    <a:bodyPr/>
+                    <a:lstStyle/>
+                    <a:p>
+                      <a:pPr marL="0" indent="0" algn="l">
+                        <a:lnSpc>
+                          <a:spcPct val="100000"/>
+                        </a:lnSpc>
+                        <a:spcBef>
+                          <a:spcPts val="0"/>
+                        </a:spcBef>
+                        <a:spcAft>
+                          <a:spcPts val="0"/>
+                        </a:spcAft>
+                        <a:buNone/>
+                      </a:pPr>
+                      <a:r>
+                        <a:rPr lang="en-IN" sz="1300" dirty="0">
+                          <a:solidFill>
+                            <a:srgbClr val="1F2328"/>
+                          </a:solidFill>
+                          <a:latin typeface="Times New Roman" panose="02020603050405020304" pitchFamily="18" charset="0"/>
+                          <a:cs typeface="Times New Roman" panose="02020603050405020304" pitchFamily="18" charset="0"/>
+                        </a:rPr>
+                        <a:t>15,348 / 415 / 29 exact</a:t>
+                      </a:r>
+                    </a:p>
+                  </a:txBody>
+                  <a:tcPr marL="73152" marR="73152" marT="45720" marB="45720" anchor="ctr">
+                    <a:lnL w="9525">
+                      <a:solidFill>
+                        <a:srgbClr val="C9D3E0"/>
+                      </a:solidFill>
+                    </a:lnL>
+                    <a:lnR w="9525">
+                      <a:solidFill>
+                        <a:srgbClr val="C9D3E0"/>
+                      </a:solidFill>
+                    </a:lnR>
+                    <a:lnT w="9525">
+                      <a:solidFill>
+                        <a:srgbClr val="C9D3E0"/>
+                      </a:solidFill>
+                    </a:lnT>
+                    <a:lnB w="9525">
+                      <a:solidFill>
+                        <a:srgbClr val="C9D3E0"/>
+                      </a:solidFill>
+                    </a:lnB>
+                    <a:solidFill>
+                      <a:srgbClr val="EEF3FA"/>
+                    </a:solidFill>
+                  </a:tcPr>
+                </a:tc>
+              </a:tr>
+              <a:tr h="429768">
+                <a:tc>
+                  <a:txBody>
+                    <a:bodyPr/>
+                    <a:lstStyle/>
+                    <a:p>
+                      <a:pPr marL="0" indent="0" algn="l">
+                        <a:lnSpc>
+                          <a:spcPct val="100000"/>
+                        </a:lnSpc>
+                        <a:spcBef>
+                          <a:spcPts val="0"/>
+                        </a:spcBef>
+                        <a:spcAft>
+                          <a:spcPts val="0"/>
+                        </a:spcAft>
+                        <a:buNone/>
+                      </a:pPr>
+                      <a:r>
+                        <a:rPr lang="en-IN" sz="1300" dirty="0">
+                          <a:solidFill>
+                            <a:srgbClr val="1F2328"/>
+                          </a:solidFill>
+                          <a:latin typeface="Times New Roman" panose="02020603050405020304" pitchFamily="18" charset="0"/>
+                          <a:cs typeface="Times New Roman" panose="02020603050405020304" pitchFamily="18" charset="0"/>
+                        </a:rPr>
+                        <a:t>Bugs our own checks found</a:t>
+                      </a:r>
+                    </a:p>
+                  </a:txBody>
+                  <a:tcPr marL="73152" marR="73152" marT="45720" marB="45720" anchor="ctr">
+                    <a:lnL w="9525">
+                      <a:solidFill>
+                        <a:srgbClr val="C9D3E0"/>
+                      </a:solidFill>
+                    </a:lnL>
+                    <a:lnR w="9525">
+                      <a:solidFill>
+                        <a:srgbClr val="C9D3E0"/>
+                      </a:solidFill>
+                    </a:lnR>
+                    <a:lnT w="9525">
+                      <a:solidFill>
+                        <a:srgbClr val="C9D3E0"/>
+                      </a:solidFill>
+                    </a:lnT>
+                    <a:lnB w="9525">
+                      <a:solidFill>
+                        <a:srgbClr val="C9D3E0"/>
+                      </a:solidFill>
+                    </a:lnB>
+                    <a:solidFill>
+                      <a:srgbClr val="FFFFFF"/>
+                    </a:solidFill>
+                  </a:tcPr>
+                </a:tc>
+                <a:tc>
+                  <a:txBody>
+                    <a:bodyPr/>
+                    <a:lstStyle/>
+                    <a:p>
+                      <a:pPr marL="0" indent="0" algn="l">
+                        <a:lnSpc>
+                          <a:spcPct val="100000"/>
+                        </a:lnSpc>
+                        <a:spcBef>
+                          <a:spcPts val="0"/>
+                        </a:spcBef>
+                        <a:spcAft>
+                          <a:spcPts val="0"/>
+                        </a:spcAft>
+                        <a:buNone/>
+                      </a:pPr>
+                      <a:r>
+                        <a:rPr lang="en-IN" sz="1300" dirty="0">
+                          <a:solidFill>
+                            <a:srgbClr val="1F2328"/>
+                          </a:solidFill>
+                          <a:latin typeface="Times New Roman" panose="02020603050405020304" pitchFamily="18" charset="0"/>
+                          <a:cs typeface="Times New Roman" panose="02020603050405020304" pitchFamily="18" charset="0"/>
+                        </a:rPr>
+                        <a:t>Verification is not a formality</a:t>
+                      </a:r>
+                    </a:p>
+                  </a:txBody>
+                  <a:tcPr marL="73152" marR="73152" marT="45720" marB="45720" anchor="ctr">
+                    <a:lnL w="9525">
+                      <a:solidFill>
+                        <a:srgbClr val="C9D3E0"/>
+                      </a:solidFill>
+                    </a:lnL>
+                    <a:lnR w="9525">
+                      <a:solidFill>
+                        <a:srgbClr val="C9D3E0"/>
+                      </a:solidFill>
+                    </a:lnR>
+                    <a:lnT w="9525">
+                      <a:solidFill>
+                        <a:srgbClr val="C9D3E0"/>
+                      </a:solidFill>
+                    </a:lnT>
+                    <a:lnB w="9525">
+                      <a:solidFill>
+                        <a:srgbClr val="C9D3E0"/>
+                      </a:solidFill>
+                    </a:lnB>
+                    <a:solidFill>
+                      <a:srgbClr val="FFFFFF"/>
+                    </a:solidFill>
+                  </a:tcPr>
+                </a:tc>
+                <a:tc>
+                  <a:txBody>
+                    <a:bodyPr/>
+                    <a:lstStyle/>
+                    <a:p>
+                      <a:pPr marL="0" indent="0" algn="l">
+                        <a:lnSpc>
+                          <a:spcPct val="100000"/>
+                        </a:lnSpc>
+                        <a:spcBef>
+                          <a:spcPts val="0"/>
+                        </a:spcBef>
+                        <a:spcAft>
+                          <a:spcPts val="0"/>
+                        </a:spcAft>
+                        <a:buNone/>
+                      </a:pPr>
+                      <a:r>
+                        <a:rPr lang="en-IN" sz="1300" dirty="0">
+                          <a:solidFill>
+                            <a:srgbClr val="1F2328"/>
+                          </a:solidFill>
+                          <a:latin typeface="Times New Roman" panose="02020603050405020304" pitchFamily="18" charset="0"/>
+                          <a:cs typeface="Times New Roman" panose="02020603050405020304" pitchFamily="18" charset="0"/>
+                        </a:rPr>
+                        <a:t>3 fixed: duplicate events, missed abandon form, tie-breaking</a:t>
+                      </a:r>
+                    </a:p>
+                  </a:txBody>
+                  <a:tcPr marL="73152" marR="73152" marT="45720" marB="45720" anchor="ctr">
+                    <a:lnL w="9525">
+                      <a:solidFill>
+                        <a:srgbClr val="C9D3E0"/>
+                      </a:solidFill>
+                    </a:lnL>
+                    <a:lnR w="9525">
+                      <a:solidFill>
+                        <a:srgbClr val="C9D3E0"/>
+                      </a:solidFill>
+                    </a:lnR>
+                    <a:lnT w="9525">
+                      <a:solidFill>
+                        <a:srgbClr val="C9D3E0"/>
+                      </a:solidFill>
+                    </a:lnT>
+                    <a:lnB w="9525">
+                      <a:solidFill>
+                        <a:srgbClr val="C9D3E0"/>
+                      </a:solidFill>
+                    </a:lnB>
+                    <a:solidFill>
+                      <a:srgbClr val="FFFFFF"/>
+                    </a:solidFill>
+                  </a:tcPr>
+                </a:tc>
+              </a:tr>
+            </a:tbl>
+          </a:graphicData>
+        </a:graphic>
+      </p:graphicFrame>
+      <p:sp>
+        <p:nvSpPr>
+          <p:cNvPr id="4" name="Limits 4"/>
+          <p:cNvSpPr txBox="1"/>
+          <p:nvPr/>
+        </p:nvSpPr>
+        <p:spPr>
+          <a:xfrm>
+            <a:off x="457200" y="5715000"/>
+            <a:ext cx="11274552" cy="640080"/>
+          </a:xfrm>
+          <a:prstGeom prst="roundRect">
+            <a:avLst>
+              <a:gd name="adj" fmla="val 6000"/>
+            </a:avLst>
+          </a:prstGeom>
+          <a:solidFill>
+            <a:srgbClr val="F3F6FA"/>
+          </a:solidFill>
+          <a:ln>
+            <a:noFill/>
+          </a:ln>
+        </p:spPr>
+        <p:txBody>
+          <a:bodyPr wrap="square" lIns="109728" tIns="76810" rIns="109728" bIns="76810" rtlCol="0" anchor="ctr">
+            <a:noAutofit/>
+          </a:bodyPr>
+          <a:lstStyle/>
+          <a:p>
+            <a:pPr marL="0" indent="0" algn="l">
+              <a:lnSpc>
+                <a:spcPct val="100000"/>
+              </a:lnSpc>
+              <a:spcBef>
+                <a:spcPts val="0"/>
+              </a:spcBef>
+              <a:spcAft>
+                <a:spcPts val="0"/>
+              </a:spcAft>
+              <a:buNone/>
+            </a:pPr>
+            <a:r>
+              <a:rPr lang="en-IN" sz="1500" b="1" dirty="0">
+                <a:solidFill>
+                  <a:srgbClr val="EB6834"/>
+                </a:solidFill>
+                <a:latin typeface="Times New Roman" panose="02020603050405020304" pitchFamily="18" charset="0"/>
+                <a:cs typeface="Times New Roman" panose="02020603050405020304" pitchFamily="18" charset="0"/>
+              </a:rPr>
+              <a:t>What we did not do: </a:t>
+            </a:r>
+            <a:r>
+              <a:rPr lang="en-IN" sz="1500" dirty="0">
+                <a:solidFill>
+                  <a:srgbClr val="1F2328"/>
+                </a:solidFill>
+                <a:latin typeface="Times New Roman" panose="02020603050405020304" pitchFamily="18" charset="0"/>
+                <a:cs typeface="Times New Roman" panose="02020603050405020304" pitchFamily="18" charset="0"/>
+              </a:rPr>
+              <a:t>independent human labelling; the activity rankings are re-checked only by the bootstrap code; the converters are checked by us only.</a:t>
+            </a:r>
+          </a:p>
+        </p:txBody>
+      </p:sp>
+      <p:sp>
+        <p:nvSpPr>
+          <p:cNvPr id="5" name="Date Placeholder"/>
+          <p:cNvSpPr>
+            <a:spLocks noGrp="1"/>
+          </p:cNvSpPr>
+          <p:nvPr>
+            <p:ph type="dt" sz="half" idx="10"/>
+          </p:nvPr>
+        </p:nvSpPr>
+        <p:spPr/>
+        <p:txBody>
+          <a:bodyPr/>
+          <a:lstStyle/>
+          <a:p>
+            <a:fld id="{61736562-4E3F-4038-A291-A7AE35CC3E6A}" type="datetime1">
+              <a:rPr lang="en-IN" smtClean="0"/>
+              <a:t>28/10/26</a:t>
+            </a:fld>
+            <a:endParaRPr lang="en-IN"/>
+          </a:p>
+        </p:txBody>
+      </p:sp>
+      <p:sp>
+        <p:nvSpPr>
+          <p:cNvPr id="6" name="Footer Placeholder"/>
+          <p:cNvSpPr>
+            <a:spLocks noGrp="1"/>
+          </p:cNvSpPr>
+          <p:nvPr>
+            <p:ph type="ftr" sz="quarter" idx="11"/>
+          </p:nvPr>
+        </p:nvSpPr>
+        <p:spPr/>
+        <p:txBody>
+          <a:bodyPr/>
+          <a:lstStyle/>
+          <a:p>
+            <a:r>
+              <a:rPr lang="en-IN"/>
+              <a:t>SCOPE</a:t>
+            </a:r>
+          </a:p>
+        </p:txBody>
+      </p:sp>
+      <p:sp>
+        <p:nvSpPr>
+          <p:cNvPr id="7" name="Slide Number Placeholder"/>
+          <p:cNvSpPr>
+            <a:spLocks noGrp="1"/>
+          </p:cNvSpPr>
+          <p:nvPr>
+            <p:ph type="sldNum" sz="quarter" idx="12"/>
+          </p:nvPr>
+        </p:nvSpPr>
+        <p:spPr/>
+        <p:txBody>
+          <a:bodyPr/>
+          <a:lstStyle/>
+          <a:p>
+            <a:fld id="{65201FD4-9D8D-4491-815B-63C7BF4F0034}" type="slidenum">
+              <a:rPr lang="en-IN" smtClean="0"/>
+              <a:t>17</a:t>
+            </a:fld>
+            <a:endParaRPr lang="en-IN"/>
+          </a:p>
+        </p:txBody>
+      </p:sp>
+    </p:spTree>
+  </p:cSld>
+  <p:clrMapOvr>
+    <a:masterClrMapping/>
+  </p:clrMapOvr>
+</p:sld>
+</file>
+
+<file path=ppt/slides/slide18.xml><?xml version="1.0" encoding="utf-8"?>
+<p:sld xmlns:a="http://schemas.openxmlformats.org/drawingml/2006/main" xmlns:r="http://schemas.openxmlformats.org/officeDocument/2006/relationships" xmlns:p="http://schemas.openxmlformats.org/presentationml/2006/main">
+  <p:cSld>
+    <p:spTree>
+      <p:nvGrpSpPr>
+        <p:cNvPr id="1" name=""/>
+        <p:cNvGrpSpPr/>
+        <p:nvPr/>
+      </p:nvGrpSpPr>
+      <p:grpSpPr>
+        <a:xfrm>
+          <a:off x="0" y="0"/>
+          <a:ext cx="0" cy="0"/>
+          <a:chOff x="0" y="0"/>
+          <a:chExt cx="0" cy="0"/>
+        </a:xfrm>
+      </p:grpSpPr>
+      <p:sp>
+        <p:nvSpPr>
+          <p:cNvPr id="2" name="Title 2"/>
+          <p:cNvSpPr txBox="1">
+            <a:spLocks noGrp="1"/>
+          </p:cNvSpPr>
+          <p:nvPr>
+            <p:ph type="title"/>
+          </p:nvPr>
+        </p:nvSpPr>
+        <p:spPr>
+          <a:xfrm>
+            <a:off x="457200" y="502920"/>
+            <a:ext cx="11274552" cy="685800"/>
+          </a:xfrm>
+          <a:prstGeom prst="rect">
+            <a:avLst/>
+          </a:prstGeom>
+        </p:spPr>
+        <p:txBody>
+          <a:bodyPr vert="horz" wrap="square" lIns="0" tIns="0" rIns="0" bIns="0" rtlCol="0" anchor="ctr">
+            <a:noAutofit/>
+          </a:bodyPr>
+          <a:lstStyle/>
+          <a:p>
+            <a:pPr marL="0">
+              <a:lnSpc>
+                <a:spcPct val="100000"/>
+              </a:lnSpc>
+            </a:pPr>
+            <a:r>
+              <a:rPr lang="en-IN" sz="3000" b="1" dirty="0">
+                <a:latin typeface="Times New Roman" panose="02020603050405020304" pitchFamily="18" charset="0"/>
+                <a:cs typeface="Times New Roman" panose="02020603050405020304" pitchFamily="18" charset="0"/>
+              </a:rPr>
               <a:t>Conclusion and Future Work</a:t>
             </a:r>
           </a:p>
@@ -11121,7 +11699,7 @@
                 <a:spcPct val="100000"/>
               </a:lnSpc>
               <a:spcBef>
-                <a:spcPts val="1400"/>
+                <a:spcPts val="1200"/>
               </a:spcBef>
               <a:spcAft>
                 <a:spcPts val="0"/>
@@ -11130,7 +11708,7 @@
               <a:buChar char="•"/>
             </a:pPr>
             <a:r>
-              <a:rPr lang="en-IN" sz="1900" dirty="0">
+              <a:rPr lang="en-IN" sz="1800" dirty="0">
                 <a:solidFill>
                   <a:srgbClr val="1F2328"/>
                 </a:solidFill>
@@ -11146,7 +11724,7 @@
                 <a:spcPct val="100000"/>
               </a:lnSpc>
               <a:spcBef>
-                <a:spcPts val="1400"/>
+                <a:spcPts val="1200"/>
               </a:spcBef>
               <a:spcAft>
                 <a:spcPts val="0"/>
@@ -11155,7 +11733,7 @@
               <a:buChar char="•"/>
             </a:pPr>
             <a:r>
-              <a:rPr lang="en-IN" sz="1900" dirty="0">
+              <a:rPr lang="en-IN" sz="1800" dirty="0">
                 <a:solidFill>
                   <a:srgbClr val="1F2328"/>
                 </a:solidFill>
@@ -11171,7 +11749,7 @@
                 <a:spcPct val="100000"/>
               </a:lnSpc>
               <a:spcBef>
-                <a:spcPts val="1400"/>
+                <a:spcPts val="1200"/>
               </a:spcBef>
               <a:spcAft>
                 <a:spcPts val="0"/>
@@ -11180,7 +11758,32 @@
               <a:buChar char="•"/>
             </a:pPr>
             <a:r>
-              <a:rPr lang="en-IN" sz="1900" dirty="0">
+              <a:rPr lang="en-IN" sz="1800" dirty="0">
+                <a:solidFill>
+                  <a:srgbClr val="1F2328"/>
+                </a:solidFill>
+                <a:latin typeface="Times New Roman" panose="02020603050405020304" pitchFamily="18" charset="0"/>
+                <a:cs typeface="Times New Roman" panose="02020603050405020304" pitchFamily="18" charset="0"/>
+              </a:rPr>
+              <a:t>Mined models look healthy (fitness 0.955 or more) even when they show a sliver of the process.</a:t>
+            </a:r>
+          </a:p>
+          <a:p>
+            <a:pPr marL="285750" indent="-285750" algn="l">
+              <a:lnSpc>
+                <a:spcPct val="100000"/>
+              </a:lnSpc>
+              <a:spcBef>
+                <a:spcPts val="1200"/>
+              </a:spcBef>
+              <a:spcAft>
+                <a:spcPts val="0"/>
+              </a:spcAft>
+              <a:buFont typeface="Arial" panose="020B0604020202020204" pitchFamily="34" charset="0"/>
+              <a:buChar char="•"/>
+            </a:pPr>
+            <a:r>
+              <a:rPr lang="en-IN" sz="1800" dirty="0">
                 <a:solidFill>
                   <a:srgbClr val="1F2328"/>
                 </a:solidFill>
@@ -11196,7 +11799,7 @@
                 <a:spcPct val="100000"/>
               </a:lnSpc>
               <a:spcBef>
-                <a:spcPts val="1400"/>
+                <a:spcPts val="1200"/>
               </a:spcBef>
               <a:spcAft>
                 <a:spcPts val="0"/>
@@ -11205,7 +11808,7 @@
               <a:buChar char="•"/>
             </a:pPr>
             <a:r>
-              <a:rPr lang="en-IN" sz="1900" dirty="0">
+              <a:rPr lang="en-IN" sz="1800" dirty="0">
                 <a:solidFill>
                   <a:srgbClr val="1F2328"/>
                 </a:solidFill>
@@ -11275,7 +11878,7 @@
                 <a:spcPct val="100000"/>
               </a:lnSpc>
               <a:spcBef>
-                <a:spcPts val="1400"/>
+                <a:spcPts val="1200"/>
               </a:spcBef>
               <a:spcAft>
                 <a:spcPts val="0"/>
@@ -11284,7 +11887,7 @@
               <a:buChar char="•"/>
             </a:pPr>
             <a:r>
-              <a:rPr lang="en-IN" sz="1900" dirty="0">
+              <a:rPr lang="en-IN" sz="1800" dirty="0">
                 <a:solidFill>
                   <a:srgbClr val="1F2328"/>
                 </a:solidFill>
@@ -11300,7 +11903,7 @@
                 <a:spcPct val="100000"/>
               </a:lnSpc>
               <a:spcBef>
-                <a:spcPts val="1400"/>
+                <a:spcPts val="1200"/>
               </a:spcBef>
               <a:spcAft>
                 <a:spcPts val="0"/>
@@ -11309,14 +11912,14 @@
               <a:buChar char="•"/>
             </a:pPr>
             <a:r>
-              <a:rPr lang="en-IN" sz="1900" dirty="0">
+              <a:rPr lang="en-IN" sz="1800" dirty="0">
                 <a:solidFill>
                   <a:srgbClr val="1F2328"/>
                 </a:solidFill>
                 <a:latin typeface="Times New Roman" panose="02020603050405020304" pitchFamily="18" charset="0"/>
                 <a:cs typeface="Times New Roman" panose="02020603050405020304" pitchFamily="18" charset="0"/>
               </a:rPr>
-              <a:t>Process-discovery quality and predictive-monitoring comparisons.</a:t>
+              <a:t>Predictive-monitoring comparisons, and the discovery comparison with other miners.</a:t>
             </a:r>
           </a:p>
           <a:p>
@@ -11325,7 +11928,7 @@
                 <a:spcPct val="100000"/>
               </a:lnSpc>
               <a:spcBef>
-                <a:spcPts val="1400"/>
+                <a:spcPts val="1200"/>
               </a:spcBef>
               <a:spcAft>
                 <a:spcPts val="0"/>
@@ -11334,64 +11937,14 @@
               <a:buChar char="•"/>
             </a:pPr>
             <a:r>
-              <a:rPr lang="en-IN" sz="1900" dirty="0">
+              <a:rPr lang="en-IN" sz="1800" dirty="0">
                 <a:solidFill>
                   <a:srgbClr val="1F2328"/>
                 </a:solidFill>
                 <a:latin typeface="Times New Roman" panose="02020603050405020304" pitchFamily="18" charset="0"/>
                 <a:cs typeface="Times New Roman" panose="02020603050405020304" pitchFamily="18" charset="0"/>
               </a:rPr>
-              <a:t>Two or three more real logs (for example BPI 2019).</a:t>
-            </a:r>
-          </a:p>
-          <a:p>
-            <a:pPr marL="285750" indent="-285750" algn="l">
-              <a:lnSpc>
-                <a:spcPct val="100000"/>
-              </a:lnSpc>
-              <a:spcBef>
-                <a:spcPts val="1400"/>
-              </a:spcBef>
-              <a:spcAft>
-                <a:spcPts val="0"/>
-              </a:spcAft>
-              <a:buFont typeface="Arial" panose="020B0604020202020204" pitchFamily="34" charset="0"/>
-              <a:buChar char="•"/>
-            </a:pPr>
-            <a:r>
-              <a:rPr lang="en-IN" sz="1900" dirty="0">
-                <a:solidFill>
-                  <a:srgbClr val="1F2328"/>
-                </a:solidFill>
-                <a:latin typeface="Times New Roman" panose="02020603050405020304" pitchFamily="18" charset="0"/>
-                <a:cs typeface="Times New Roman" panose="02020603050405020304" pitchFamily="18" charset="0"/>
-              </a:rPr>
-              <a:t>A portal adapter once de-identified audit logs are approved.</a:t>
-            </a:r>
-          </a:p>
-          <a:p>
-            <a:pPr marL="285750" indent="-285750" algn="l">
-              <a:lnSpc>
-                <a:spcPct val="100000"/>
-              </a:lnSpc>
-              <a:spcBef>
-                <a:spcPts val="1400"/>
-              </a:spcBef>
-              <a:spcAft>
-                <a:spcPts val="0"/>
-              </a:spcAft>
-              <a:buFont typeface="Arial" panose="020B0604020202020204" pitchFamily="34" charset="0"/>
-              <a:buChar char="•"/>
-            </a:pPr>
-            <a:r>
-              <a:rPr lang="en-IN" sz="1900" dirty="0">
-                <a:solidFill>
-                  <a:srgbClr val="1F2328"/>
-                </a:solidFill>
-                <a:latin typeface="Times New Roman" panose="02020603050405020304" pitchFamily="18" charset="0"/>
-                <a:cs typeface="Times New Roman" panose="02020603050405020304" pitchFamily="18" charset="0"/>
-              </a:rPr>
-              <a:t>Journal manuscript, venue still to be chosen.</a:t>
+              <a:t>Answer the JIIS reviewers and revise the paper.</a:t>
             </a:r>
           </a:p>
         </p:txBody>
@@ -11458,7 +12011,7 @@
           <a:p>
             <a:fld id="{65201FD4-9D8D-4491-815B-63C7BF4F0034}" type="slidenum">
               <a:rPr lang="en-IN" smtClean="0"/>
-              <a:t>17</a:t>
+              <a:t>18</a:t>
             </a:fld>
             <a:endParaRPr lang="en-IN"/>
           </a:p>
@@ -11472,7 +12025,7 @@
 </p:sld>
 </file>
 
-<file path=ppt/slides/slide18.xml><?xml version="1.0" encoding="utf-8"?>
+<file path=ppt/slides/slide19.xml><?xml version="1.0" encoding="utf-8"?>
 <p:sld xmlns:a="http://schemas.openxmlformats.org/drawingml/2006/main" xmlns:r="http://schemas.openxmlformats.org/officeDocument/2006/relationships" xmlns:p="http://schemas.openxmlformats.org/presentationml/2006/main">
   <p:cSld>
     <p:spTree>
@@ -11966,7 +12519,7 @@
                           <a:latin typeface="Times New Roman" panose="02020603050405020304" pitchFamily="18" charset="0"/>
                           <a:cs typeface="Times New Roman" panose="02020603050405020304" pitchFamily="18" charset="0"/>
                         </a:rPr>
-                        <a:t>Manuscript in preparation (draft v0.3); not submitted; venue not yet chosen</a:t>
+                        <a:t>Submitted to the Journal of Intelligent Information Systems (Springer; Scopus, SCIE), 27 Oct 2026; under review</a:t>
                       </a:r>
                     </a:p>
                   </a:txBody>
@@ -12284,7 +12837,30 @@
                 <a:latin typeface="Times New Roman" panose="02020603050405020304" pitchFamily="18" charset="0"/>
                 <a:cs typeface="Times New Roman" panose="02020603050405020304" pitchFamily="18" charset="0"/>
               </a:rPr>
-              <a:t>none yet, because nothing has been accepted or published. We will upload proof as soon as a submission receipt or acceptance exists.</a:t>
+              <a:t>the Springer submission acknowledgement e-mail, manuscript number </a:t>
+            </a:r>
+            <a:r>
+              <a:rPr lang="en-IN" sz="1500" dirty="0">
+                <a:solidFill>
+                  <a:srgbClr val="1F2328"/>
+                </a:solidFill>
+                <a:highlight>
+                  <a:srgbClr val="FFFF00"/>
+                </a:highlight>
+                <a:latin typeface="Times New Roman" panose="02020603050405020304" pitchFamily="18" charset="0"/>
+                <a:cs typeface="Times New Roman" panose="02020603050405020304" pitchFamily="18" charset="0"/>
+              </a:rPr>
+              <a:t>[fill in]</a:t>
+            </a:r>
+            <a:r>
+              <a:rPr lang="en-IN" sz="1500" dirty="0">
+                <a:solidFill>
+                  <a:srgbClr val="1F2328"/>
+                </a:solidFill>
+                <a:latin typeface="Times New Roman" panose="02020603050405020304" pitchFamily="18" charset="0"/>
+                <a:cs typeface="Times New Roman" panose="02020603050405020304" pitchFamily="18" charset="0"/>
+              </a:rPr>
+              <a:t>. Acceptance is not yet decided.</a:t>
             </a:r>
           </a:p>
           <a:p>
@@ -12322,479 +12898,6 @@
                 <a:cs typeface="Times New Roman" panose="02020603050405020304" pitchFamily="18" charset="0"/>
               </a:rPr>
               <a:t>[confirm submitted]</a:t>
-            </a:r>
-          </a:p>
-        </p:txBody>
-      </p:sp>
-      <p:sp>
-        <p:nvSpPr>
-          <p:cNvPr id="5" name="Date Placeholder"/>
-          <p:cNvSpPr>
-            <a:spLocks noGrp="1"/>
-          </p:cNvSpPr>
-          <p:nvPr>
-            <p:ph type="dt" sz="half" idx="10"/>
-          </p:nvPr>
-        </p:nvSpPr>
-        <p:spPr/>
-        <p:txBody>
-          <a:bodyPr/>
-          <a:lstStyle/>
-          <a:p>
-            <a:fld id="{61736562-4E3F-4038-A291-A7AE35CC3E6A}" type="datetime1">
-              <a:rPr lang="en-IN" smtClean="0"/>
-              <a:t>28/10/26</a:t>
-            </a:fld>
-            <a:endParaRPr lang="en-IN"/>
-          </a:p>
-        </p:txBody>
-      </p:sp>
-      <p:sp>
-        <p:nvSpPr>
-          <p:cNvPr id="6" name="Footer Placeholder"/>
-          <p:cNvSpPr>
-            <a:spLocks noGrp="1"/>
-          </p:cNvSpPr>
-          <p:nvPr>
-            <p:ph type="ftr" sz="quarter" idx="11"/>
-          </p:nvPr>
-        </p:nvSpPr>
-        <p:spPr/>
-        <p:txBody>
-          <a:bodyPr/>
-          <a:lstStyle/>
-          <a:p>
-            <a:r>
-              <a:rPr lang="en-IN"/>
-              <a:t>SCOPE</a:t>
-            </a:r>
-          </a:p>
-        </p:txBody>
-      </p:sp>
-      <p:sp>
-        <p:nvSpPr>
-          <p:cNvPr id="7" name="Slide Number Placeholder"/>
-          <p:cNvSpPr>
-            <a:spLocks noGrp="1"/>
-          </p:cNvSpPr>
-          <p:nvPr>
-            <p:ph type="sldNum" sz="quarter" idx="12"/>
-          </p:nvPr>
-        </p:nvSpPr>
-        <p:spPr/>
-        <p:txBody>
-          <a:bodyPr/>
-          <a:lstStyle/>
-          <a:p>
-            <a:fld id="{65201FD4-9D8D-4491-815B-63C7BF4F0034}" type="slidenum">
-              <a:rPr lang="en-IN" smtClean="0"/>
-              <a:t>18</a:t>
-            </a:fld>
-            <a:endParaRPr lang="en-IN"/>
-          </a:p>
-        </p:txBody>
-      </p:sp>
-    </p:spTree>
-  </p:cSld>
-  <p:clrMapOvr>
-    <a:masterClrMapping/>
-  </p:clrMapOvr>
-</p:sld>
-</file>
-
-<file path=ppt/slides/slide19.xml><?xml version="1.0" encoding="utf-8"?>
-<p:sld xmlns:a="http://schemas.openxmlformats.org/drawingml/2006/main" xmlns:r="http://schemas.openxmlformats.org/officeDocument/2006/relationships" xmlns:p="http://schemas.openxmlformats.org/presentationml/2006/main">
-  <p:cSld>
-    <p:spTree>
-      <p:nvGrpSpPr>
-        <p:cNvPr id="1" name=""/>
-        <p:cNvGrpSpPr/>
-        <p:nvPr/>
-      </p:nvGrpSpPr>
-      <p:grpSpPr>
-        <a:xfrm>
-          <a:off x="0" y="0"/>
-          <a:ext cx="0" cy="0"/>
-          <a:chOff x="0" y="0"/>
-          <a:chExt cx="0" cy="0"/>
-        </a:xfrm>
-      </p:grpSpPr>
-      <p:sp>
-        <p:nvSpPr>
-          <p:cNvPr id="2" name="Title 2"/>
-          <p:cNvSpPr txBox="1">
-            <a:spLocks noGrp="1"/>
-          </p:cNvSpPr>
-          <p:nvPr>
-            <p:ph type="title"/>
-          </p:nvPr>
-        </p:nvSpPr>
-        <p:spPr>
-          <a:xfrm>
-            <a:off x="457200" y="502920"/>
-            <a:ext cx="11274552" cy="685800"/>
-          </a:xfrm>
-          <a:prstGeom prst="rect">
-            <a:avLst/>
-          </a:prstGeom>
-        </p:spPr>
-        <p:txBody>
-          <a:bodyPr vert="horz" wrap="square" lIns="0" tIns="0" rIns="0" bIns="0" rtlCol="0" anchor="ctr">
-            <a:noAutofit/>
-          </a:bodyPr>
-          <a:lstStyle/>
-          <a:p>
-            <a:pPr marL="0">
-              <a:lnSpc>
-                <a:spcPct val="100000"/>
-              </a:lnSpc>
-            </a:pPr>
-            <a:r>
-              <a:rPr lang="en-IN" sz="3000" b="1" dirty="0">
-                <a:latin typeface="Times New Roman" panose="02020603050405020304" pitchFamily="18" charset="0"/>
-                <a:cs typeface="Times New Roman" panose="02020603050405020304" pitchFamily="18" charset="0"/>
-              </a:rPr>
-              <a:t>References</a:t>
-            </a:r>
-          </a:p>
-        </p:txBody>
-      </p:sp>
-      <p:sp>
-        <p:nvSpPr>
-          <p:cNvPr id="3" name="Refs left 3"/>
-          <p:cNvSpPr txBox="1"/>
-          <p:nvPr/>
-        </p:nvSpPr>
-        <p:spPr>
-          <a:xfrm>
-            <a:off x="457200" y="1325880"/>
-            <a:ext cx="5577840" cy="4846320"/>
-          </a:xfrm>
-          <a:prstGeom prst="rect">
-            <a:avLst/>
-          </a:prstGeom>
-          <a:noFill/>
-          <a:ln>
-            <a:noFill/>
-          </a:ln>
-        </p:spPr>
-        <p:txBody>
-          <a:bodyPr wrap="square" lIns="109728" tIns="76810" rIns="109728" bIns="76810" rtlCol="0" anchor="t">
-            <a:noAutofit/>
-          </a:bodyPr>
-          <a:lstStyle/>
-          <a:p>
-            <a:pPr marL="0" indent="0" algn="l">
-              <a:lnSpc>
-                <a:spcPct val="100000"/>
-              </a:lnSpc>
-              <a:spcBef>
-                <a:spcPts val="700"/>
-              </a:spcBef>
-              <a:spcAft>
-                <a:spcPts val="0"/>
-              </a:spcAft>
-              <a:buNone/>
-            </a:pPr>
-            <a:r>
-              <a:rPr lang="en-IN" sz="1400" dirty="0">
-                <a:solidFill>
-                  <a:srgbClr val="1F2328"/>
-                </a:solidFill>
-                <a:latin typeface="Times New Roman" panose="02020603050405020304" pitchFamily="18" charset="0"/>
-                <a:cs typeface="Times New Roman" panose="02020603050405020304" pitchFamily="18" charset="0"/>
-              </a:rPr>
-              <a:t>[1] W. M. P. van der Aalst, "Object-centric process mining: Dealing with divergence and convergence in event data," in SEFM, LNCS, Springer, 2019, pp. 3-25.</a:t>
-            </a:r>
-          </a:p>
-          <a:p>
-            <a:pPr marL="0" indent="0" algn="l">
-              <a:lnSpc>
-                <a:spcPct val="100000"/>
-              </a:lnSpc>
-              <a:spcBef>
-                <a:spcPts val="700"/>
-              </a:spcBef>
-              <a:spcAft>
-                <a:spcPts val="0"/>
-              </a:spcAft>
-              <a:buNone/>
-            </a:pPr>
-            <a:r>
-              <a:rPr lang="en-IN" sz="1400" dirty="0">
-                <a:solidFill>
-                  <a:srgbClr val="1F2328"/>
-                </a:solidFill>
-                <a:latin typeface="Times New Roman" panose="02020603050405020304" pitchFamily="18" charset="0"/>
-                <a:cs typeface="Times New Roman" panose="02020603050405020304" pitchFamily="18" charset="0"/>
-              </a:rPr>
-              <a:t>[2] A. Berti et al., "OCEL (Object-Centric Event Log) 2.0 specification," arXiv:2403.01975, 2024.</a:t>
-            </a:r>
-          </a:p>
-          <a:p>
-            <a:pPr marL="0" indent="0" algn="l">
-              <a:lnSpc>
-                <a:spcPct val="100000"/>
-              </a:lnSpc>
-              <a:spcBef>
-                <a:spcPts val="700"/>
-              </a:spcBef>
-              <a:spcAft>
-                <a:spcPts val="0"/>
-              </a:spcAft>
-              <a:buNone/>
-            </a:pPr>
-            <a:r>
-              <a:rPr lang="en-IN" sz="1400" dirty="0">
-                <a:solidFill>
-                  <a:srgbClr val="1F2328"/>
-                </a:solidFill>
-                <a:latin typeface="Times New Roman" panose="02020603050405020304" pitchFamily="18" charset="0"/>
-                <a:cs typeface="Times New Roman" panose="02020603050405020304" pitchFamily="18" charset="0"/>
-              </a:rPr>
-              <a:t>[3] J. N. Adams, G. Park, and W. M. P. van der Aalst, "Preserving complex object-centric graph structures to improve machine learning tasks in process mining," Eng. Appl. Artif. Intell., vol. 125, p. 106764, 2023.</a:t>
-            </a:r>
-          </a:p>
-          <a:p>
-            <a:pPr marL="0" indent="0" algn="l">
-              <a:lnSpc>
-                <a:spcPct val="100000"/>
-              </a:lnSpc>
-              <a:spcBef>
-                <a:spcPts val="700"/>
-              </a:spcBef>
-              <a:spcAft>
-                <a:spcPts val="0"/>
-              </a:spcAft>
-              <a:buNone/>
-            </a:pPr>
-            <a:r>
-              <a:rPr lang="en-IN" sz="1400" dirty="0">
-                <a:solidFill>
-                  <a:srgbClr val="1F2328"/>
-                </a:solidFill>
-                <a:latin typeface="Times New Roman" panose="02020603050405020304" pitchFamily="18" charset="0"/>
-                <a:cs typeface="Times New Roman" panose="02020603050405020304" pitchFamily="18" charset="0"/>
-              </a:rPr>
-              <a:t>[4] J. N. Adams and W. M. P. van der Aalst, "Addressing convergence, divergence, and deficiency issues," LNBIP, Springer, 2024.</a:t>
-            </a:r>
-          </a:p>
-          <a:p>
-            <a:pPr marL="0" indent="0" algn="l">
-              <a:lnSpc>
-                <a:spcPct val="100000"/>
-              </a:lnSpc>
-              <a:spcBef>
-                <a:spcPts val="700"/>
-              </a:spcBef>
-              <a:spcAft>
-                <a:spcPts val="0"/>
-              </a:spcAft>
-              <a:buNone/>
-            </a:pPr>
-            <a:r>
-              <a:rPr lang="en-IN" sz="1400" dirty="0">
-                <a:solidFill>
-                  <a:srgbClr val="1F2328"/>
-                </a:solidFill>
-                <a:latin typeface="Times New Roman" panose="02020603050405020304" pitchFamily="18" charset="0"/>
-                <a:cs typeface="Times New Roman" panose="02020603050405020304" pitchFamily="18" charset="0"/>
-              </a:rPr>
-              <a:t>[5] P. Waibel, L. Pfahlsberger, K. Revoredo, and J. Mendling, "Causal process mining from relational databases with domain knowledge," arXiv:2202.08314, 2022.</a:t>
-            </a:r>
-          </a:p>
-          <a:p>
-            <a:pPr marL="0" indent="0" algn="l">
-              <a:lnSpc>
-                <a:spcPct val="100000"/>
-              </a:lnSpc>
-              <a:spcBef>
-                <a:spcPts val="700"/>
-              </a:spcBef>
-              <a:spcAft>
-                <a:spcPts val="0"/>
-              </a:spcAft>
-              <a:buNone/>
-            </a:pPr>
-            <a:r>
-              <a:rPr lang="en-IN" sz="1400" dirty="0">
-                <a:solidFill>
-                  <a:srgbClr val="1F2328"/>
-                </a:solidFill>
-                <a:latin typeface="Times New Roman" panose="02020603050405020304" pitchFamily="18" charset="0"/>
-                <a:cs typeface="Times New Roman" panose="02020603050405020304" pitchFamily="18" charset="0"/>
-              </a:rPr>
-              <a:t>[6] M. Kabierski et al., "Data quality in object-centric event data: Issues classification and evaluation," Process Science, vol. 3, 2026.</a:t>
-            </a:r>
-          </a:p>
-        </p:txBody>
-      </p:sp>
-      <p:sp>
-        <p:nvSpPr>
-          <p:cNvPr id="4" name="Refs right 4"/>
-          <p:cNvSpPr txBox="1"/>
-          <p:nvPr/>
-        </p:nvSpPr>
-        <p:spPr>
-          <a:xfrm>
-            <a:off x="6172200" y="1325880"/>
-            <a:ext cx="5577840" cy="4846320"/>
-          </a:xfrm>
-          <a:prstGeom prst="rect">
-            <a:avLst/>
-          </a:prstGeom>
-          <a:noFill/>
-          <a:ln>
-            <a:noFill/>
-          </a:ln>
-        </p:spPr>
-        <p:txBody>
-          <a:bodyPr wrap="square" lIns="109728" tIns="76810" rIns="109728" bIns="76810" rtlCol="0" anchor="t">
-            <a:noAutofit/>
-          </a:bodyPr>
-          <a:lstStyle/>
-          <a:p>
-            <a:pPr marL="0" indent="0" algn="l">
-              <a:lnSpc>
-                <a:spcPct val="100000"/>
-              </a:lnSpc>
-              <a:spcBef>
-                <a:spcPts val="700"/>
-              </a:spcBef>
-              <a:spcAft>
-                <a:spcPts val="0"/>
-              </a:spcAft>
-              <a:buNone/>
-            </a:pPr>
-            <a:r>
-              <a:rPr lang="en-IN" sz="1400" dirty="0">
-                <a:solidFill>
-                  <a:srgbClr val="1F2328"/>
-                </a:solidFill>
-                <a:latin typeface="Times New Roman" panose="02020603050405020304" pitchFamily="18" charset="0"/>
-                <a:cs typeface="Times New Roman" panose="02020603050405020304" pitchFamily="18" charset="0"/>
-              </a:rPr>
-              <a:t>[7] N. Miri, S. Khayatbashi, J. Zdravkovic, and A. Jalali, "An object-centric approach to multi-entity educational process mining," Decis. Anal. J., vol. 19, p. 100724, 2026.</a:t>
-            </a:r>
-          </a:p>
-          <a:p>
-            <a:pPr marL="0" indent="0" algn="l">
-              <a:lnSpc>
-                <a:spcPct val="100000"/>
-              </a:lnSpc>
-              <a:spcBef>
-                <a:spcPts val="700"/>
-              </a:spcBef>
-              <a:spcAft>
-                <a:spcPts val="0"/>
-              </a:spcAft>
-              <a:buNone/>
-            </a:pPr>
-            <a:r>
-              <a:rPr lang="en-IN" sz="1400" dirty="0">
-                <a:solidFill>
-                  <a:srgbClr val="1F2328"/>
-                </a:solidFill>
-                <a:latin typeface="Times New Roman" panose="02020603050405020304" pitchFamily="18" charset="0"/>
-                <a:cs typeface="Times New Roman" panose="02020603050405020304" pitchFamily="18" charset="0"/>
-              </a:rPr>
-              <a:t>[8] J. Kuzilek, M. Hlosta, and Z. Zdrahal, "Open University Learning Analytics dataset," Sci. Data, vol. 4, p. 170171, 2017.</a:t>
-            </a:r>
-          </a:p>
-          <a:p>
-            <a:pPr marL="0" indent="0" algn="l">
-              <a:lnSpc>
-                <a:spcPct val="100000"/>
-              </a:lnSpc>
-              <a:spcBef>
-                <a:spcPts val="700"/>
-              </a:spcBef>
-              <a:spcAft>
-                <a:spcPts val="0"/>
-              </a:spcAft>
-              <a:buNone/>
-            </a:pPr>
-            <a:r>
-              <a:rPr lang="en-IN" sz="1400" dirty="0">
-                <a:solidFill>
-                  <a:srgbClr val="1F2328"/>
-                </a:solidFill>
-                <a:latin typeface="Times New Roman" panose="02020603050405020304" pitchFamily="18" charset="0"/>
-                <a:cs typeface="Times New Roman" panose="02020603050405020304" pitchFamily="18" charset="0"/>
-              </a:rPr>
-              <a:t>[9] M. Paixao, J. Krinke, D. Han, and M. Harman, "CROP: Linking code reviews to source code changes," in Proc. MSR, 2018.</a:t>
-            </a:r>
-          </a:p>
-          <a:p>
-            <a:pPr marL="0" indent="0" algn="l">
-              <a:lnSpc>
-                <a:spcPct val="100000"/>
-              </a:lnSpc>
-              <a:spcBef>
-                <a:spcPts val="700"/>
-              </a:spcBef>
-              <a:spcAft>
-                <a:spcPts val="0"/>
-              </a:spcAft>
-              <a:buNone/>
-            </a:pPr>
-            <a:r>
-              <a:rPr lang="en-IN" sz="1400" dirty="0">
-                <a:solidFill>
-                  <a:srgbClr val="1F2328"/>
-                </a:solidFill>
-                <a:latin typeface="Times New Roman" panose="02020603050405020304" pitchFamily="18" charset="0"/>
-                <a:cs typeface="Times New Roman" panose="02020603050405020304" pitchFamily="18" charset="0"/>
-              </a:rPr>
-              <a:t>[10] H. Hassani et al., "Supervision of undergraduate final year projects in computing: A case study," Educ. Sci., vol. 8, no. 4, p. 210, 2018.</a:t>
-            </a:r>
-          </a:p>
-          <a:p>
-            <a:pPr marL="0" indent="0" algn="l">
-              <a:lnSpc>
-                <a:spcPct val="100000"/>
-              </a:lnSpc>
-              <a:spcBef>
-                <a:spcPts val="700"/>
-              </a:spcBef>
-              <a:spcAft>
-                <a:spcPts val="0"/>
-              </a:spcAft>
-              <a:buNone/>
-            </a:pPr>
-            <a:r>
-              <a:rPr lang="en-IN" sz="1400" dirty="0">
-                <a:solidFill>
-                  <a:srgbClr val="1F2328"/>
-                </a:solidFill>
-                <a:latin typeface="Times New Roman" panose="02020603050405020304" pitchFamily="18" charset="0"/>
-                <a:cs typeface="Times New Roman" panose="02020603050405020304" pitchFamily="18" charset="0"/>
-              </a:rPr>
-              <a:t>[11] W. Premchaiswadi and P. Porouhan, "Process modeling and bottleneck mining in online peer-review systems," SpringerPlus, vol. 4, p. 441, 2015.</a:t>
-            </a:r>
-          </a:p>
-          <a:p>
-            <a:pPr marL="0" indent="0" algn="l">
-              <a:lnSpc>
-                <a:spcPct val="100000"/>
-              </a:lnSpc>
-              <a:spcBef>
-                <a:spcPts val="700"/>
-              </a:spcBef>
-              <a:spcAft>
-                <a:spcPts val="0"/>
-              </a:spcAft>
-              <a:buNone/>
-            </a:pPr>
-            <a:r>
-              <a:rPr lang="en-IN" sz="1400" dirty="0">
-                <a:solidFill>
-                  <a:srgbClr val="1F2328"/>
-                </a:solidFill>
-                <a:latin typeface="Times New Roman" panose="02020603050405020304" pitchFamily="18" charset="0"/>
-                <a:cs typeface="Times New Roman" panose="02020603050405020304" pitchFamily="18" charset="0"/>
-              </a:rPr>
-              <a:t>[12] Datasets (CC BY 4.0): Zenodo 16811928 (Bundestag), 21989732 (Enron), 21989580 (Ethereum), 13365584 (Age of Empires), 8430332 (Angular), 3599150 (CROP); UCI 10.24432/C5KK69 (OULAD).</a:t>
             </a:r>
           </a:p>
         </p:txBody>
@@ -13225,7 +13328,7 @@
                 <a:latin typeface="Times New Roman" panose="02020603050405020304" pitchFamily="18" charset="0"/>
                 <a:cs typeface="Times New Roman" panose="02020603050405020304" pitchFamily="18" charset="0"/>
               </a:rPr>
-              <a:t>Ongoing</a:t>
+              <a:t>Journal paper submitted</a:t>
             </a:r>
             <a:r>
               <a:rPr lang="en-IN" sz="1600" dirty="0">
@@ -13235,7 +13338,7 @@
                 <a:latin typeface="Times New Roman" panose="02020603050405020304" pitchFamily="18" charset="0"/>
                 <a:cs typeface="Times New Roman" panose="02020603050405020304" pitchFamily="18" charset="0"/>
               </a:rPr>
-              <a:t> (manuscript in preparation)</a:t>
+              <a:t> (JIIS, under review)</a:t>
             </a:r>
           </a:p>
           <a:p>
@@ -13427,6 +13530,575 @@
             <a:fld id="{65201FD4-9D8D-4491-815B-63C7BF4F0034}" type="slidenum">
               <a:rPr lang="en-IN" smtClean="0"/>
               <a:t>2</a:t>
+            </a:fld>
+            <a:endParaRPr lang="en-IN"/>
+          </a:p>
+        </p:txBody>
+      </p:sp>
+    </p:spTree>
+  </p:cSld>
+  <p:clrMapOvr>
+    <a:masterClrMapping/>
+  </p:clrMapOvr>
+</p:sld>
+</file>
+
+<file path=ppt/slides/slide20.xml><?xml version="1.0" encoding="utf-8"?>
+<p:sld xmlns:a="http://schemas.openxmlformats.org/drawingml/2006/main" xmlns:r="http://schemas.openxmlformats.org/officeDocument/2006/relationships" xmlns:p="http://schemas.openxmlformats.org/presentationml/2006/main">
+  <p:cSld>
+    <p:spTree>
+      <p:nvGrpSpPr>
+        <p:cNvPr id="1" name=""/>
+        <p:cNvGrpSpPr/>
+        <p:nvPr/>
+      </p:nvGrpSpPr>
+      <p:grpSpPr>
+        <a:xfrm>
+          <a:off x="0" y="0"/>
+          <a:ext cx="0" cy="0"/>
+          <a:chOff x="0" y="0"/>
+          <a:chExt cx="0" cy="0"/>
+        </a:xfrm>
+      </p:grpSpPr>
+      <p:sp>
+        <p:nvSpPr>
+          <p:cNvPr id="2" name="Title 2"/>
+          <p:cNvSpPr txBox="1">
+            <a:spLocks noGrp="1"/>
+          </p:cNvSpPr>
+          <p:nvPr>
+            <p:ph type="title"/>
+          </p:nvPr>
+        </p:nvSpPr>
+        <p:spPr>
+          <a:xfrm>
+            <a:off x="457200" y="502920"/>
+            <a:ext cx="11274552" cy="685800"/>
+          </a:xfrm>
+          <a:prstGeom prst="rect">
+            <a:avLst/>
+          </a:prstGeom>
+        </p:spPr>
+        <p:txBody>
+          <a:bodyPr vert="horz" wrap="square" lIns="0" tIns="0" rIns="0" bIns="0" rtlCol="0" anchor="ctr">
+            <a:noAutofit/>
+          </a:bodyPr>
+          <a:lstStyle/>
+          <a:p>
+            <a:pPr marL="0">
+              <a:lnSpc>
+                <a:spcPct val="100000"/>
+              </a:lnSpc>
+            </a:pPr>
+            <a:r>
+              <a:rPr lang="en-IN" sz="3000" b="1" dirty="0">
+                <a:latin typeface="Times New Roman" panose="02020603050405020304" pitchFamily="18" charset="0"/>
+                <a:cs typeface="Times New Roman" panose="02020603050405020304" pitchFamily="18" charset="0"/>
+              </a:rPr>
+              <a:t>References</a:t>
+            </a:r>
+          </a:p>
+        </p:txBody>
+      </p:sp>
+      <p:sp>
+        <p:nvSpPr>
+          <p:cNvPr id="3" name="Refs left 3"/>
+          <p:cNvSpPr txBox="1"/>
+          <p:nvPr/>
+        </p:nvSpPr>
+        <p:spPr>
+          <a:xfrm>
+            <a:off x="457200" y="1280160"/>
+            <a:ext cx="5577840" cy="5029200"/>
+          </a:xfrm>
+          <a:prstGeom prst="rect">
+            <a:avLst/>
+          </a:prstGeom>
+          <a:noFill/>
+          <a:ln>
+            <a:noFill/>
+          </a:ln>
+        </p:spPr>
+        <p:txBody>
+          <a:bodyPr wrap="square" lIns="109728" tIns="76810" rIns="109728" bIns="76810" rtlCol="0" anchor="t">
+            <a:noAutofit/>
+          </a:bodyPr>
+          <a:lstStyle/>
+          <a:p>
+            <a:pPr marL="0" indent="0" algn="l">
+              <a:lnSpc>
+                <a:spcPct val="100000"/>
+              </a:lnSpc>
+              <a:spcBef>
+                <a:spcPts val="500"/>
+              </a:spcBef>
+              <a:spcAft>
+                <a:spcPts val="0"/>
+              </a:spcAft>
+              <a:buNone/>
+            </a:pPr>
+            <a:r>
+              <a:rPr lang="en-IN" sz="1200" dirty="0">
+                <a:solidFill>
+                  <a:srgbClr val="1F2328"/>
+                </a:solidFill>
+                <a:latin typeface="Times New Roman" panose="02020603050405020304" pitchFamily="18" charset="0"/>
+                <a:cs typeface="Times New Roman" panose="02020603050405020304" pitchFamily="18" charset="0"/>
+              </a:rPr>
+              <a:t>[1] W. M. P. van der Aalst, "Object-centric process mining: Dealing with divergence and convergence in event data," in SEFM, LNCS, Springer, 2019, pp. 3-25.</a:t>
+            </a:r>
+          </a:p>
+          <a:p>
+            <a:pPr marL="0" indent="0" algn="l">
+              <a:lnSpc>
+                <a:spcPct val="100000"/>
+              </a:lnSpc>
+              <a:spcBef>
+                <a:spcPts val="500"/>
+              </a:spcBef>
+              <a:spcAft>
+                <a:spcPts val="0"/>
+              </a:spcAft>
+              <a:buNone/>
+            </a:pPr>
+            <a:r>
+              <a:rPr lang="en-IN" sz="1200" dirty="0">
+                <a:solidFill>
+                  <a:srgbClr val="1F2328"/>
+                </a:solidFill>
+                <a:latin typeface="Times New Roman" panose="02020603050405020304" pitchFamily="18" charset="0"/>
+                <a:cs typeface="Times New Roman" panose="02020603050405020304" pitchFamily="18" charset="0"/>
+              </a:rPr>
+              <a:t>[2] A. Berti et al., "OCEL (Object-Centric Event Log) 2.0 specification," arXiv:2403.01975, 2024.</a:t>
+            </a:r>
+          </a:p>
+          <a:p>
+            <a:pPr marL="0" indent="0" algn="l">
+              <a:lnSpc>
+                <a:spcPct val="100000"/>
+              </a:lnSpc>
+              <a:spcBef>
+                <a:spcPts val="500"/>
+              </a:spcBef>
+              <a:spcAft>
+                <a:spcPts val="0"/>
+              </a:spcAft>
+              <a:buNone/>
+            </a:pPr>
+            <a:r>
+              <a:rPr lang="en-IN" sz="1200" dirty="0">
+                <a:solidFill>
+                  <a:srgbClr val="1F2328"/>
+                </a:solidFill>
+                <a:latin typeface="Times New Roman" panose="02020603050405020304" pitchFamily="18" charset="0"/>
+                <a:cs typeface="Times New Roman" panose="02020603050405020304" pitchFamily="18" charset="0"/>
+              </a:rPr>
+              <a:t>[3] J. N. Adams, G. Park, and W. M. P. van der Aalst, "Preserving complex object-centric graph structures to improve machine learning tasks in process mining," Eng. Appl. Artif. Intell., vol. 125, p. 106764, 2023.</a:t>
+            </a:r>
+          </a:p>
+          <a:p>
+            <a:pPr marL="0" indent="0" algn="l">
+              <a:lnSpc>
+                <a:spcPct val="100000"/>
+              </a:lnSpc>
+              <a:spcBef>
+                <a:spcPts val="500"/>
+              </a:spcBef>
+              <a:spcAft>
+                <a:spcPts val="0"/>
+              </a:spcAft>
+              <a:buNone/>
+            </a:pPr>
+            <a:r>
+              <a:rPr lang="en-IN" sz="1200" dirty="0">
+                <a:solidFill>
+                  <a:srgbClr val="1F2328"/>
+                </a:solidFill>
+                <a:latin typeface="Times New Roman" panose="02020603050405020304" pitchFamily="18" charset="0"/>
+                <a:cs typeface="Times New Roman" panose="02020603050405020304" pitchFamily="18" charset="0"/>
+              </a:rPr>
+              <a:t>[4] J. N. Adams and W. M. P. van der Aalst, "Addressing convergence, divergence, and deficiency issues," LNBIP, Springer, 2024.</a:t>
+            </a:r>
+          </a:p>
+          <a:p>
+            <a:pPr marL="0" indent="0" algn="l">
+              <a:lnSpc>
+                <a:spcPct val="100000"/>
+              </a:lnSpc>
+              <a:spcBef>
+                <a:spcPts val="500"/>
+              </a:spcBef>
+              <a:spcAft>
+                <a:spcPts val="0"/>
+              </a:spcAft>
+              <a:buNone/>
+            </a:pPr>
+            <a:r>
+              <a:rPr lang="en-IN" sz="1200" dirty="0">
+                <a:solidFill>
+                  <a:srgbClr val="1F2328"/>
+                </a:solidFill>
+                <a:latin typeface="Times New Roman" panose="02020603050405020304" pitchFamily="18" charset="0"/>
+                <a:cs typeface="Times New Roman" panose="02020603050405020304" pitchFamily="18" charset="0"/>
+              </a:rPr>
+              <a:t>[5] P. Waibel, L. Pfahlsberger, K. Revoredo, and J. Mendling, "Causal process mining from relational databases with domain knowledge," arXiv:2202.08314, 2022.</a:t>
+            </a:r>
+          </a:p>
+          <a:p>
+            <a:pPr marL="0" indent="0" algn="l">
+              <a:lnSpc>
+                <a:spcPct val="100000"/>
+              </a:lnSpc>
+              <a:spcBef>
+                <a:spcPts val="500"/>
+              </a:spcBef>
+              <a:spcAft>
+                <a:spcPts val="0"/>
+              </a:spcAft>
+              <a:buNone/>
+            </a:pPr>
+            <a:r>
+              <a:rPr lang="en-IN" sz="1200" dirty="0">
+                <a:solidFill>
+                  <a:srgbClr val="1F2328"/>
+                </a:solidFill>
+                <a:latin typeface="Times New Roman" panose="02020603050405020304" pitchFamily="18" charset="0"/>
+                <a:cs typeface="Times New Roman" panose="02020603050405020304" pitchFamily="18" charset="0"/>
+              </a:rPr>
+              <a:t>[6] M. Kabierski et al., "Data quality in object-centric event data: Issues classification and evaluation," Process Science, vol. 3, 2026.</a:t>
+            </a:r>
+          </a:p>
+          <a:p>
+            <a:pPr marL="0" indent="0" algn="l">
+              <a:lnSpc>
+                <a:spcPct val="100000"/>
+              </a:lnSpc>
+              <a:spcBef>
+                <a:spcPts val="500"/>
+              </a:spcBef>
+              <a:spcAft>
+                <a:spcPts val="0"/>
+              </a:spcAft>
+              <a:buNone/>
+            </a:pPr>
+            <a:r>
+              <a:rPr lang="en-IN" sz="1200" dirty="0">
+                <a:solidFill>
+                  <a:srgbClr val="1F2328"/>
+                </a:solidFill>
+                <a:latin typeface="Times New Roman" panose="02020603050405020304" pitchFamily="18" charset="0"/>
+                <a:cs typeface="Times New Roman" panose="02020603050405020304" pitchFamily="18" charset="0"/>
+              </a:rPr>
+              <a:t>[7] N. Miri, S. Khayatbashi, J. Zdravkovic, and A. Jalali, "An object-centric approach to multi-entity educational process mining," Decis. Anal. J., vol. 19, p. 100724, 2026.</a:t>
+            </a:r>
+          </a:p>
+          <a:p>
+            <a:pPr marL="0" indent="0" algn="l">
+              <a:lnSpc>
+                <a:spcPct val="100000"/>
+              </a:lnSpc>
+              <a:spcBef>
+                <a:spcPts val="500"/>
+              </a:spcBef>
+              <a:spcAft>
+                <a:spcPts val="0"/>
+              </a:spcAft>
+              <a:buNone/>
+            </a:pPr>
+            <a:r>
+              <a:rPr lang="en-IN" sz="1200" dirty="0">
+                <a:solidFill>
+                  <a:srgbClr val="1F2328"/>
+                </a:solidFill>
+                <a:latin typeface="Times New Roman" panose="02020603050405020304" pitchFamily="18" charset="0"/>
+                <a:cs typeface="Times New Roman" panose="02020603050405020304" pitchFamily="18" charset="0"/>
+              </a:rPr>
+              <a:t>[8] J. Kuzilek, M. Hlosta, and Z. Zdrahal, "Open University Learning Analytics dataset," Sci. Data, vol. 4, p. 170171, 2017.</a:t>
+            </a:r>
+          </a:p>
+        </p:txBody>
+      </p:sp>
+      <p:sp>
+        <p:nvSpPr>
+          <p:cNvPr id="4" name="Refs right 4"/>
+          <p:cNvSpPr txBox="1"/>
+          <p:nvPr/>
+        </p:nvSpPr>
+        <p:spPr>
+          <a:xfrm>
+            <a:off x="6172200" y="1280160"/>
+            <a:ext cx="5577840" cy="5029200"/>
+          </a:xfrm>
+          <a:prstGeom prst="rect">
+            <a:avLst/>
+          </a:prstGeom>
+          <a:noFill/>
+          <a:ln>
+            <a:noFill/>
+          </a:ln>
+        </p:spPr>
+        <p:txBody>
+          <a:bodyPr wrap="square" lIns="109728" tIns="76810" rIns="109728" bIns="76810" rtlCol="0" anchor="t">
+            <a:noAutofit/>
+          </a:bodyPr>
+          <a:lstStyle/>
+          <a:p>
+            <a:pPr marL="0" indent="0" algn="l">
+              <a:lnSpc>
+                <a:spcPct val="100000"/>
+              </a:lnSpc>
+              <a:spcBef>
+                <a:spcPts val="500"/>
+              </a:spcBef>
+              <a:spcAft>
+                <a:spcPts val="0"/>
+              </a:spcAft>
+              <a:buNone/>
+            </a:pPr>
+            <a:r>
+              <a:rPr lang="en-IN" sz="1200" dirty="0">
+                <a:solidFill>
+                  <a:srgbClr val="1F2328"/>
+                </a:solidFill>
+                <a:latin typeface="Times New Roman" panose="02020603050405020304" pitchFamily="18" charset="0"/>
+                <a:cs typeface="Times New Roman" panose="02020603050405020304" pitchFamily="18" charset="0"/>
+              </a:rPr>
+              <a:t>[9] M. Paixao, J. Krinke, D. Han, and M. Harman, "CROP: Linking code reviews to source code changes," in Proc. MSR, 2018.</a:t>
+            </a:r>
+          </a:p>
+          <a:p>
+            <a:pPr marL="0" indent="0" algn="l">
+              <a:lnSpc>
+                <a:spcPct val="100000"/>
+              </a:lnSpc>
+              <a:spcBef>
+                <a:spcPts val="500"/>
+              </a:spcBef>
+              <a:spcAft>
+                <a:spcPts val="0"/>
+              </a:spcAft>
+              <a:buNone/>
+            </a:pPr>
+            <a:r>
+              <a:rPr lang="en-IN" sz="1200" dirty="0">
+                <a:solidFill>
+                  <a:srgbClr val="1F2328"/>
+                </a:solidFill>
+                <a:latin typeface="Times New Roman" panose="02020603050405020304" pitchFamily="18" charset="0"/>
+                <a:cs typeface="Times New Roman" panose="02020603050405020304" pitchFamily="18" charset="0"/>
+              </a:rPr>
+              <a:t>[10] H. Hassani et al., "Supervision of undergraduate final year projects in computing: A case study," Educ. Sci., vol. 8, no. 4, p. 210, 2018.</a:t>
+            </a:r>
+          </a:p>
+          <a:p>
+            <a:pPr marL="0" indent="0" algn="l">
+              <a:lnSpc>
+                <a:spcPct val="100000"/>
+              </a:lnSpc>
+              <a:spcBef>
+                <a:spcPts val="500"/>
+              </a:spcBef>
+              <a:spcAft>
+                <a:spcPts val="0"/>
+              </a:spcAft>
+              <a:buNone/>
+            </a:pPr>
+            <a:r>
+              <a:rPr lang="en-IN" sz="1200" dirty="0">
+                <a:solidFill>
+                  <a:srgbClr val="1F2328"/>
+                </a:solidFill>
+                <a:latin typeface="Times New Roman" panose="02020603050405020304" pitchFamily="18" charset="0"/>
+                <a:cs typeface="Times New Roman" panose="02020603050405020304" pitchFamily="18" charset="0"/>
+              </a:rPr>
+              <a:t>[11] W. Premchaiswadi and P. Porouhan, "Process modeling and bottleneck mining in online peer-review systems," SpringerPlus, vol. 4, p. 441, 2015.</a:t>
+            </a:r>
+          </a:p>
+          <a:p>
+            <a:pPr marL="0" indent="0" algn="l">
+              <a:lnSpc>
+                <a:spcPct val="100000"/>
+              </a:lnSpc>
+              <a:spcBef>
+                <a:spcPts val="500"/>
+              </a:spcBef>
+              <a:spcAft>
+                <a:spcPts val="0"/>
+              </a:spcAft>
+              <a:buNone/>
+            </a:pPr>
+            <a:r>
+              <a:rPr lang="en-IN" sz="1200" dirty="0">
+                <a:solidFill>
+                  <a:srgbClr val="1F2328"/>
+                </a:solidFill>
+                <a:latin typeface="Times New Roman" panose="02020603050405020304" pitchFamily="18" charset="0"/>
+                <a:cs typeface="Times New Roman" panose="02020603050405020304" pitchFamily="18" charset="0"/>
+              </a:rPr>
+              <a:t>[12] S. J. J. Leemans, D. Fahland, and W. M. P. van der Aalst, "Discovering block-structured process models from event logs containing infrequent behaviour," in BPM Workshops, LNBIP 171, Springer, 2014, pp. 66-78.</a:t>
+            </a:r>
+          </a:p>
+          <a:p>
+            <a:pPr marL="0" indent="0" algn="l">
+              <a:lnSpc>
+                <a:spcPct val="100000"/>
+              </a:lnSpc>
+              <a:spcBef>
+                <a:spcPts val="500"/>
+              </a:spcBef>
+              <a:spcAft>
+                <a:spcPts val="0"/>
+              </a:spcAft>
+              <a:buNone/>
+            </a:pPr>
+            <a:r>
+              <a:rPr lang="en-IN" sz="1200" dirty="0">
+                <a:solidFill>
+                  <a:srgbClr val="1F2328"/>
+                </a:solidFill>
+                <a:latin typeface="Times New Roman" panose="02020603050405020304" pitchFamily="18" charset="0"/>
+                <a:cs typeface="Times New Roman" panose="02020603050405020304" pitchFamily="18" charset="0"/>
+              </a:rPr>
+              <a:t>[13] A. Berti and W. M. P. van der Aalst, "Reviving token-based replay: Increasing speed while improving diagnostics," in ATAED, CEUR-WS 2371, 2019, pp. 87-103.</a:t>
+            </a:r>
+          </a:p>
+          <a:p>
+            <a:pPr marL="0" indent="0" algn="l">
+              <a:lnSpc>
+                <a:spcPct val="100000"/>
+              </a:lnSpc>
+              <a:spcBef>
+                <a:spcPts val="500"/>
+              </a:spcBef>
+              <a:spcAft>
+                <a:spcPts val="0"/>
+              </a:spcAft>
+              <a:buNone/>
+            </a:pPr>
+            <a:r>
+              <a:rPr lang="en-IN" sz="1200" dirty="0">
+                <a:solidFill>
+                  <a:srgbClr val="1F2328"/>
+                </a:solidFill>
+                <a:latin typeface="Times New Roman" panose="02020603050405020304" pitchFamily="18" charset="0"/>
+                <a:cs typeface="Times New Roman" panose="02020603050405020304" pitchFamily="18" charset="0"/>
+              </a:rPr>
+              <a:t>[14] J. Munoz-Gama and J. Carmona, "A fresh look at precision in process conformance," in BPM, LNCS 6336, Springer, 2010, pp. 211-226.</a:t>
+            </a:r>
+          </a:p>
+          <a:p>
+            <a:pPr marL="0" indent="0" algn="l">
+              <a:lnSpc>
+                <a:spcPct val="100000"/>
+              </a:lnSpc>
+              <a:spcBef>
+                <a:spcPts val="500"/>
+              </a:spcBef>
+              <a:spcAft>
+                <a:spcPts val="0"/>
+              </a:spcAft>
+              <a:buNone/>
+            </a:pPr>
+            <a:r>
+              <a:rPr lang="en-IN" sz="1200" dirty="0">
+                <a:solidFill>
+                  <a:srgbClr val="1F2328"/>
+                </a:solidFill>
+                <a:latin typeface="Times New Roman" panose="02020603050405020304" pitchFamily="18" charset="0"/>
+                <a:cs typeface="Times New Roman" panose="02020603050405020304" pitchFamily="18" charset="0"/>
+              </a:rPr>
+              <a:t>[15] A. Berti, S. van Zelst, and D. Schuster, "PM4Py: A process mining library for Python," Softw. Impacts, vol. 17, p. 100556, 2023.</a:t>
+            </a:r>
+          </a:p>
+          <a:p>
+            <a:pPr marL="0" indent="0" algn="l">
+              <a:lnSpc>
+                <a:spcPct val="100000"/>
+              </a:lnSpc>
+              <a:spcBef>
+                <a:spcPts val="500"/>
+              </a:spcBef>
+              <a:spcAft>
+                <a:spcPts val="0"/>
+              </a:spcAft>
+              <a:buNone/>
+            </a:pPr>
+            <a:r>
+              <a:rPr lang="en-IN" sz="1200" dirty="0">
+                <a:solidFill>
+                  <a:srgbClr val="1F2328"/>
+                </a:solidFill>
+                <a:latin typeface="Times New Roman" panose="02020603050405020304" pitchFamily="18" charset="0"/>
+                <a:cs typeface="Times New Roman" panose="02020603050405020304" pitchFamily="18" charset="0"/>
+              </a:rPr>
+              <a:t>[16] Datasets (CC BY 4.0): Zenodo 16811928 (Bundestag), 21989732 (Enron), 21989580 (Ethereum), 13365584 (Age of Empires), 8430332 (Angular), 3599150 (CROP); UCI 10.24432/C5KK69 (OULAD).</a:t>
+            </a:r>
+          </a:p>
+        </p:txBody>
+      </p:sp>
+      <p:sp>
+        <p:nvSpPr>
+          <p:cNvPr id="5" name="Date Placeholder"/>
+          <p:cNvSpPr>
+            <a:spLocks noGrp="1"/>
+          </p:cNvSpPr>
+          <p:nvPr>
+            <p:ph type="dt" sz="half" idx="10"/>
+          </p:nvPr>
+        </p:nvSpPr>
+        <p:spPr/>
+        <p:txBody>
+          <a:bodyPr/>
+          <a:lstStyle/>
+          <a:p>
+            <a:fld id="{61736562-4E3F-4038-A291-A7AE35CC3E6A}" type="datetime1">
+              <a:rPr lang="en-IN" smtClean="0"/>
+              <a:t>28/10/26</a:t>
+            </a:fld>
+            <a:endParaRPr lang="en-IN"/>
+          </a:p>
+        </p:txBody>
+      </p:sp>
+      <p:sp>
+        <p:nvSpPr>
+          <p:cNvPr id="6" name="Footer Placeholder"/>
+          <p:cNvSpPr>
+            <a:spLocks noGrp="1"/>
+          </p:cNvSpPr>
+          <p:nvPr>
+            <p:ph type="ftr" sz="quarter" idx="11"/>
+          </p:nvPr>
+        </p:nvSpPr>
+        <p:spPr/>
+        <p:txBody>
+          <a:bodyPr/>
+          <a:lstStyle/>
+          <a:p>
+            <a:r>
+              <a:rPr lang="en-IN"/>
+              <a:t>SCOPE</a:t>
+            </a:r>
+          </a:p>
+        </p:txBody>
+      </p:sp>
+      <p:sp>
+        <p:nvSpPr>
+          <p:cNvPr id="7" name="Slide Number Placeholder"/>
+          <p:cNvSpPr>
+            <a:spLocks noGrp="1"/>
+          </p:cNvSpPr>
+          <p:nvPr>
+            <p:ph type="sldNum" sz="quarter" idx="12"/>
+          </p:nvPr>
+        </p:nvSpPr>
+        <p:spPr/>
+        <p:txBody>
+          <a:bodyPr/>
+          <a:lstStyle/>
+          <a:p>
+            <a:fld id="{65201FD4-9D8D-4491-815B-63C7BF4F0034}" type="slidenum">
+              <a:rPr lang="en-IN" smtClean="0"/>
+              <a:t>20</a:t>
             </a:fld>
             <a:endParaRPr lang="en-IN"/>
           </a:p>
@@ -13902,7 +14574,7 @@
                 <a:latin typeface="Times New Roman" panose="02020603050405020304" pitchFamily="18" charset="0"/>
                 <a:cs typeface="Times New Roman" panose="02020603050405020304" pitchFamily="18" charset="0"/>
               </a:rPr>
-              <a:t>Duplication from flattening turned out to be small except in fan-out logs. The larger effect is narrowing: one case notion shows only a slice of the process. Every number is re-computed by open code and checked by independent implementations.</a:t>
+              <a:t>Duplication from flattening turned out to be small except in fan-out logs. The larger effect is narrowing: one case notion shows only a slice of the process, and a model mined from that slice still scores a near-perfect fitness, so nothing warns the analyst. Every number is re-computed by open code, carries a bootstrap interval and is checked by independent implementations.</a:t>
             </a:r>
           </a:p>
         </p:txBody>
@@ -18068,7 +18740,7 @@
                 <a:latin typeface="Times New Roman" panose="02020603050405020304" pitchFamily="18" charset="0"/>
                 <a:cs typeface="Times New Roman" panose="02020603050405020304" pitchFamily="18" charset="0"/>
               </a:rPr>
-              <a:t>Compare standard outputs (rankings, directly-follows, variants, entity counts) between flat and object-centric views.</a:t>
+              <a:t>Compare standard outputs (rankings, directly-follows, variants, entity counts, discovered models) between flat and object-centric views.</a:t>
             </a:r>
           </a:p>
           <a:p>
@@ -18577,7 +19249,7 @@
                 <a:latin typeface="Times New Roman" panose="02020603050405020304" pitchFamily="18" charset="0"/>
                 <a:cs typeface="Times New Roman" panose="02020603050405020304" pitchFamily="18" charset="0"/>
               </a:rPr>
-              <a:t>Journal paper (Scopus): manuscript in preparation, not yet submitted</a:t>
+              <a:t>Journal paper (Scopus, SCIE): submitted to JIIS, Springer; under review</a:t>
             </a:r>
           </a:p>
           <a:p>

</xml_diff>

<commit_message>
Final discovery results; humanised report and paper text
- Re-mined AoE2 and Angular with the raised recursion limit: 37 of 38 case
  notions now mine (Angular branches still exceeds the one-hour budget)
- Paper: corrected humanised wording, abstract 248 words, Table 4 and
  discovery text updated; loop-share figure for the lowest-precision models
  corrected to 94%
- Report: reworded body paragraphs applied from report_humanised.json at build
  time; front matter, references and appendix unchanged
- Report and deck regenerated with final numbers; make study re-timed (6 min 6 s)

Co-Authored-By: Claude Opus 5.5 <noreply@anthropic.com>
</commit_message>
<xml_diff>
--- a/docs/review-3/Team1_Review3_OCEL.pptx
+++ b/docs/review-3/Team1_Review3_OCEL.pptx
@@ -8775,7 +8775,7 @@
                 <a:latin typeface="Times New Roman" panose="02020603050405020304" pitchFamily="18" charset="0"/>
                 <a:cs typeface="Times New Roman" panose="02020603050405020304" pitchFamily="18" charset="0"/>
               </a:rPr>
-              <a:t>Full run: make study (5 min 21 s on our laptop)</a:t>
+              <a:t>Full run: make study (6 min 6 s on our laptop)</a:t>
             </a:r>
           </a:p>
         </p:txBody>
@@ -9663,7 +9663,7 @@
                 <a:latin typeface="Times New Roman" panose="02020603050405020304" pitchFamily="18" charset="0"/>
                 <a:cs typeface="Times New Roman" panose="02020603050405020304" pitchFamily="18" charset="0"/>
               </a:rPr>
-              <a:t>35 of 38 </a:t>
+              <a:t>37 of 38 </a:t>
             </a:r>
             <a:r>
               <a:rPr lang="en-IN" sz="1500" dirty="0">
@@ -9743,7 +9743,7 @@
                 <a:latin typeface="Times New Roman" panose="02020603050405020304" pitchFamily="18" charset="0"/>
                 <a:cs typeface="Times New Roman" panose="02020603050405020304" pitchFamily="18" charset="0"/>
               </a:rPr>
-              <a:t>loop share rises with divergence (rho 0.66)</a:t>
+              <a:t>loop share rises with divergence (rho 0.69)</a:t>
             </a:r>
           </a:p>
           <a:p>

</xml_diff>

<commit_message>
Rewrite research gaps in the Review 3 deck and report
The three gaps now come from the cited literature and each maps to what the
project delivers: flattening is described but not measured across real logs;
its effect on analyst outputs is unknown; review workflows have no
object-centric model. Missing portal logs are treated as a limitation.

Co-Authored-By: Claude Opus 5.5 <noreply@anthropic.com>
</commit_message>
<xml_diff>
--- a/docs/review-3/Team1_Review3_OCEL.pptx
+++ b/docs/review-3/Team1_Review3_OCEL.pptx
@@ -1533,7 +1533,7 @@
           <a:p>
             <a:r>
               <a:rPr lang="en-IN" dirty="0"/>
-              <a:t>So where is the gap? Number one: everyone agrees flattening is a problem, but we could not find a study that counts it across several real logs. Most of the evidence is simulated or one company's case. Number two: in education, object-centric work is about Moodle clicks. A capstone is different, it is a chain of submit, review, reject, resubmit, score. And number three, the awkward one: nobody publishes capstone portal logs. We searched. So we cannot prove anything about the portal itself. What we can do is measure the effect on real logs that look like it, and be upfront about that limit.</a:t>
+              <a:t>So where exactly is the gap? Three places. One: the problems of flattening have names, convergence, divergence and deficiency, and they are explained in theory and in single case studies. But nobody has counted how often they happen across several real logs. That is the first thing we do: 38 case notions on seven real logs. Two: even where people discuss flattening, they look at machine-learning accuracy or list data-quality issues. Nobody checks what an analyst actually reads off the screen, the activity ranking, the process paths, the discovered model. And nobody separates duplication, which you can fix, from narrowing, which you cannot. That is our consequence analysis, C1 to C5. Three: object-centric work in education looks at Moodle clicks, and review processes have only been mined with one case notion. A capstone is a chain of submit, review, reject, resubmit and score. We give it an OCEL 2.0 model, and we measure on real logs that have that review shape.</a:t>
             </a:r>
           </a:p>
         </p:txBody>
@@ -18044,7 +18044,7 @@
         </p:nvSpPr>
         <p:spPr>
           <a:xfrm>
-            <a:off x="457200" y="1463040"/>
+            <a:off x="457200" y="1490472"/>
             <a:ext cx="685800" cy="685800"/>
           </a:xfrm>
           <a:prstGeom prst="ellipse">
@@ -18096,8 +18096,8 @@
         </p:nvSpPr>
         <p:spPr>
           <a:xfrm>
-            <a:off x="1371600" y="1371600"/>
-            <a:ext cx="10332720" cy="1188720"/>
+            <a:off x="1371600" y="1325880"/>
+            <a:ext cx="10332720" cy="1261872"/>
           </a:xfrm>
           <a:prstGeom prst="roundRect">
             <a:avLst>
@@ -18112,10 +18112,34 @@
           </a:ln>
         </p:spPr>
         <p:txBody>
-          <a:bodyPr wrap="square" lIns="182880" tIns="128016" rIns="182880" bIns="128016" rtlCol="0" anchor="ctr">
+          <a:bodyPr wrap="square" lIns="146304" tIns="102413" rIns="146304" bIns="102413" rtlCol="0" anchor="ctr">
             <a:noAutofit/>
           </a:bodyPr>
           <a:lstStyle/>
+          <a:p>
+            <a:pPr marL="0" indent="0" algn="l">
+              <a:lnSpc>
+                <a:spcPct val="100000"/>
+              </a:lnSpc>
+              <a:spcBef>
+                <a:spcPts val="0"/>
+              </a:spcBef>
+              <a:spcAft>
+                <a:spcPts val="200"/>
+              </a:spcAft>
+              <a:buNone/>
+            </a:pPr>
+            <a:r>
+              <a:rPr lang="en-IN" sz="1800" b="1" dirty="0">
+                <a:solidFill>
+                  <a:srgbClr val="1F2328"/>
+                </a:solidFill>
+                <a:latin typeface="Times New Roman" panose="02020603050405020304" pitchFamily="18" charset="0"/>
+                <a:cs typeface="Times New Roman" panose="02020603050405020304" pitchFamily="18" charset="0"/>
+              </a:rPr>
+              <a:t>Flattening is described, but not measured</a:t>
+            </a:r>
+          </a:p>
           <a:p>
             <a:pPr marL="0" indent="0" algn="l">
               <a:lnSpc>
@@ -18130,14 +18154,14 @@
               <a:buNone/>
             </a:pPr>
             <a:r>
-              <a:rPr lang="en-IN" sz="1900" b="1" dirty="0">
+              <a:rPr lang="en-IN" sz="1300" dirty="0">
                 <a:solidFill>
-                  <a:srgbClr val="1F2328"/>
+                  <a:srgbClr val="5B616B"/>
                 </a:solidFill>
                 <a:latin typeface="Times New Roman" panose="02020603050405020304" pitchFamily="18" charset="0"/>
                 <a:cs typeface="Times New Roman" panose="02020603050405020304" pitchFamily="18" charset="0"/>
               </a:rPr>
-              <a:t>Flattening problems are named, but not measured</a:t>
+              <a:t>Convergence, divergence and deficiency are defined conceptually [1, 4] and shown on single case studies [5]. No study reports how often they occur across several real logs from different domains.</a:t>
             </a:r>
           </a:p>
           <a:p>
@@ -18154,14 +18178,24 @@
               <a:buNone/>
             </a:pPr>
             <a:r>
-              <a:rPr lang="en-IN" sz="1500" dirty="0">
+              <a:rPr lang="en-IN" sz="1300" b="1" dirty="0">
                 <a:solidFill>
-                  <a:srgbClr val="5B616B"/>
+                  <a:srgbClr val="2A78D6"/>
                 </a:solidFill>
                 <a:latin typeface="Times New Roman" panose="02020603050405020304" pitchFamily="18" charset="0"/>
                 <a:cs typeface="Times New Roman" panose="02020603050405020304" pitchFamily="18" charset="0"/>
               </a:rPr>
-              <a:t>Convergence and divergence appear as toy or single-case examples. We found no study that reports how often or how badly they occur across several real logs. Most object-centric evidence uses simulated logs.</a:t>
+              <a:t>Addressed by: </a:t>
+            </a:r>
+            <a:r>
+              <a:rPr lang="en-IN" sz="1300" dirty="0">
+                <a:solidFill>
+                  <a:srgbClr val="1F2328"/>
+                </a:solidFill>
+                <a:latin typeface="Times New Roman" panose="02020603050405020304" pitchFamily="18" charset="0"/>
+                <a:cs typeface="Times New Roman" panose="02020603050405020304" pitchFamily="18" charset="0"/>
+              </a:rPr>
+              <a:t>Distortion metrics for 38 case notions on 7 real public logs; three regimes</a:t>
             </a:r>
           </a:p>
         </p:txBody>
@@ -18174,7 +18208,7 @@
         </p:nvSpPr>
         <p:spPr>
           <a:xfrm>
-            <a:off x="457200" y="2788920"/>
+            <a:off x="457200" y="2862072"/>
             <a:ext cx="685800" cy="685800"/>
           </a:xfrm>
           <a:prstGeom prst="ellipse">
@@ -18227,7 +18261,7 @@
         <p:spPr>
           <a:xfrm>
             <a:off x="1371600" y="2697480"/>
-            <a:ext cx="10332720" cy="1188720"/>
+            <a:ext cx="10332720" cy="1261872"/>
           </a:xfrm>
           <a:prstGeom prst="roundRect">
             <a:avLst>
@@ -18242,10 +18276,34 @@
           </a:ln>
         </p:spPr>
         <p:txBody>
-          <a:bodyPr wrap="square" lIns="182880" tIns="128016" rIns="182880" bIns="128016" rtlCol="0" anchor="ctr">
+          <a:bodyPr wrap="square" lIns="146304" tIns="102413" rIns="146304" bIns="102413" rtlCol="0" anchor="ctr">
             <a:noAutofit/>
           </a:bodyPr>
           <a:lstStyle/>
+          <a:p>
+            <a:pPr marL="0" indent="0" algn="l">
+              <a:lnSpc>
+                <a:spcPct val="100000"/>
+              </a:lnSpc>
+              <a:spcBef>
+                <a:spcPts val="0"/>
+              </a:spcBef>
+              <a:spcAft>
+                <a:spcPts val="200"/>
+              </a:spcAft>
+              <a:buNone/>
+            </a:pPr>
+            <a:r>
+              <a:rPr lang="en-IN" sz="1800" b="1" dirty="0">
+                <a:solidFill>
+                  <a:srgbClr val="1F2328"/>
+                </a:solidFill>
+                <a:latin typeface="Times New Roman" panose="02020603050405020304" pitchFamily="18" charset="0"/>
+                <a:cs typeface="Times New Roman" panose="02020603050405020304" pitchFamily="18" charset="0"/>
+              </a:rPr>
+              <a:t>Its effect on what an analyst reads is unknown</a:t>
+            </a:r>
+          </a:p>
           <a:p>
             <a:pPr marL="0" indent="0" algn="l">
               <a:lnSpc>
@@ -18260,14 +18318,14 @@
               <a:buNone/>
             </a:pPr>
             <a:r>
-              <a:rPr lang="en-IN" sz="1900" b="1" dirty="0">
+              <a:rPr lang="en-IN" sz="1300" dirty="0">
                 <a:solidFill>
-                  <a:srgbClr val="1F2328"/>
+                  <a:srgbClr val="5B616B"/>
                 </a:solidFill>
                 <a:latin typeface="Times New Roman" panose="02020603050405020304" pitchFamily="18" charset="0"/>
                 <a:cs typeface="Times New Roman" panose="02020603050405020304" pitchFamily="18" charset="0"/>
               </a:rPr>
-              <a:t>Education and capstone work stays on LMS data</a:t>
+              <a:t>Prior work compares machine-learning performance [3] or classifies data-quality issues [6]. None measures, across logs, whether flattening changes rankings, process paths or discovered models, or separates fixable duplication from unfixable narrowing.</a:t>
             </a:r>
           </a:p>
           <a:p>
@@ -18284,14 +18342,24 @@
               <a:buNone/>
             </a:pPr>
             <a:r>
-              <a:rPr lang="en-IN" sz="1500" dirty="0">
+              <a:rPr lang="en-IN" sz="1300" b="1" dirty="0">
                 <a:solidFill>
-                  <a:srgbClr val="5B616B"/>
+                  <a:srgbClr val="EB6834"/>
                 </a:solidFill>
                 <a:latin typeface="Times New Roman" panose="02020603050405020304" pitchFamily="18" charset="0"/>
                 <a:cs typeface="Times New Roman" panose="02020603050405020304" pitchFamily="18" charset="0"/>
               </a:rPr>
-              <a:t>Object-centric educational mining uses Moodle activity. A transactional review lifecycle (submit, review, reject, resubmit, score) has no public object-centric dataset.</a:t>
+              <a:t>Addressed by: </a:t>
+            </a:r>
+            <a:r>
+              <a:rPr lang="en-IN" sz="1300" dirty="0">
+                <a:solidFill>
+                  <a:srgbClr val="1F2328"/>
+                </a:solidFill>
+                <a:latin typeface="Times New Roman" panose="02020603050405020304" pitchFamily="18" charset="0"/>
+                <a:cs typeface="Times New Roman" panose="02020603050405020304" pitchFamily="18" charset="0"/>
+              </a:rPr>
+              <a:t>Five outputs (C1 to C5) compared with an object-centric reference, with bootstrap intervals</a:t>
             </a:r>
           </a:p>
         </p:txBody>
@@ -18304,7 +18372,7 @@
         </p:nvSpPr>
         <p:spPr>
           <a:xfrm>
-            <a:off x="457200" y="4114800"/>
+            <a:off x="457200" y="4233672"/>
             <a:ext cx="685800" cy="685800"/>
           </a:xfrm>
           <a:prstGeom prst="ellipse">
@@ -18356,8 +18424,8 @@
         </p:nvSpPr>
         <p:spPr>
           <a:xfrm>
-            <a:off x="1371600" y="4023360"/>
-            <a:ext cx="10332720" cy="1188720"/>
+            <a:off x="1371600" y="4069080"/>
+            <a:ext cx="10332720" cy="1261872"/>
           </a:xfrm>
           <a:prstGeom prst="roundRect">
             <a:avLst>
@@ -18372,10 +18440,34 @@
           </a:ln>
         </p:spPr>
         <p:txBody>
-          <a:bodyPr wrap="square" lIns="182880" tIns="128016" rIns="182880" bIns="128016" rtlCol="0" anchor="ctr">
+          <a:bodyPr wrap="square" lIns="146304" tIns="102413" rIns="146304" bIns="102413" rtlCol="0" anchor="ctr">
             <a:noAutofit/>
           </a:bodyPr>
           <a:lstStyle/>
+          <a:p>
+            <a:pPr marL="0" indent="0" algn="l">
+              <a:lnSpc>
+                <a:spcPct val="100000"/>
+              </a:lnSpc>
+              <a:spcBef>
+                <a:spcPts val="0"/>
+              </a:spcBef>
+              <a:spcAft>
+                <a:spcPts val="200"/>
+              </a:spcAft>
+              <a:buNone/>
+            </a:pPr>
+            <a:r>
+              <a:rPr lang="en-IN" sz="1800" b="1" dirty="0">
+                <a:solidFill>
+                  <a:srgbClr val="1F2328"/>
+                </a:solidFill>
+                <a:latin typeface="Times New Roman" panose="02020603050405020304" pitchFamily="18" charset="0"/>
+                <a:cs typeface="Times New Roman" panose="02020603050405020304" pitchFamily="18" charset="0"/>
+              </a:rPr>
+              <a:t>Review workflows have no object-centric model</a:t>
+            </a:r>
+          </a:p>
           <a:p>
             <a:pPr marL="0" indent="0" algn="l">
               <a:lnSpc>
@@ -18390,14 +18482,14 @@
               <a:buNone/>
             </a:pPr>
             <a:r>
-              <a:rPr lang="en-IN" sz="1900" b="1" dirty="0">
+              <a:rPr lang="en-IN" sz="1300" dirty="0">
                 <a:solidFill>
-                  <a:srgbClr val="1F2328"/>
+                  <a:srgbClr val="5B616B"/>
                 </a:solidFill>
                 <a:latin typeface="Times New Roman" panose="02020603050405020304" pitchFamily="18" charset="0"/>
                 <a:cs typeface="Times New Roman" panose="02020603050405020304" pitchFamily="18" charset="0"/>
               </a:rPr>
-              <a:t>Capstone portal logs cannot be had</a:t>
+              <a:t>Object-centric educational mining uses learning-platform activity [7], and review processes have been mined with one case notion only [11]. A submit, review, reject, resubmit and score lifecycle has no object-centric model that we could find.</a:t>
             </a:r>
           </a:p>
           <a:p>
@@ -18414,14 +18506,24 @@
               <a:buNone/>
             </a:pPr>
             <a:r>
-              <a:rPr lang="en-IN" sz="1500" dirty="0">
+              <a:rPr lang="en-IN" sz="1300" b="1" dirty="0">
                 <a:solidFill>
-                  <a:srgbClr val="5B616B"/>
+                  <a:srgbClr val="1BAF7A"/>
                 </a:solidFill>
                 <a:latin typeface="Times New Roman" panose="02020603050405020304" pitchFamily="18" charset="0"/>
                 <a:cs typeface="Times New Roman" panose="02020603050405020304" pitchFamily="18" charset="0"/>
               </a:rPr>
-              <a:t>Searches of Zenodo, 4TU and the web found no public capstone or thesis-management event log, so the capstone claim cannot be tested directly.</a:t>
+              <a:t>Addressed by: </a:t>
+            </a:r>
+            <a:r>
+              <a:rPr lang="en-IN" sz="1300" dirty="0">
+                <a:solidFill>
+                  <a:srgbClr val="1F2328"/>
+                </a:solidFill>
+                <a:latin typeface="Times New Roman" panose="02020603050405020304" pitchFamily="18" charset="0"/>
+                <a:cs typeface="Times New Roman" panose="02020603050405020304" pitchFamily="18" charset="0"/>
+              </a:rPr>
+              <a:t>OCEL 2.0 model of the capstone lifecycle, plus real review-like logs (code review, assessment)</a:t>
             </a:r>
           </a:p>
         </p:txBody>
@@ -18434,8 +18536,8 @@
         </p:nvSpPr>
         <p:spPr>
           <a:xfrm>
-            <a:off x="457200" y="5440680"/>
-            <a:ext cx="11274552" cy="640080"/>
+            <a:off x="457200" y="5532120"/>
+            <a:ext cx="11274552" cy="548640"/>
           </a:xfrm>
           <a:prstGeom prst="rect">
             <a:avLst/>
@@ -18481,7 +18583,7 @@
                 <a:latin typeface="Times New Roman" panose="02020603050405020304" pitchFamily="18" charset="0"/>
                 <a:cs typeface="Times New Roman" panose="02020603050405020304" pitchFamily="18" charset="0"/>
               </a:rPr>
-              <a:t>measure on real review-like and multi-entity logs, give the capstone an OCEL 2.0 model, and state the limits plainly.</a:t>
+              <a:t>measure first, on real data only, and check every number with independent code.</a:t>
             </a:r>
           </a:p>
         </p:txBody>

</xml_diff>